<commit_message>
Publish preregistered sequential privacy result
</commit_message>
<xml_diff>
--- a/competition/EraSeMap_RKNP_ISEF_RU.pptx
+++ b/competition/EraSeMap_RKNP_ISEF_RU.pptx
@@ -2,23 +2,23 @@
 <file path=ppt/presentation.xml><?xml version="1.0" encoding="utf-8"?>
 <p:presentation xmlns:p="http://schemas.openxmlformats.org/presentationml/2006/main">
   <p:sldMasterIdLst>
-    <p:sldMasterId xmlns:r="http://schemas.openxmlformats.org/officeDocument/2006/relationships" id="2147483648" r:id="Rd4de7a2425524122"/>
+    <p:sldMasterId xmlns:r="http://schemas.openxmlformats.org/officeDocument/2006/relationships" id="2147483648" r:id="R3dd3c923f25948da"/>
   </p:sldMasterIdLst>
   <p:notesMasterIdLst>
-    <p:notesMasterId xmlns:r="http://schemas.openxmlformats.org/officeDocument/2006/relationships" r:id="Rec10f22a63464104"/>
+    <p:notesMasterId xmlns:r="http://schemas.openxmlformats.org/officeDocument/2006/relationships" r:id="R541015338a994eaa"/>
   </p:notesMasterIdLst>
   <p:sldIdLst>
-    <p:sldId xmlns:r="http://schemas.openxmlformats.org/officeDocument/2006/relationships" id="256" r:id="R2840dbba117c4876"/>
-    <p:sldId xmlns:r="http://schemas.openxmlformats.org/officeDocument/2006/relationships" id="257" r:id="R203324b9fc864075"/>
-    <p:sldId xmlns:r="http://schemas.openxmlformats.org/officeDocument/2006/relationships" id="258" r:id="R7443bdc2adfe47ef"/>
-    <p:sldId xmlns:r="http://schemas.openxmlformats.org/officeDocument/2006/relationships" id="259" r:id="Rd86579aa35dc4d10"/>
-    <p:sldId xmlns:r="http://schemas.openxmlformats.org/officeDocument/2006/relationships" id="260" r:id="R41fd46827d80495f"/>
-    <p:sldId xmlns:r="http://schemas.openxmlformats.org/officeDocument/2006/relationships" id="261" r:id="Re6b29d0ba7db458c"/>
-    <p:sldId xmlns:r="http://schemas.openxmlformats.org/officeDocument/2006/relationships" id="262" r:id="R95671ee7dc0d4bf4"/>
-    <p:sldId xmlns:r="http://schemas.openxmlformats.org/officeDocument/2006/relationships" id="263" r:id="R8cb0b53f953e4468"/>
-    <p:sldId xmlns:r="http://schemas.openxmlformats.org/officeDocument/2006/relationships" id="264" r:id="R8a50f8d56f344320"/>
-    <p:sldId xmlns:r="http://schemas.openxmlformats.org/officeDocument/2006/relationships" id="265" r:id="Re1c66ca2238b4160"/>
-    <p:sldId xmlns:r="http://schemas.openxmlformats.org/officeDocument/2006/relationships" id="266" r:id="Rea01174606204efa"/>
+    <p:sldId xmlns:r="http://schemas.openxmlformats.org/officeDocument/2006/relationships" id="256" r:id="Rc8a63c9932494367"/>
+    <p:sldId xmlns:r="http://schemas.openxmlformats.org/officeDocument/2006/relationships" id="257" r:id="R3cdae93c92a54bcc"/>
+    <p:sldId xmlns:r="http://schemas.openxmlformats.org/officeDocument/2006/relationships" id="258" r:id="R7d77851f41554637"/>
+    <p:sldId xmlns:r="http://schemas.openxmlformats.org/officeDocument/2006/relationships" id="259" r:id="R3985fba6de6544c9"/>
+    <p:sldId xmlns:r="http://schemas.openxmlformats.org/officeDocument/2006/relationships" id="260" r:id="R12ed691edcd24152"/>
+    <p:sldId xmlns:r="http://schemas.openxmlformats.org/officeDocument/2006/relationships" id="261" r:id="Rbe5ebb3f240d4fae"/>
+    <p:sldId xmlns:r="http://schemas.openxmlformats.org/officeDocument/2006/relationships" id="262" r:id="Rc404a70400da47aa"/>
+    <p:sldId xmlns:r="http://schemas.openxmlformats.org/officeDocument/2006/relationships" id="263" r:id="R0d7e8dc796f94006"/>
+    <p:sldId xmlns:r="http://schemas.openxmlformats.org/officeDocument/2006/relationships" id="264" r:id="Rca73acb9bd1542b9"/>
+    <p:sldId xmlns:r="http://schemas.openxmlformats.org/officeDocument/2006/relationships" id="265" r:id="R4fa01144ca0b4fa3"/>
+    <p:sldId xmlns:r="http://schemas.openxmlformats.org/officeDocument/2006/relationships" id="266" r:id="Re5e2326e24a14471"/>
   </p:sldIdLst>
   <p:sldSz cx="12192000" cy="6858000"/>
   <p:notesSz cx="6858000" cy="9144000"/>
@@ -1220,7 +1220,7 @@
   </p:cSld>
   <p:clrMap bg1="lt1" tx1="dk1" bg2="lt2" tx2="dk2" accent1="accent1" accent2="accent2" accent3="accent3" accent4="accent4" accent5="accent5" accent6="accent6" hlink="hlink" folHlink="folHlink"/>
   <p:sldLayoutIdLst>
-    <p:sldLayoutId xmlns:r="http://schemas.openxmlformats.org/officeDocument/2006/relationships" id="2147483649" r:id="Ra49ef039077b4852"/>
+    <p:sldLayoutId xmlns:r="http://schemas.openxmlformats.org/officeDocument/2006/relationships" id="2147483649" r:id="R26510f37b931411c"/>
   </p:sldLayoutIdLst>
   <p:txStyles>
     <p:titleStyle>
@@ -2072,6 +2072,7 @@
           <a:lstStyle xmlns:a="http://schemas.openxmlformats.org/drawingml/2006/main"/>
           <a:p xmlns:a="http://schemas.openxmlformats.org/drawingml/2006/main">
             <a:pPr algn="l">
+              <a:buNone/>
               <a:defRPr sz="1200" b="1">
                 <a:solidFill>
                   <a:srgbClr val="FF6B35"/>
@@ -2112,6 +2113,7 @@
           <a:lstStyle xmlns:a="http://schemas.openxmlformats.org/drawingml/2006/main"/>
           <a:p xmlns:a="http://schemas.openxmlformats.org/drawingml/2006/main">
             <a:pPr algn="l">
+              <a:buNone/>
               <a:defRPr sz="5400" b="1">
                 <a:solidFill>
                   <a:srgbClr val="0B0D10"/>
@@ -2180,6 +2182,7 @@
           <a:lstStyle xmlns:a="http://schemas.openxmlformats.org/drawingml/2006/main"/>
           <a:p xmlns:a="http://schemas.openxmlformats.org/drawingml/2006/main">
             <a:pPr algn="l">
+              <a:buNone/>
               <a:defRPr sz="2325" b="1">
                 <a:solidFill>
                   <a:srgbClr val="0B0D10"/>
@@ -2220,6 +2223,7 @@
           <a:lstStyle xmlns:a="http://schemas.openxmlformats.org/drawingml/2006/main"/>
           <a:p xmlns:a="http://schemas.openxmlformats.org/drawingml/2006/main">
             <a:pPr algn="l">
+              <a:buNone/>
               <a:defRPr sz="1800" b="0">
                 <a:solidFill>
                   <a:srgbClr val="555B63"/>
@@ -2314,6 +2318,7 @@
           <a:lstStyle xmlns:a="http://schemas.openxmlformats.org/drawingml/2006/main"/>
           <a:p xmlns:a="http://schemas.openxmlformats.org/drawingml/2006/main">
             <a:pPr algn="l">
+              <a:buNone/>
               <a:defRPr sz="1650" b="1">
                 <a:solidFill>
                   <a:srgbClr val="0B0D10"/>
@@ -2354,6 +2359,7 @@
           <a:lstStyle xmlns:a="http://schemas.openxmlformats.org/drawingml/2006/main"/>
           <a:p xmlns:a="http://schemas.openxmlformats.org/drawingml/2006/main">
             <a:pPr algn="l">
+              <a:buNone/>
               <a:defRPr sz="1500" b="0">
                 <a:solidFill>
                   <a:srgbClr val="555B63"/>
@@ -2394,6 +2400,7 @@
           <a:lstStyle xmlns:a="http://schemas.openxmlformats.org/drawingml/2006/main"/>
           <a:p xmlns:a="http://schemas.openxmlformats.org/drawingml/2006/main">
             <a:pPr algn="r">
+              <a:buNone/>
               <a:defRPr sz="1125" b="0">
                 <a:solidFill>
                   <a:srgbClr val="555B63"/>
@@ -2463,6 +2470,7 @@
           <a:lstStyle xmlns:a="http://schemas.openxmlformats.org/drawingml/2006/main"/>
           <a:p xmlns:a="http://schemas.openxmlformats.org/drawingml/2006/main">
             <a:pPr algn="l">
+              <a:buNone/>
               <a:defRPr sz="1200" b="1">
                 <a:solidFill>
                   <a:srgbClr val="FF6B35"/>
@@ -2503,6 +2511,7 @@
           <a:lstStyle xmlns:a="http://schemas.openxmlformats.org/drawingml/2006/main"/>
           <a:p xmlns:a="http://schemas.openxmlformats.org/drawingml/2006/main">
             <a:pPr algn="l">
+              <a:buNone/>
               <a:defRPr sz="3375" b="1">
                 <a:solidFill>
                   <a:srgbClr val="0B0D10"/>
@@ -2624,6 +2633,7 @@
           <a:lstStyle xmlns:a="http://schemas.openxmlformats.org/drawingml/2006/main"/>
           <a:p xmlns:a="http://schemas.openxmlformats.org/drawingml/2006/main">
             <a:pPr algn="l">
+              <a:buNone/>
               <a:defRPr sz="4950" b="1">
                 <a:solidFill>
                   <a:srgbClr val="0B0D10"/>
@@ -2664,6 +2674,7 @@
           <a:lstStyle xmlns:a="http://schemas.openxmlformats.org/drawingml/2006/main"/>
           <a:p xmlns:a="http://schemas.openxmlformats.org/drawingml/2006/main">
             <a:pPr algn="l">
+              <a:buNone/>
               <a:defRPr sz="1950" b="1">
                 <a:solidFill>
                   <a:srgbClr val="0B0D10"/>
@@ -2704,6 +2715,7 @@
           <a:lstStyle xmlns:a="http://schemas.openxmlformats.org/drawingml/2006/main"/>
           <a:p xmlns:a="http://schemas.openxmlformats.org/drawingml/2006/main">
             <a:pPr algn="l">
+              <a:buNone/>
               <a:defRPr sz="1500" b="0">
                 <a:solidFill>
                   <a:srgbClr val="0B0D10"/>
@@ -2744,6 +2756,7 @@
           <a:lstStyle xmlns:a="http://schemas.openxmlformats.org/drawingml/2006/main"/>
           <a:p xmlns:a="http://schemas.openxmlformats.org/drawingml/2006/main">
             <a:pPr algn="l">
+              <a:buNone/>
               <a:defRPr sz="4950" b="1">
                 <a:solidFill>
                   <a:srgbClr val="FF6B35"/>
@@ -2784,6 +2797,7 @@
           <a:lstStyle xmlns:a="http://schemas.openxmlformats.org/drawingml/2006/main"/>
           <a:p xmlns:a="http://schemas.openxmlformats.org/drawingml/2006/main">
             <a:pPr algn="l">
+              <a:buNone/>
               <a:defRPr sz="1950" b="1">
                 <a:solidFill>
                   <a:srgbClr val="0B0D10"/>
@@ -2824,6 +2838,7 @@
           <a:lstStyle xmlns:a="http://schemas.openxmlformats.org/drawingml/2006/main"/>
           <a:p xmlns:a="http://schemas.openxmlformats.org/drawingml/2006/main">
             <a:pPr algn="l">
+              <a:buNone/>
               <a:defRPr sz="1500" b="0">
                 <a:solidFill>
                   <a:srgbClr val="0B0D10"/>
@@ -2864,6 +2879,7 @@
           <a:lstStyle xmlns:a="http://schemas.openxmlformats.org/drawingml/2006/main"/>
           <a:p xmlns:a="http://schemas.openxmlformats.org/drawingml/2006/main">
             <a:pPr algn="l">
+              <a:buNone/>
               <a:defRPr sz="4950" b="1">
                 <a:solidFill>
                   <a:srgbClr val="0B0D10"/>
@@ -2904,6 +2920,7 @@
           <a:lstStyle xmlns:a="http://schemas.openxmlformats.org/drawingml/2006/main"/>
           <a:p xmlns:a="http://schemas.openxmlformats.org/drawingml/2006/main">
             <a:pPr algn="l">
+              <a:buNone/>
               <a:defRPr sz="1950" b="1">
                 <a:solidFill>
                   <a:srgbClr val="0B0D10"/>
@@ -2944,6 +2961,7 @@
           <a:lstStyle xmlns:a="http://schemas.openxmlformats.org/drawingml/2006/main"/>
           <a:p xmlns:a="http://schemas.openxmlformats.org/drawingml/2006/main">
             <a:pPr algn="l">
+              <a:buNone/>
               <a:defRPr sz="1500" b="0">
                 <a:solidFill>
                   <a:srgbClr val="0B0D10"/>
@@ -2984,6 +3002,7 @@
           <a:lstStyle xmlns:a="http://schemas.openxmlformats.org/drawingml/2006/main"/>
           <a:p xmlns:a="http://schemas.openxmlformats.org/drawingml/2006/main">
             <a:pPr algn="l">
+              <a:buNone/>
               <a:defRPr sz="1500" b="1">
                 <a:solidFill>
                   <a:srgbClr val="FF6B35"/>
@@ -3024,6 +3043,7 @@
           <a:lstStyle xmlns:a="http://schemas.openxmlformats.org/drawingml/2006/main"/>
           <a:p xmlns:a="http://schemas.openxmlformats.org/drawingml/2006/main">
             <a:pPr algn="r">
+              <a:buNone/>
               <a:defRPr sz="1125" b="0">
                 <a:solidFill>
                   <a:srgbClr val="555B63"/>
@@ -3093,6 +3113,7 @@
           <a:lstStyle xmlns:a="http://schemas.openxmlformats.org/drawingml/2006/main"/>
           <a:p xmlns:a="http://schemas.openxmlformats.org/drawingml/2006/main">
             <a:pPr algn="l">
+              <a:buNone/>
               <a:defRPr sz="1200" b="1">
                 <a:solidFill>
                   <a:srgbClr val="FF6B35"/>
@@ -3133,6 +3154,7 @@
           <a:lstStyle xmlns:a="http://schemas.openxmlformats.org/drawingml/2006/main"/>
           <a:p xmlns:a="http://schemas.openxmlformats.org/drawingml/2006/main">
             <a:pPr algn="l">
+              <a:buNone/>
               <a:defRPr sz="4800" b="1">
                 <a:solidFill>
                   <a:srgbClr val="0B0D10"/>
@@ -3282,6 +3304,7 @@
           <a:lstStyle xmlns:a="http://schemas.openxmlformats.org/drawingml/2006/main"/>
           <a:p xmlns:a="http://schemas.openxmlformats.org/drawingml/2006/main">
             <a:pPr algn="l">
+              <a:buNone/>
               <a:defRPr sz="1875" b="1">
                 <a:solidFill>
                   <a:srgbClr val="0B0D10"/>
@@ -3322,6 +3345,7 @@
           <a:lstStyle xmlns:a="http://schemas.openxmlformats.org/drawingml/2006/main"/>
           <a:p xmlns:a="http://schemas.openxmlformats.org/drawingml/2006/main">
             <a:pPr algn="l">
+              <a:buNone/>
               <a:defRPr sz="1500" b="0">
                 <a:solidFill>
                   <a:srgbClr val="0B0D10"/>
@@ -3362,6 +3386,7 @@
           <a:lstStyle xmlns:a="http://schemas.openxmlformats.org/drawingml/2006/main"/>
           <a:p xmlns:a="http://schemas.openxmlformats.org/drawingml/2006/main">
             <a:pPr algn="l">
+              <a:buNone/>
               <a:defRPr sz="1875" b="1">
                 <a:solidFill>
                   <a:srgbClr val="0B0D10"/>
@@ -3402,6 +3427,7 @@
           <a:lstStyle xmlns:a="http://schemas.openxmlformats.org/drawingml/2006/main"/>
           <a:p xmlns:a="http://schemas.openxmlformats.org/drawingml/2006/main">
             <a:pPr algn="l">
+              <a:buNone/>
               <a:defRPr sz="1500" b="0">
                 <a:solidFill>
                   <a:srgbClr val="0B0D10"/>
@@ -3442,6 +3468,7 @@
           <a:lstStyle xmlns:a="http://schemas.openxmlformats.org/drawingml/2006/main"/>
           <a:p xmlns:a="http://schemas.openxmlformats.org/drawingml/2006/main">
             <a:pPr algn="l">
+              <a:buNone/>
               <a:defRPr sz="1875" b="1">
                 <a:solidFill>
                   <a:srgbClr val="FF6B35"/>
@@ -3482,6 +3509,7 @@
           <a:lstStyle xmlns:a="http://schemas.openxmlformats.org/drawingml/2006/main"/>
           <a:p xmlns:a="http://schemas.openxmlformats.org/drawingml/2006/main">
             <a:pPr algn="l">
+              <a:buNone/>
               <a:defRPr sz="1500" b="1">
                 <a:solidFill>
                   <a:srgbClr val="0B0D10"/>
@@ -3522,6 +3550,7 @@
           <a:lstStyle xmlns:a="http://schemas.openxmlformats.org/drawingml/2006/main"/>
           <a:p xmlns:a="http://schemas.openxmlformats.org/drawingml/2006/main">
             <a:pPr algn="r">
+              <a:buNone/>
               <a:defRPr sz="1125" b="0">
                 <a:solidFill>
                   <a:srgbClr val="555B63"/>
@@ -3591,6 +3620,7 @@
           <a:lstStyle xmlns:a="http://schemas.openxmlformats.org/drawingml/2006/main"/>
           <a:p xmlns:a="http://schemas.openxmlformats.org/drawingml/2006/main">
             <a:pPr algn="l">
+              <a:buNone/>
               <a:defRPr sz="1200" b="1">
                 <a:solidFill>
                   <a:srgbClr val="FF6B35"/>
@@ -3631,6 +3661,7 @@
           <a:lstStyle xmlns:a="http://schemas.openxmlformats.org/drawingml/2006/main"/>
           <a:p xmlns:a="http://schemas.openxmlformats.org/drawingml/2006/main">
             <a:pPr algn="l">
+              <a:buNone/>
               <a:defRPr sz="3450" b="1">
                 <a:solidFill>
                   <a:srgbClr val="0B0D10"/>
@@ -3941,6 +3972,7 @@
           <a:lstStyle xmlns:a="http://schemas.openxmlformats.org/drawingml/2006/main"/>
           <a:p xmlns:a="http://schemas.openxmlformats.org/drawingml/2006/main">
             <a:pPr algn="ctr">
+              <a:buNone/>
               <a:defRPr sz="1500" b="1">
                 <a:solidFill>
                   <a:srgbClr val="0B0D10"/>
@@ -3981,6 +4013,7 @@
           <a:lstStyle xmlns:a="http://schemas.openxmlformats.org/drawingml/2006/main"/>
           <a:p xmlns:a="http://schemas.openxmlformats.org/drawingml/2006/main">
             <a:pPr algn="ctr">
+              <a:buNone/>
               <a:defRPr sz="1350" b="1">
                 <a:solidFill>
                   <a:srgbClr val="0B0D10"/>
@@ -4022,6 +4055,7 @@
           <a:lstStyle xmlns:a="http://schemas.openxmlformats.org/drawingml/2006/main"/>
           <a:p xmlns:a="http://schemas.openxmlformats.org/drawingml/2006/main">
             <a:pPr algn="ctr">
+              <a:buNone/>
               <a:defRPr sz="1350" b="1">
                 <a:solidFill>
                   <a:srgbClr val="0B0D10"/>
@@ -4062,6 +4096,7 @@
           <a:lstStyle xmlns:a="http://schemas.openxmlformats.org/drawingml/2006/main"/>
           <a:p xmlns:a="http://schemas.openxmlformats.org/drawingml/2006/main">
             <a:pPr algn="ctr">
+              <a:buNone/>
               <a:defRPr sz="1350" b="1">
                 <a:solidFill>
                   <a:srgbClr val="0B0D10"/>
@@ -4103,6 +4138,7 @@
           <a:lstStyle xmlns:a="http://schemas.openxmlformats.org/drawingml/2006/main"/>
           <a:p xmlns:a="http://schemas.openxmlformats.org/drawingml/2006/main">
             <a:pPr algn="ctr">
+              <a:buNone/>
               <a:defRPr sz="1350" b="1">
                 <a:solidFill>
                   <a:srgbClr val="0B0D10"/>
@@ -4143,6 +4179,7 @@
           <a:lstStyle xmlns:a="http://schemas.openxmlformats.org/drawingml/2006/main"/>
           <a:p xmlns:a="http://schemas.openxmlformats.org/drawingml/2006/main">
             <a:pPr algn="ctr">
+              <a:buNone/>
               <a:defRPr sz="1350" b="1">
                 <a:solidFill>
                   <a:srgbClr val="0B0D10"/>
@@ -4211,6 +4248,7 @@
           <a:lstStyle xmlns:a="http://schemas.openxmlformats.org/drawingml/2006/main"/>
           <a:p xmlns:a="http://schemas.openxmlformats.org/drawingml/2006/main">
             <a:pPr algn="l">
+              <a:buNone/>
               <a:defRPr sz="1350" b="1">
                 <a:solidFill>
                   <a:srgbClr val="FF6B35"/>
@@ -4251,6 +4289,7 @@
           <a:lstStyle xmlns:a="http://schemas.openxmlformats.org/drawingml/2006/main"/>
           <a:p xmlns:a="http://schemas.openxmlformats.org/drawingml/2006/main">
             <a:pPr algn="l">
+              <a:buNone/>
               <a:defRPr sz="1650" b="1">
                 <a:solidFill>
                   <a:srgbClr val="0B0D10"/>
@@ -4291,6 +4330,7 @@
           <a:lstStyle xmlns:a="http://schemas.openxmlformats.org/drawingml/2006/main"/>
           <a:p xmlns:a="http://schemas.openxmlformats.org/drawingml/2006/main">
             <a:pPr algn="l">
+              <a:buNone/>
               <a:defRPr sz="1350" b="0">
                 <a:solidFill>
                   <a:srgbClr val="555B63"/>
@@ -4331,6 +4371,7 @@
           <a:lstStyle xmlns:a="http://schemas.openxmlformats.org/drawingml/2006/main"/>
           <a:p xmlns:a="http://schemas.openxmlformats.org/drawingml/2006/main">
             <a:pPr algn="r">
+              <a:buNone/>
               <a:defRPr sz="1125" b="0">
                 <a:solidFill>
                   <a:srgbClr val="555B63"/>
@@ -4400,6 +4441,7 @@
           <a:lstStyle xmlns:a="http://schemas.openxmlformats.org/drawingml/2006/main"/>
           <a:p xmlns:a="http://schemas.openxmlformats.org/drawingml/2006/main">
             <a:pPr algn="l">
+              <a:buNone/>
               <a:defRPr sz="1200" b="1">
                 <a:solidFill>
                   <a:srgbClr val="FF6B35"/>
@@ -4440,6 +4482,7 @@
           <a:lstStyle xmlns:a="http://schemas.openxmlformats.org/drawingml/2006/main"/>
           <a:p xmlns:a="http://schemas.openxmlformats.org/drawingml/2006/main">
             <a:pPr algn="l">
+              <a:buNone/>
               <a:defRPr sz="4350" b="1">
                 <a:solidFill>
                   <a:srgbClr val="FF6B35"/>
@@ -4480,6 +4523,7 @@
           <a:lstStyle xmlns:a="http://schemas.openxmlformats.org/drawingml/2006/main"/>
           <a:p xmlns:a="http://schemas.openxmlformats.org/drawingml/2006/main">
             <a:pPr algn="l">
+              <a:buNone/>
               <a:defRPr sz="1650" b="0">
                 <a:solidFill>
                   <a:srgbClr val="555B63"/>
@@ -4547,6 +4591,7 @@
           <a:lstStyle xmlns:a="http://schemas.openxmlformats.org/drawingml/2006/main"/>
           <a:p xmlns:a="http://schemas.openxmlformats.org/drawingml/2006/main">
             <a:pPr algn="ctr">
+              <a:buNone/>
               <a:defRPr sz="2850" b="1">
                 <a:solidFill>
                   <a:srgbClr val="0B0D10"/>
@@ -4587,6 +4632,7 @@
           <a:lstStyle xmlns:a="http://schemas.openxmlformats.org/drawingml/2006/main"/>
           <a:p xmlns:a="http://schemas.openxmlformats.org/drawingml/2006/main">
             <a:pPr algn="ctr">
+              <a:buNone/>
               <a:defRPr sz="3600" b="1">
                 <a:solidFill>
                   <a:srgbClr val="FF6B35"/>
@@ -4627,6 +4673,7 @@
           <a:lstStyle xmlns:a="http://schemas.openxmlformats.org/drawingml/2006/main"/>
           <a:p xmlns:a="http://schemas.openxmlformats.org/drawingml/2006/main">
             <a:pPr algn="ctr">
+              <a:buNone/>
               <a:defRPr sz="2850" b="1">
                 <a:solidFill>
                   <a:srgbClr val="0B0D10"/>
@@ -4667,6 +4714,7 @@
           <a:lstStyle xmlns:a="http://schemas.openxmlformats.org/drawingml/2006/main"/>
           <a:p xmlns:a="http://schemas.openxmlformats.org/drawingml/2006/main">
             <a:pPr algn="ctr">
+              <a:buNone/>
               <a:defRPr sz="1425" b="0">
                 <a:solidFill>
                   <a:srgbClr val="555B63"/>
@@ -4707,6 +4755,7 @@
           <a:lstStyle xmlns:a="http://schemas.openxmlformats.org/drawingml/2006/main"/>
           <a:p xmlns:a="http://schemas.openxmlformats.org/drawingml/2006/main">
             <a:pPr algn="ctr">
+              <a:buNone/>
               <a:defRPr sz="1425" b="1">
                 <a:solidFill>
                   <a:srgbClr val="FF6B35"/>
@@ -4747,6 +4796,7 @@
           <a:lstStyle xmlns:a="http://schemas.openxmlformats.org/drawingml/2006/main"/>
           <a:p xmlns:a="http://schemas.openxmlformats.org/drawingml/2006/main">
             <a:pPr algn="l">
+              <a:buNone/>
               <a:defRPr sz="2100" b="1">
                 <a:solidFill>
                   <a:srgbClr val="0B0D10"/>
@@ -4787,6 +4837,7 @@
           <a:lstStyle xmlns:a="http://schemas.openxmlformats.org/drawingml/2006/main"/>
           <a:p xmlns:a="http://schemas.openxmlformats.org/drawingml/2006/main">
             <a:pPr algn="l">
+              <a:buNone/>
               <a:defRPr sz="1650" b="1">
                 <a:solidFill>
                   <a:srgbClr val="087F5B"/>
@@ -4827,6 +4878,7 @@
           <a:lstStyle xmlns:a="http://schemas.openxmlformats.org/drawingml/2006/main"/>
           <a:p xmlns:a="http://schemas.openxmlformats.org/drawingml/2006/main">
             <a:pPr algn="l">
+              <a:buNone/>
               <a:defRPr sz="1350" b="0">
                 <a:solidFill>
                   <a:srgbClr val="555B63"/>
@@ -4867,6 +4919,7 @@
           <a:lstStyle xmlns:a="http://schemas.openxmlformats.org/drawingml/2006/main"/>
           <a:p xmlns:a="http://schemas.openxmlformats.org/drawingml/2006/main">
             <a:pPr algn="l">
+              <a:buNone/>
               <a:defRPr sz="1650" b="1">
                 <a:solidFill>
                   <a:srgbClr val="FF6B35"/>
@@ -4907,6 +4960,7 @@
           <a:lstStyle xmlns:a="http://schemas.openxmlformats.org/drawingml/2006/main"/>
           <a:p xmlns:a="http://schemas.openxmlformats.org/drawingml/2006/main">
             <a:pPr algn="l">
+              <a:buNone/>
               <a:defRPr sz="1350" b="0">
                 <a:solidFill>
                   <a:srgbClr val="555B63"/>
@@ -4947,6 +5001,7 @@
           <a:lstStyle xmlns:a="http://schemas.openxmlformats.org/drawingml/2006/main"/>
           <a:p xmlns:a="http://schemas.openxmlformats.org/drawingml/2006/main">
             <a:pPr algn="l">
+              <a:buNone/>
               <a:defRPr sz="1650" b="1">
                 <a:solidFill>
                   <a:srgbClr val="0B0D10"/>
@@ -4987,6 +5042,7 @@
           <a:lstStyle xmlns:a="http://schemas.openxmlformats.org/drawingml/2006/main"/>
           <a:p xmlns:a="http://schemas.openxmlformats.org/drawingml/2006/main">
             <a:pPr algn="l">
+              <a:buNone/>
               <a:defRPr sz="1350" b="0">
                 <a:solidFill>
                   <a:srgbClr val="555B63"/>
@@ -5027,6 +5083,7 @@
           <a:lstStyle xmlns:a="http://schemas.openxmlformats.org/drawingml/2006/main"/>
           <a:p xmlns:a="http://schemas.openxmlformats.org/drawingml/2006/main">
             <a:pPr algn="l">
+              <a:buNone/>
               <a:defRPr sz="1500" b="1">
                 <a:solidFill>
                   <a:srgbClr val="0B0D10"/>
@@ -5067,6 +5124,7 @@
           <a:lstStyle xmlns:a="http://schemas.openxmlformats.org/drawingml/2006/main"/>
           <a:p xmlns:a="http://schemas.openxmlformats.org/drawingml/2006/main">
             <a:pPr algn="r">
+              <a:buNone/>
               <a:defRPr sz="1125" b="0">
                 <a:solidFill>
                   <a:srgbClr val="555B63"/>
@@ -5136,6 +5194,7 @@
           <a:lstStyle xmlns:a="http://schemas.openxmlformats.org/drawingml/2006/main"/>
           <a:p xmlns:a="http://schemas.openxmlformats.org/drawingml/2006/main">
             <a:pPr algn="l">
+              <a:buNone/>
               <a:defRPr sz="1200" b="1">
                 <a:solidFill>
                   <a:srgbClr val="FF6B35"/>
@@ -5176,6 +5235,7 @@
           <a:lstStyle xmlns:a="http://schemas.openxmlformats.org/drawingml/2006/main"/>
           <a:p xmlns:a="http://schemas.openxmlformats.org/drawingml/2006/main">
             <a:pPr algn="l">
+              <a:buNone/>
               <a:defRPr sz="3600" b="1">
                 <a:solidFill>
                   <a:srgbClr val="0B0D10"/>
@@ -5297,6 +5357,7 @@
           <a:lstStyle xmlns:a="http://schemas.openxmlformats.org/drawingml/2006/main"/>
           <a:p xmlns:a="http://schemas.openxmlformats.org/drawingml/2006/main">
             <a:pPr algn="l">
+              <a:buNone/>
               <a:defRPr sz="3300" b="1">
                 <a:solidFill>
                   <a:srgbClr val="FF6B35"/>
@@ -5337,6 +5398,7 @@
           <a:lstStyle xmlns:a="http://schemas.openxmlformats.org/drawingml/2006/main"/>
           <a:p xmlns:a="http://schemas.openxmlformats.org/drawingml/2006/main">
             <a:pPr algn="l">
+              <a:buNone/>
               <a:defRPr sz="2325" b="1">
                 <a:solidFill>
                   <a:srgbClr val="0B0D10"/>
@@ -5377,6 +5439,7 @@
           <a:lstStyle xmlns:a="http://schemas.openxmlformats.org/drawingml/2006/main"/>
           <a:p xmlns:a="http://schemas.openxmlformats.org/drawingml/2006/main">
             <a:pPr algn="l">
+              <a:buNone/>
               <a:defRPr sz="1575" b="0">
                 <a:solidFill>
                   <a:srgbClr val="0B0D10"/>
@@ -5417,6 +5480,7 @@
           <a:lstStyle xmlns:a="http://schemas.openxmlformats.org/drawingml/2006/main"/>
           <a:p xmlns:a="http://schemas.openxmlformats.org/drawingml/2006/main">
             <a:pPr algn="l">
+              <a:buNone/>
               <a:defRPr sz="3300" b="1">
                 <a:solidFill>
                   <a:srgbClr val="FF6B35"/>
@@ -5457,6 +5521,7 @@
           <a:lstStyle xmlns:a="http://schemas.openxmlformats.org/drawingml/2006/main"/>
           <a:p xmlns:a="http://schemas.openxmlformats.org/drawingml/2006/main">
             <a:pPr algn="l">
+              <a:buNone/>
               <a:defRPr sz="2325" b="1">
                 <a:solidFill>
                   <a:srgbClr val="0B0D10"/>
@@ -5497,6 +5562,7 @@
           <a:lstStyle xmlns:a="http://schemas.openxmlformats.org/drawingml/2006/main"/>
           <a:p xmlns:a="http://schemas.openxmlformats.org/drawingml/2006/main">
             <a:pPr algn="l">
+              <a:buNone/>
               <a:defRPr sz="1575" b="0">
                 <a:solidFill>
                   <a:srgbClr val="0B0D10"/>
@@ -5537,6 +5603,7 @@
           <a:lstStyle xmlns:a="http://schemas.openxmlformats.org/drawingml/2006/main"/>
           <a:p xmlns:a="http://schemas.openxmlformats.org/drawingml/2006/main">
             <a:pPr algn="l">
+              <a:buNone/>
               <a:defRPr sz="3300" b="1">
                 <a:solidFill>
                   <a:srgbClr val="FF6B35"/>
@@ -5577,6 +5644,7 @@
           <a:lstStyle xmlns:a="http://schemas.openxmlformats.org/drawingml/2006/main"/>
           <a:p xmlns:a="http://schemas.openxmlformats.org/drawingml/2006/main">
             <a:pPr algn="l">
+              <a:buNone/>
               <a:defRPr sz="2325" b="1">
                 <a:solidFill>
                   <a:srgbClr val="0B0D10"/>
@@ -5617,6 +5685,7 @@
           <a:lstStyle xmlns:a="http://schemas.openxmlformats.org/drawingml/2006/main"/>
           <a:p xmlns:a="http://schemas.openxmlformats.org/drawingml/2006/main">
             <a:pPr algn="l">
+              <a:buNone/>
               <a:defRPr sz="1575" b="0">
                 <a:solidFill>
                   <a:srgbClr val="0B0D10"/>
@@ -5657,6 +5726,7 @@
           <a:lstStyle xmlns:a="http://schemas.openxmlformats.org/drawingml/2006/main"/>
           <a:p xmlns:a="http://schemas.openxmlformats.org/drawingml/2006/main">
             <a:pPr algn="l">
+              <a:buNone/>
               <a:defRPr sz="1500" b="0">
                 <a:solidFill>
                   <a:srgbClr val="555B63"/>
@@ -5697,6 +5767,7 @@
           <a:lstStyle xmlns:a="http://schemas.openxmlformats.org/drawingml/2006/main"/>
           <a:p xmlns:a="http://schemas.openxmlformats.org/drawingml/2006/main">
             <a:pPr algn="r">
+              <a:buNone/>
               <a:defRPr sz="1125" b="0">
                 <a:solidFill>
                   <a:srgbClr val="555B63"/>
@@ -5766,6 +5837,7 @@
           <a:lstStyle xmlns:a="http://schemas.openxmlformats.org/drawingml/2006/main"/>
           <a:p xmlns:a="http://schemas.openxmlformats.org/drawingml/2006/main">
             <a:pPr algn="l">
+              <a:buNone/>
               <a:defRPr sz="1200" b="1">
                 <a:solidFill>
                   <a:srgbClr val="FF6B35"/>
@@ -5806,6 +5878,7 @@
           <a:lstStyle xmlns:a="http://schemas.openxmlformats.org/drawingml/2006/main"/>
           <a:p xmlns:a="http://schemas.openxmlformats.org/drawingml/2006/main">
             <a:pPr algn="l">
+              <a:buNone/>
               <a:defRPr sz="3375" b="1">
                 <a:solidFill>
                   <a:srgbClr val="0B0D10"/>
@@ -5873,6 +5946,7 @@
           <a:lstStyle xmlns:a="http://schemas.openxmlformats.org/drawingml/2006/main"/>
           <a:p xmlns:a="http://schemas.openxmlformats.org/drawingml/2006/main">
             <a:pPr algn="l">
+              <a:buNone/>
               <a:defRPr sz="4950" b="1">
                 <a:solidFill>
                   <a:srgbClr val="087F5B"/>
@@ -5913,6 +5987,7 @@
           <a:lstStyle xmlns:a="http://schemas.openxmlformats.org/drawingml/2006/main"/>
           <a:p xmlns:a="http://schemas.openxmlformats.org/drawingml/2006/main">
             <a:pPr algn="l">
+              <a:buNone/>
               <a:defRPr sz="1725" b="1">
                 <a:solidFill>
                   <a:srgbClr val="0B0D10"/>
@@ -5953,6 +6028,7 @@
           <a:lstStyle xmlns:a="http://schemas.openxmlformats.org/drawingml/2006/main"/>
           <a:p xmlns:a="http://schemas.openxmlformats.org/drawingml/2006/main">
             <a:pPr algn="l">
+              <a:buNone/>
               <a:defRPr sz="4950" b="1">
                 <a:solidFill>
                   <a:srgbClr val="FF6B35"/>
@@ -5993,6 +6069,7 @@
           <a:lstStyle xmlns:a="http://schemas.openxmlformats.org/drawingml/2006/main"/>
           <a:p xmlns:a="http://schemas.openxmlformats.org/drawingml/2006/main">
             <a:pPr algn="l">
+              <a:buNone/>
               <a:defRPr sz="1725" b="1">
                 <a:solidFill>
                   <a:srgbClr val="0B0D10"/>
@@ -6033,6 +6110,7 @@
           <a:lstStyle xmlns:a="http://schemas.openxmlformats.org/drawingml/2006/main"/>
           <a:p xmlns:a="http://schemas.openxmlformats.org/drawingml/2006/main">
             <a:pPr algn="l">
+              <a:buNone/>
               <a:defRPr sz="1275" b="0">
                 <a:solidFill>
                   <a:srgbClr val="555B63"/>
@@ -6073,6 +6151,7 @@
           <a:lstStyle xmlns:a="http://schemas.openxmlformats.org/drawingml/2006/main"/>
           <a:p xmlns:a="http://schemas.openxmlformats.org/drawingml/2006/main">
             <a:pPr algn="r">
+              <a:buNone/>
               <a:defRPr sz="1125" b="0">
                 <a:solidFill>
                   <a:srgbClr val="555B63"/>
@@ -6087,7 +6166,7 @@
       </p:sp>
       <p:graphicFrame>
         <p:nvGraphicFramePr>
-          <p:cNvPr id="20" name="Chart"/>
+          <p:cNvPr id="22" name="Chart"/>
           <p:cNvGraphicFramePr/>
           <p:nvPr/>
         </p:nvGraphicFramePr>
@@ -6097,7 +6176,7 @@
         </p:xfrm>
         <a:graphic xmlns:a="http://schemas.openxmlformats.org/drawingml/2006/main">
           <a:graphicData uri="http://schemas.openxmlformats.org/drawingml/2006/chart">
-            <c:chart xmlns:r="http://schemas.openxmlformats.org/officeDocument/2006/relationships" xmlns:c="http://schemas.openxmlformats.org/drawingml/2006/chart" r:id="R9db5b09cc759422a"/>
+            <c:chart xmlns:r="http://schemas.openxmlformats.org/officeDocument/2006/relationships" xmlns:c="http://schemas.openxmlformats.org/drawingml/2006/chart" r:id="R2fe7050674d8484c"/>
           </a:graphicData>
         </a:graphic>
       </p:graphicFrame>
@@ -6158,6 +6237,7 @@
           <a:lstStyle xmlns:a="http://schemas.openxmlformats.org/drawingml/2006/main"/>
           <a:p xmlns:a="http://schemas.openxmlformats.org/drawingml/2006/main">
             <a:pPr algn="l">
+              <a:buNone/>
               <a:defRPr sz="1200" b="1">
                 <a:solidFill>
                   <a:srgbClr val="FF6B35"/>
@@ -6198,6 +6278,7 @@
           <a:lstStyle xmlns:a="http://schemas.openxmlformats.org/drawingml/2006/main"/>
           <a:p xmlns:a="http://schemas.openxmlformats.org/drawingml/2006/main">
             <a:pPr algn="l">
+              <a:buNone/>
               <a:defRPr sz="5700" b="1">
                 <a:solidFill>
                   <a:srgbClr val="0B0D10"/>
@@ -6238,6 +6319,7 @@
           <a:lstStyle xmlns:a="http://schemas.openxmlformats.org/drawingml/2006/main"/>
           <a:p xmlns:a="http://schemas.openxmlformats.org/drawingml/2006/main">
             <a:pPr algn="l">
+              <a:buNone/>
               <a:defRPr sz="2100" b="0">
                 <a:solidFill>
                   <a:srgbClr val="555B63"/>
@@ -6359,6 +6441,7 @@
           <a:lstStyle xmlns:a="http://schemas.openxmlformats.org/drawingml/2006/main"/>
           <a:p xmlns:a="http://schemas.openxmlformats.org/drawingml/2006/main">
             <a:pPr algn="l">
+              <a:buNone/>
               <a:defRPr sz="2025" b="1">
                 <a:solidFill>
                   <a:srgbClr val="0B0D10"/>
@@ -6399,6 +6482,7 @@
           <a:lstStyle xmlns:a="http://schemas.openxmlformats.org/drawingml/2006/main"/>
           <a:p xmlns:a="http://schemas.openxmlformats.org/drawingml/2006/main">
             <a:pPr algn="l">
+              <a:buNone/>
               <a:defRPr sz="1425" b="0">
                 <a:solidFill>
                   <a:srgbClr val="0B0D10"/>
@@ -6439,6 +6523,7 @@
           <a:lstStyle xmlns:a="http://schemas.openxmlformats.org/drawingml/2006/main"/>
           <a:p xmlns:a="http://schemas.openxmlformats.org/drawingml/2006/main">
             <a:pPr algn="l">
+              <a:buNone/>
               <a:defRPr sz="2025" b="1">
                 <a:solidFill>
                   <a:srgbClr val="0B0D10"/>
@@ -6479,6 +6564,7 @@
           <a:lstStyle xmlns:a="http://schemas.openxmlformats.org/drawingml/2006/main"/>
           <a:p xmlns:a="http://schemas.openxmlformats.org/drawingml/2006/main">
             <a:pPr algn="l">
+              <a:buNone/>
               <a:defRPr sz="1425" b="0">
                 <a:solidFill>
                   <a:srgbClr val="0B0D10"/>
@@ -6519,6 +6605,7 @@
           <a:lstStyle xmlns:a="http://schemas.openxmlformats.org/drawingml/2006/main"/>
           <a:p xmlns:a="http://schemas.openxmlformats.org/drawingml/2006/main">
             <a:pPr algn="l">
+              <a:buNone/>
               <a:defRPr sz="2025" b="1">
                 <a:solidFill>
                   <a:srgbClr val="FF6B35"/>
@@ -6559,6 +6646,7 @@
           <a:lstStyle xmlns:a="http://schemas.openxmlformats.org/drawingml/2006/main"/>
           <a:p xmlns:a="http://schemas.openxmlformats.org/drawingml/2006/main">
             <a:pPr algn="l">
+              <a:buNone/>
               <a:defRPr sz="1425" b="0">
                 <a:solidFill>
                   <a:srgbClr val="0B0D10"/>
@@ -6599,6 +6687,7 @@
           <a:lstStyle xmlns:a="http://schemas.openxmlformats.org/drawingml/2006/main"/>
           <a:p xmlns:a="http://schemas.openxmlformats.org/drawingml/2006/main">
             <a:pPr algn="l">
+              <a:buNone/>
               <a:defRPr sz="1425" b="0">
                 <a:solidFill>
                   <a:srgbClr val="555B63"/>
@@ -6639,6 +6728,7 @@
           <a:lstStyle xmlns:a="http://schemas.openxmlformats.org/drawingml/2006/main"/>
           <a:p xmlns:a="http://schemas.openxmlformats.org/drawingml/2006/main">
             <a:pPr algn="r">
+              <a:buNone/>
               <a:defRPr sz="1125" b="0">
                 <a:solidFill>
                   <a:srgbClr val="555B63"/>
@@ -6708,6 +6798,7 @@
           <a:lstStyle xmlns:a="http://schemas.openxmlformats.org/drawingml/2006/main"/>
           <a:p xmlns:a="http://schemas.openxmlformats.org/drawingml/2006/main">
             <a:pPr algn="l">
+              <a:buNone/>
               <a:defRPr sz="1200" b="1">
                 <a:solidFill>
                   <a:srgbClr val="FF6B35"/>
@@ -6748,6 +6839,7 @@
           <a:lstStyle xmlns:a="http://schemas.openxmlformats.org/drawingml/2006/main"/>
           <a:p xmlns:a="http://schemas.openxmlformats.org/drawingml/2006/main">
             <a:pPr algn="l">
+              <a:buNone/>
               <a:defRPr sz="3375" b="1">
                 <a:solidFill>
                   <a:srgbClr val="0B0D10"/>
@@ -6815,6 +6907,7 @@
           <a:lstStyle xmlns:a="http://schemas.openxmlformats.org/drawingml/2006/main"/>
           <a:p xmlns:a="http://schemas.openxmlformats.org/drawingml/2006/main">
             <a:pPr algn="l">
+              <a:buNone/>
               <a:defRPr sz="4650" b="1">
                 <a:solidFill>
                   <a:srgbClr val="FF6B35"/>
@@ -6855,6 +6948,7 @@
           <a:lstStyle xmlns:a="http://schemas.openxmlformats.org/drawingml/2006/main"/>
           <a:p xmlns:a="http://schemas.openxmlformats.org/drawingml/2006/main">
             <a:pPr algn="l">
+              <a:buNone/>
               <a:defRPr sz="1575" b="0">
                 <a:solidFill>
                   <a:srgbClr val="555B63"/>
@@ -6895,6 +6989,7 @@
           <a:lstStyle xmlns:a="http://schemas.openxmlformats.org/drawingml/2006/main"/>
           <a:p xmlns:a="http://schemas.openxmlformats.org/drawingml/2006/main">
             <a:pPr algn="l">
+              <a:buNone/>
               <a:defRPr sz="4650" b="1">
                 <a:solidFill>
                   <a:srgbClr val="0B0D10"/>
@@ -6935,6 +7030,7 @@
           <a:lstStyle xmlns:a="http://schemas.openxmlformats.org/drawingml/2006/main"/>
           <a:p xmlns:a="http://schemas.openxmlformats.org/drawingml/2006/main">
             <a:pPr algn="l">
+              <a:buNone/>
               <a:defRPr sz="1575" b="0">
                 <a:solidFill>
                   <a:srgbClr val="555B63"/>
@@ -6975,6 +7071,7 @@
           <a:lstStyle xmlns:a="http://schemas.openxmlformats.org/drawingml/2006/main"/>
           <a:p xmlns:a="http://schemas.openxmlformats.org/drawingml/2006/main">
             <a:pPr algn="l">
+              <a:buNone/>
               <a:defRPr sz="1350" b="1">
                 <a:solidFill>
                   <a:srgbClr val="0B0D10"/>
@@ -7015,6 +7112,7 @@
           <a:lstStyle xmlns:a="http://schemas.openxmlformats.org/drawingml/2006/main"/>
           <a:p xmlns:a="http://schemas.openxmlformats.org/drawingml/2006/main">
             <a:pPr algn="r">
+              <a:buNone/>
               <a:defRPr sz="1125" b="0">
                 <a:solidFill>
                   <a:srgbClr val="555B63"/>
@@ -7029,7 +7127,7 @@
       </p:sp>
       <p:graphicFrame>
         <p:nvGraphicFramePr>
-          <p:cNvPr id="20" name="Chart"/>
+          <p:cNvPr id="22" name="Chart"/>
           <p:cNvGraphicFramePr/>
           <p:nvPr/>
         </p:nvGraphicFramePr>
@@ -7039,7 +7137,7 @@
         </p:xfrm>
         <a:graphic xmlns:a="http://schemas.openxmlformats.org/drawingml/2006/main">
           <a:graphicData uri="http://schemas.openxmlformats.org/drawingml/2006/chart">
-            <c:chart xmlns:r="http://schemas.openxmlformats.org/officeDocument/2006/relationships" xmlns:c="http://schemas.openxmlformats.org/drawingml/2006/chart" r:id="R46e9ffa63a29446e"/>
+            <c:chart xmlns:r="http://schemas.openxmlformats.org/officeDocument/2006/relationships" xmlns:c="http://schemas.openxmlformats.org/drawingml/2006/chart" r:id="R8a323f633dec4e35"/>
           </a:graphicData>
         </a:graphic>
       </p:graphicFrame>
@@ -7100,6 +7198,7 @@
           <a:lstStyle xmlns:a="http://schemas.openxmlformats.org/drawingml/2006/main"/>
           <a:p xmlns:a="http://schemas.openxmlformats.org/drawingml/2006/main">
             <a:pPr algn="l">
+              <a:buNone/>
               <a:defRPr sz="1200" b="1">
                 <a:solidFill>
                   <a:srgbClr val="FF6B35"/>
@@ -7140,6 +7239,7 @@
           <a:lstStyle xmlns:a="http://schemas.openxmlformats.org/drawingml/2006/main"/>
           <a:p xmlns:a="http://schemas.openxmlformats.org/drawingml/2006/main">
             <a:pPr algn="l">
+              <a:buNone/>
               <a:defRPr sz="3375" b="1">
                 <a:solidFill>
                   <a:srgbClr val="0B0D10"/>
@@ -7147,7 +7247,7 @@
               </a:defRPr>
             </a:pPr>
             <a:r>
-              <a:t>Негативный результат не был скрыт</a:t>
+              <a:t>MUFAC FAIL → sequential PASS</a:t>
             </a:r>
           </a:p>
         </p:txBody>
@@ -7207,6 +7307,7 @@
           <a:lstStyle xmlns:a="http://schemas.openxmlformats.org/drawingml/2006/main"/>
           <a:p xmlns:a="http://schemas.openxmlformats.org/drawingml/2006/main">
             <a:pPr algn="l">
+              <a:buNone/>
               <a:defRPr sz="2025" b="1">
                 <a:solidFill>
                   <a:srgbClr val="0B0D10"/>
@@ -7247,6 +7348,7 @@
           <a:lstStyle xmlns:a="http://schemas.openxmlformats.org/drawingml/2006/main"/>
           <a:p xmlns:a="http://schemas.openxmlformats.org/drawingml/2006/main">
             <a:pPr algn="l">
+              <a:buNone/>
               <a:defRPr sz="3600" b="1">
                 <a:solidFill>
                   <a:srgbClr val="FF6B35"/>
@@ -7287,6 +7389,7 @@
           <a:lstStyle xmlns:a="http://schemas.openxmlformats.org/drawingml/2006/main"/>
           <a:p xmlns:a="http://schemas.openxmlformats.org/drawingml/2006/main">
             <a:pPr algn="l">
+              <a:buNone/>
               <a:defRPr sz="1500" b="0">
                 <a:solidFill>
                   <a:srgbClr val="555B63"/>
@@ -7327,6 +7430,7 @@
           <a:lstStyle xmlns:a="http://schemas.openxmlformats.org/drawingml/2006/main"/>
           <a:p xmlns:a="http://schemas.openxmlformats.org/drawingml/2006/main">
             <a:pPr algn="l">
+              <a:buNone/>
               <a:defRPr sz="2025" b="1">
                 <a:solidFill>
                   <a:srgbClr val="0B0D10"/>
@@ -7334,7 +7438,7 @@
               </a:defRPr>
             </a:pPr>
             <a:r>
-              <a:t>Adaptive v3.2</a:t>
+              <a:t>Sequential v1</a:t>
             </a:r>
           </a:p>
         </p:txBody>
@@ -7367,6 +7471,7 @@
           <a:lstStyle xmlns:a="http://schemas.openxmlformats.org/drawingml/2006/main"/>
           <a:p xmlns:a="http://schemas.openxmlformats.org/drawingml/2006/main">
             <a:pPr algn="l">
+              <a:buNone/>
               <a:defRPr sz="3300" b="1">
                 <a:solidFill>
                   <a:srgbClr val="087F5B"/>
@@ -7374,7 +7479,7 @@
               </a:defRPr>
             </a:pPr>
             <a:r>
-              <a:t>PASS · 1.59×</a:t>
+              <a:t>PASS · 25/25</a:t>
             </a:r>
           </a:p>
         </p:txBody>
@@ -7407,6 +7512,7 @@
           <a:lstStyle xmlns:a="http://schemas.openxmlformats.org/drawingml/2006/main"/>
           <a:p xmlns:a="http://schemas.openxmlformats.org/drawingml/2006/main">
             <a:pPr algn="l">
+              <a:buNone/>
               <a:defRPr sz="1350" b="0">
                 <a:solidFill>
                   <a:srgbClr val="555B63"/>
@@ -7414,7 +7520,7 @@
               </a:defRPr>
             </a:pPr>
             <a:r>
-              <a:t>Post-exposure method improvement, не независимое подтверждение.</a:t>
+              <a:t>privacy upper CI 0.00624 · first-run, project-authored.</a:t>
             </a:r>
           </a:p>
         </p:txBody>
@@ -7447,6 +7553,7 @@
           <a:lstStyle xmlns:a="http://schemas.openxmlformats.org/drawingml/2006/main"/>
           <a:p xmlns:a="http://schemas.openxmlformats.org/drawingml/2006/main">
             <a:pPr algn="r">
+              <a:buNone/>
               <a:defRPr sz="1125" b="0">
                 <a:solidFill>
                   <a:srgbClr val="555B63"/>
@@ -7461,14 +7568,14 @@
       </p:sp>
       <p:pic>
         <p:nvPicPr>
-          <p:cNvPr id="22" name=""/>
+          <p:cNvPr id="24" name=""/>
           <p:cNvPicPr>
             <a:picLocks xmlns:a="http://schemas.openxmlformats.org/drawingml/2006/main" noChangeAspect="1"/>
           </p:cNvPicPr>
           <p:nvPr/>
         </p:nvPicPr>
         <p:blipFill>
-          <a:blip xmlns:r="http://schemas.openxmlformats.org/officeDocument/2006/relationships" xmlns:a="http://schemas.openxmlformats.org/drawingml/2006/main" r:embed="Rea0c3beaf0d94010"/>
+          <a:blip xmlns:r="http://schemas.openxmlformats.org/officeDocument/2006/relationships" xmlns:a="http://schemas.openxmlformats.org/drawingml/2006/main" r:embed="Rb131826b7ce14bd2"/>
           <a:stretch xmlns:a="http://schemas.openxmlformats.org/drawingml/2006/main"/>
         </p:blipFill>
         <p:spPr>
@@ -7538,6 +7645,7 @@
           <a:lstStyle xmlns:a="http://schemas.openxmlformats.org/drawingml/2006/main"/>
           <a:p xmlns:a="http://schemas.openxmlformats.org/drawingml/2006/main">
             <a:pPr algn="l">
+              <a:buNone/>
               <a:defRPr sz="1200" b="1">
                 <a:solidFill>
                   <a:srgbClr val="FF6B35"/>
@@ -7578,6 +7686,7 @@
           <a:lstStyle xmlns:a="http://schemas.openxmlformats.org/drawingml/2006/main"/>
           <a:p xmlns:a="http://schemas.openxmlformats.org/drawingml/2006/main">
             <a:pPr algn="l">
+              <a:buNone/>
               <a:defRPr sz="3375" b="1">
                 <a:solidFill>
                   <a:srgbClr val="0B0D10"/>
@@ -7699,6 +7808,7 @@
           <a:lstStyle xmlns:a="http://schemas.openxmlformats.org/drawingml/2006/main"/>
           <a:p xmlns:a="http://schemas.openxmlformats.org/drawingml/2006/main">
             <a:pPr algn="l">
+              <a:buNone/>
               <a:defRPr sz="1950" b="1">
                 <a:solidFill>
                   <a:srgbClr val="0B0D10"/>
@@ -7739,6 +7849,7 @@
           <a:lstStyle xmlns:a="http://schemas.openxmlformats.org/drawingml/2006/main"/>
           <a:p xmlns:a="http://schemas.openxmlformats.org/drawingml/2006/main">
             <a:pPr algn="l">
+              <a:buNone/>
               <a:defRPr sz="1650" b="0">
                 <a:solidFill>
                   <a:srgbClr val="0B0D10"/>
@@ -7783,6 +7894,7 @@
           <a:lstStyle xmlns:a="http://schemas.openxmlformats.org/drawingml/2006/main"/>
           <a:p xmlns:a="http://schemas.openxmlformats.org/drawingml/2006/main">
             <a:pPr algn="l">
+              <a:buNone/>
               <a:defRPr sz="1950" b="1">
                 <a:solidFill>
                   <a:srgbClr val="FF6B35"/>
@@ -7823,6 +7935,7 @@
           <a:lstStyle xmlns:a="http://schemas.openxmlformats.org/drawingml/2006/main"/>
           <a:p xmlns:a="http://schemas.openxmlformats.org/drawingml/2006/main">
             <a:pPr algn="l">
+              <a:buNone/>
               <a:defRPr sz="1575" b="1">
                 <a:solidFill>
                   <a:srgbClr val="0B0D10"/>
@@ -7863,6 +7976,7 @@
           <a:lstStyle xmlns:a="http://schemas.openxmlformats.org/drawingml/2006/main"/>
           <a:p xmlns:a="http://schemas.openxmlformats.org/drawingml/2006/main">
             <a:pPr algn="l">
+              <a:buNone/>
               <a:defRPr sz="1950" b="1">
                 <a:solidFill>
                   <a:srgbClr val="0B0D10"/>
@@ -7903,6 +8017,7 @@
           <a:lstStyle xmlns:a="http://schemas.openxmlformats.org/drawingml/2006/main"/>
           <a:p xmlns:a="http://schemas.openxmlformats.org/drawingml/2006/main">
             <a:pPr algn="l">
+              <a:buNone/>
               <a:defRPr sz="1650" b="0">
                 <a:solidFill>
                   <a:srgbClr val="0B0D10"/>
@@ -7946,6 +8061,7 @@
           <a:lstStyle xmlns:a="http://schemas.openxmlformats.org/drawingml/2006/main"/>
           <a:p xmlns:a="http://schemas.openxmlformats.org/drawingml/2006/main">
             <a:pPr algn="l">
+              <a:buNone/>
               <a:defRPr sz="1350" b="0">
                 <a:solidFill>
                   <a:srgbClr val="555B63"/>
@@ -7986,6 +8102,7 @@
           <a:lstStyle xmlns:a="http://schemas.openxmlformats.org/drawingml/2006/main"/>
           <a:p xmlns:a="http://schemas.openxmlformats.org/drawingml/2006/main">
             <a:pPr algn="r">
+              <a:buNone/>
               <a:defRPr sz="1125" b="0">
                 <a:solidFill>
                   <a:srgbClr val="555B63"/>

</xml_diff>

<commit_message>
docs: synchronize papers and defense deck with GhostGraph v2
</commit_message>
<xml_diff>
--- a/competition/EraSeMap_RKNP_ISEF_RU.pptx
+++ b/competition/EraSeMap_RKNP_ISEF_RU.pptx
@@ -2,23 +2,25 @@
 <file path=ppt/presentation.xml><?xml version="1.0" encoding="utf-8"?>
 <p:presentation xmlns:p="http://schemas.openxmlformats.org/presentationml/2006/main">
   <p:sldMasterIdLst>
-    <p:sldMasterId xmlns:r="http://schemas.openxmlformats.org/officeDocument/2006/relationships" id="2147483648" r:id="R3dd3c923f25948da"/>
+    <p:sldMasterId xmlns:r="http://schemas.openxmlformats.org/officeDocument/2006/relationships" id="2147483648" r:id="Re4baf87b8571477d"/>
   </p:sldMasterIdLst>
   <p:notesMasterIdLst>
-    <p:notesMasterId xmlns:r="http://schemas.openxmlformats.org/officeDocument/2006/relationships" r:id="R541015338a994eaa"/>
+    <p:notesMasterId xmlns:r="http://schemas.openxmlformats.org/officeDocument/2006/relationships" r:id="R0ca15390281a4c1e"/>
   </p:notesMasterIdLst>
   <p:sldIdLst>
-    <p:sldId xmlns:r="http://schemas.openxmlformats.org/officeDocument/2006/relationships" id="256" r:id="Rc8a63c9932494367"/>
-    <p:sldId xmlns:r="http://schemas.openxmlformats.org/officeDocument/2006/relationships" id="257" r:id="R3cdae93c92a54bcc"/>
-    <p:sldId xmlns:r="http://schemas.openxmlformats.org/officeDocument/2006/relationships" id="258" r:id="R7d77851f41554637"/>
-    <p:sldId xmlns:r="http://schemas.openxmlformats.org/officeDocument/2006/relationships" id="259" r:id="R3985fba6de6544c9"/>
-    <p:sldId xmlns:r="http://schemas.openxmlformats.org/officeDocument/2006/relationships" id="260" r:id="R12ed691edcd24152"/>
-    <p:sldId xmlns:r="http://schemas.openxmlformats.org/officeDocument/2006/relationships" id="261" r:id="Rbe5ebb3f240d4fae"/>
-    <p:sldId xmlns:r="http://schemas.openxmlformats.org/officeDocument/2006/relationships" id="262" r:id="Rc404a70400da47aa"/>
-    <p:sldId xmlns:r="http://schemas.openxmlformats.org/officeDocument/2006/relationships" id="263" r:id="R0d7e8dc796f94006"/>
-    <p:sldId xmlns:r="http://schemas.openxmlformats.org/officeDocument/2006/relationships" id="264" r:id="Rca73acb9bd1542b9"/>
-    <p:sldId xmlns:r="http://schemas.openxmlformats.org/officeDocument/2006/relationships" id="265" r:id="R4fa01144ca0b4fa3"/>
-    <p:sldId xmlns:r="http://schemas.openxmlformats.org/officeDocument/2006/relationships" id="266" r:id="Re5e2326e24a14471"/>
+    <p:sldId xmlns:r="http://schemas.openxmlformats.org/officeDocument/2006/relationships" id="256" r:id="R85d989a87b994158"/>
+    <p:sldId xmlns:r="http://schemas.openxmlformats.org/officeDocument/2006/relationships" id="257" r:id="R37e86a87c7114b5c"/>
+    <p:sldId xmlns:r="http://schemas.openxmlformats.org/officeDocument/2006/relationships" id="258" r:id="Rc63d747e38524c43"/>
+    <p:sldId xmlns:r="http://schemas.openxmlformats.org/officeDocument/2006/relationships" id="259" r:id="R904b86407f1942af"/>
+    <p:sldId xmlns:r="http://schemas.openxmlformats.org/officeDocument/2006/relationships" id="260" r:id="R3cfe274f290c40af"/>
+    <p:sldId xmlns:r="http://schemas.openxmlformats.org/officeDocument/2006/relationships" id="261" r:id="R445a4b43df8543b5"/>
+    <p:sldId xmlns:r="http://schemas.openxmlformats.org/officeDocument/2006/relationships" id="262" r:id="R13656b7bcc4343bb"/>
+    <p:sldId xmlns:r="http://schemas.openxmlformats.org/officeDocument/2006/relationships" id="263" r:id="R30e90c30a56242d6"/>
+    <p:sldId xmlns:r="http://schemas.openxmlformats.org/officeDocument/2006/relationships" id="264" r:id="Rc7f396e9ebc14929"/>
+    <p:sldId xmlns:r="http://schemas.openxmlformats.org/officeDocument/2006/relationships" id="265" r:id="Rdc2c0cfa1ada492f"/>
+    <p:sldId xmlns:r="http://schemas.openxmlformats.org/officeDocument/2006/relationships" id="266" r:id="R08503a3d744749cc"/>
+    <p:sldId xmlns:r="http://schemas.openxmlformats.org/officeDocument/2006/relationships" id="267" r:id="Ra291ee1d47a14354"/>
+    <p:sldId xmlns:r="http://schemas.openxmlformats.org/officeDocument/2006/relationships" id="268" r:id="R406713be4e504493"/>
   </p:sldIdLst>
   <p:sldSz cx="12192000" cy="6858000"/>
   <p:notesSz cx="6858000" cy="9144000"/>
@@ -522,7 +524,7 @@
           <a:lstStyle xmlns:a="http://schemas.openxmlformats.org/drawingml/2006/main"/>
           <a:p xmlns:a="http://schemas.openxmlformats.org/drawingml/2006/main">
             <a:r>
-              <a:t>Это ключевой слайд честности. Скажите: технически путь к 9.5 готов, но фактическая независимость остаётся 7.8.</a:t>
+              <a:t>Реальны процессы PostgreSQL, Redis и Qdrant. Данные synthetic; это не production latency FaceID/eGov.</a:t>
             </a:r>
           </a:p>
         </p:txBody>
@@ -592,6 +594,146 @@
           <a:lstStyle xmlns:a="http://schemas.openxmlformats.org/drawingml/2006/main"/>
           <a:p xmlns:a="http://schemas.openxmlformats.org/drawingml/2006/main">
             <a:r>
+              <a:t>Если жюри спросит «где новизна», ответьте одной фразой из центральной колонки и сразу назовите prior art.</a:t>
+            </a:r>
+          </a:p>
+        </p:txBody>
+      </p:sp>
+      <p:sp>
+        <p:nvSpPr>
+          <p:cNvPr id="4" name="Slide Number Placeholder 3"/>
+          <p:cNvSpPr>
+            <a:spLocks xmlns:a="http://schemas.openxmlformats.org/drawingml/2006/main" noGrp="1"/>
+          </p:cNvSpPr>
+          <p:nvPr>
+            <p:ph type="sldNum" idx="5"/>
+          </p:nvPr>
+        </p:nvSpPr>
+        <p:spPr/>
+        <p:txBody>
+          <a:bodyPr xmlns:a="http://schemas.openxmlformats.org/drawingml/2006/main"/>
+          <a:lstStyle xmlns:a="http://schemas.openxmlformats.org/drawingml/2006/main"/>
+          <a:p xmlns:a="http://schemas.openxmlformats.org/drawingml/2006/main"/>
+        </p:txBody>
+      </p:sp>
+    </p:spTree>
+  </p:cSld>
+  <p:clrMapOvr>
+    <a:masterClrMapping xmlns:a="http://schemas.openxmlformats.org/drawingml/2006/main"/>
+  </p:clrMapOvr>
+</p:notes>
+</file>
+
+<file path=ppt/notesSlides/notesSlide12.xml><?xml version="1.0" encoding="utf-8"?>
+<p:notes xmlns:p="http://schemas.openxmlformats.org/presentationml/2006/main">
+  <p:cSld>
+    <p:spTree>
+      <p:nvGrpSpPr>
+        <p:cNvPr id="1" name=""/>
+        <p:cNvGrpSpPr/>
+        <p:nvPr/>
+      </p:nvGrpSpPr>
+      <p:grpSpPr>
+        <a:xfrm xmlns:a="http://schemas.openxmlformats.org/drawingml/2006/main"/>
+      </p:grpSpPr>
+      <p:sp>
+        <p:nvSpPr>
+          <p:cNvPr id="2" name="Slide Image Placeholder 1"/>
+          <p:cNvSpPr>
+            <a:spLocks xmlns:a="http://schemas.openxmlformats.org/drawingml/2006/main" noGrp="1"/>
+          </p:cNvSpPr>
+          <p:nvPr>
+            <p:ph type="sldImg" idx="0"/>
+          </p:nvPr>
+        </p:nvSpPr>
+        <p:spPr/>
+      </p:sp>
+      <p:sp>
+        <p:nvSpPr>
+          <p:cNvPr id="3" name="Notes Placeholder 2"/>
+          <p:cNvSpPr>
+            <a:spLocks xmlns:a="http://schemas.openxmlformats.org/drawingml/2006/main" noGrp="1"/>
+          </p:cNvSpPr>
+          <p:nvPr>
+            <p:ph type="body" idx="1"/>
+          </p:nvPr>
+        </p:nvSpPr>
+        <p:spPr/>
+        <p:txBody>
+          <a:bodyPr xmlns:a="http://schemas.openxmlformats.org/drawingml/2006/main"/>
+          <a:lstStyle xmlns:a="http://schemas.openxmlformats.org/drawingml/2006/main"/>
+          <a:p xmlns:a="http://schemas.openxmlformats.org/drawingml/2006/main">
+            <a:r>
+              <a:t>Это ключевой слайд честности. Скажите: технически путь к 9.5 готов, но фактическая независимость остаётся 7.8.</a:t>
+            </a:r>
+          </a:p>
+        </p:txBody>
+      </p:sp>
+      <p:sp>
+        <p:nvSpPr>
+          <p:cNvPr id="4" name="Slide Number Placeholder 3"/>
+          <p:cNvSpPr>
+            <a:spLocks xmlns:a="http://schemas.openxmlformats.org/drawingml/2006/main" noGrp="1"/>
+          </p:cNvSpPr>
+          <p:nvPr>
+            <p:ph type="sldNum" idx="5"/>
+          </p:nvPr>
+        </p:nvSpPr>
+        <p:spPr/>
+        <p:txBody>
+          <a:bodyPr xmlns:a="http://schemas.openxmlformats.org/drawingml/2006/main"/>
+          <a:lstStyle xmlns:a="http://schemas.openxmlformats.org/drawingml/2006/main"/>
+          <a:p xmlns:a="http://schemas.openxmlformats.org/drawingml/2006/main"/>
+        </p:txBody>
+      </p:sp>
+    </p:spTree>
+  </p:cSld>
+  <p:clrMapOvr>
+    <a:masterClrMapping xmlns:a="http://schemas.openxmlformats.org/drawingml/2006/main"/>
+  </p:clrMapOvr>
+</p:notes>
+</file>
+
+<file path=ppt/notesSlides/notesSlide13.xml><?xml version="1.0" encoding="utf-8"?>
+<p:notes xmlns:p="http://schemas.openxmlformats.org/presentationml/2006/main">
+  <p:cSld>
+    <p:spTree>
+      <p:nvGrpSpPr>
+        <p:cNvPr id="1" name=""/>
+        <p:cNvGrpSpPr/>
+        <p:nvPr/>
+      </p:nvGrpSpPr>
+      <p:grpSpPr>
+        <a:xfrm xmlns:a="http://schemas.openxmlformats.org/drawingml/2006/main"/>
+      </p:grpSpPr>
+      <p:sp>
+        <p:nvSpPr>
+          <p:cNvPr id="2" name="Slide Image Placeholder 1"/>
+          <p:cNvSpPr>
+            <a:spLocks xmlns:a="http://schemas.openxmlformats.org/drawingml/2006/main" noGrp="1"/>
+          </p:cNvSpPr>
+          <p:nvPr>
+            <p:ph type="sldImg" idx="0"/>
+          </p:nvPr>
+        </p:nvSpPr>
+        <p:spPr/>
+      </p:sp>
+      <p:sp>
+        <p:nvSpPr>
+          <p:cNvPr id="3" name="Notes Placeholder 2"/>
+          <p:cNvSpPr>
+            <a:spLocks xmlns:a="http://schemas.openxmlformats.org/drawingml/2006/main" noGrp="1"/>
+          </p:cNvSpPr>
+          <p:nvPr>
+            <p:ph type="body" idx="1"/>
+          </p:nvPr>
+        </p:nvSpPr>
+        <p:spPr/>
+        <p:txBody>
+          <a:bodyPr xmlns:a="http://schemas.openxmlformats.org/drawingml/2006/main"/>
+          <a:lstStyle xmlns:a="http://schemas.openxmlformats.org/drawingml/2006/main"/>
+          <a:p xmlns:a="http://schemas.openxmlformats.org/drawingml/2006/main">
+            <a:r>
               <a:t>Завершите: ценность EraSeMap не в обещании идеального удаления, а в отказе объявлять успех без проверяемого основания.</a:t>
             </a:r>
           </a:p>
@@ -1152,7 +1294,7 @@
           <a:lstStyle xmlns:a="http://schemas.openxmlformats.org/drawingml/2006/main"/>
           <a:p xmlns:a="http://schemas.openxmlformats.org/drawingml/2006/main">
             <a:r>
-              <a:t>Если жюри спросит «где новизна», ответьте одной фразой из центральной колонки и сразу назовите prior art.</a:t>
+              <a:t>Сформулируйте вклад как композицию. Не заявляйте изобретение lineage, подписи, min-cut или machine unlearning по отдельности.</a:t>
             </a:r>
           </a:p>
         </p:txBody>
@@ -1220,7 +1362,7 @@
   </p:cSld>
   <p:clrMap bg1="lt1" tx1="dk1" bg2="lt2" tx2="dk2" accent1="accent1" accent2="accent2" accent3="accent3" accent4="accent4" accent5="accent5" accent6="accent6" hlink="hlink" folHlink="folHlink"/>
   <p:sldLayoutIdLst>
-    <p:sldLayoutId xmlns:r="http://schemas.openxmlformats.org/officeDocument/2006/relationships" id="2147483649" r:id="R26510f37b931411c"/>
+    <p:sldLayoutId xmlns:r="http://schemas.openxmlformats.org/officeDocument/2006/relationships" id="2147483649" r:id="R44154ae30a114e4c"/>
   </p:sldLayoutIdLst>
   <p:txStyles>
     <p:titleStyle>
@@ -2025,6 +2167,145 @@
 </c:chartSpace>
 </file>
 
+<file path=ppt/slides/charts/chart3.xml><?xml version="1.0" encoding="utf-8"?>
+<c:chartSpace xmlns:c="http://schemas.openxmlformats.org/drawingml/2006/chart">
+  <c:lang val="en-US"/>
+  <c:chart>
+    <c:plotArea>
+      <c:barChart>
+        <c:barDir val="col"/>
+        <c:varyColors val="0"/>
+        <c:ser>
+          <c:idx val="0"/>
+          <c:order val="0"/>
+          <c:tx>
+            <c:v>Relative bytes written</c:v>
+          </c:tx>
+          <c:spPr>
+            <a:solidFill xmlns:a="http://schemas.openxmlformats.org/drawingml/2006/main">
+              <a:srgbClr val="0B0D10"/>
+            </a:solidFill>
+          </c:spPr>
+          <c:cat>
+            <c:strLit>
+              <c:ptCount val="2"/>
+              <c:pt idx="0">
+                <c:v>Active minimax</c:v>
+              </c:pt>
+              <c:pt idx="1">
+                <c:v>Frozen random</c:v>
+              </c:pt>
+            </c:strLit>
+          </c:cat>
+          <c:val>
+            <c:numLit>
+              <c:formatCode>General</c:formatCode>
+              <c:ptCount val="2"/>
+              <c:pt idx="0">
+                <c:v>7</c:v>
+              </c:pt>
+              <c:pt idx="1">
+                <c:v>13</c:v>
+              </c:pt>
+            </c:numLit>
+          </c:val>
+        </c:ser>
+        <c:dLbls>
+          <c:dLblPos val="outEnd"/>
+          <c:showLegendKey val="0"/>
+          <c:showVal val="1"/>
+          <c:showCatName val="0"/>
+          <c:showSerName val="0"/>
+          <c:showPercent val="0"/>
+          <c:showBubbleSize val="0"/>
+          <c:showLeaderLines val="0"/>
+        </c:dLbls>
+        <c:axId val="48650112"/>
+        <c:axId val="48672768"/>
+      </c:barChart>
+      <c:catAx>
+        <c:axId val="48650112"/>
+        <c:scaling>
+          <c:orientation val="minMax"/>
+        </c:scaling>
+        <c:delete val="0"/>
+        <c:axPos val="b"/>
+        <c:majorGridlines>
+          <c:spPr>
+            <a:ln xmlns:a="http://schemas.openxmlformats.org/drawingml/2006/main" w="9525">
+              <a:solidFill>
+                <a:srgbClr val="B8BCC4"/>
+              </a:solidFill>
+              <a:prstDash val="solid"/>
+            </a:ln>
+          </c:spPr>
+        </c:majorGridlines>
+        <c:numFmt formatCode="General"/>
+        <c:majorTickMark val="none"/>
+        <c:minorTickMark val="none"/>
+        <c:spPr>
+          <a:ln xmlns:a="http://schemas.openxmlformats.org/drawingml/2006/main" w="9525">
+            <a:solidFill>
+              <a:srgbClr val="D4D4D4"/>
+            </a:solidFill>
+            <a:prstDash val="solid"/>
+          </a:ln>
+        </c:spPr>
+        <c:txPr>
+          <a:bodyPr xmlns:a="http://schemas.openxmlformats.org/drawingml/2006/main" anchorCtr="1"/>
+          <a:lstStyle xmlns:a="http://schemas.openxmlformats.org/drawingml/2006/main"/>
+          <a:p xmlns:a="http://schemas.openxmlformats.org/drawingml/2006/main">
+            <a:pPr>
+              <a:defRPr>
+                <a:solidFill>
+                  <a:srgbClr val="666666"/>
+                </a:solidFill>
+              </a:defRPr>
+            </a:pPr>
+          </a:p>
+        </c:txPr>
+        <c:crossAx val="48672768"/>
+      </c:catAx>
+      <c:valAx>
+        <c:axId val="48672768"/>
+        <c:scaling>
+          <c:orientation val="minMax"/>
+        </c:scaling>
+        <c:delete val="1"/>
+        <c:axPos val="l"/>
+        <c:numFmt formatCode="General"/>
+        <c:majorTickMark val="none"/>
+        <c:minorTickMark val="none"/>
+        <c:spPr>
+          <a:ln xmlns:a="http://schemas.openxmlformats.org/drawingml/2006/main" w="9525">
+            <a:solidFill>
+              <a:srgbClr val="D4D4D4"/>
+            </a:solidFill>
+            <a:prstDash val="solid"/>
+          </a:ln>
+        </c:spPr>
+        <c:txPr>
+          <a:bodyPr xmlns:a="http://schemas.openxmlformats.org/drawingml/2006/main" anchorCtr="1"/>
+          <a:lstStyle xmlns:a="http://schemas.openxmlformats.org/drawingml/2006/main"/>
+          <a:p xmlns:a="http://schemas.openxmlformats.org/drawingml/2006/main">
+            <a:pPr>
+              <a:defRPr>
+                <a:solidFill>
+                  <a:srgbClr val="666666"/>
+                </a:solidFill>
+              </a:defRPr>
+            </a:pPr>
+          </a:p>
+        </c:txPr>
+        <c:crossAx val="48650112"/>
+        <c:crossBetween val="between"/>
+      </c:valAx>
+    </c:plotArea>
+    <c:plotVisOnly val="1"/>
+  </c:chart>
+</c:chartSpace>
+</file>
+
 <file path=ppt/slides/slide1.xml><?xml version="1.0" encoding="utf-8"?>
 <p:sld xmlns:p="http://schemas.openxmlformats.org/presentationml/2006/main">
   <p:cSld>
@@ -2444,10 +2725,10 @@
       </p:grpSpPr>
       <p:sp>
         <p:nvSpPr>
-          <p:cNvPr id="17" name="text-42-38">
-            <a:extLst xmlns:a="http://schemas.openxmlformats.org/drawingml/2006/main">
-              <a:ext uri="{FF2B5EF4-FFF2-40B4-BE49-F238E27FC236}">
-                <a16:creationId xmlns:a16="http://schemas.microsoft.com/office/drawing/2014/main" id="{096D2445-227C-4447-8399-FA96923F8557}"/>
+          <p:cNvPr id="11" name="text-42-38">
+            <a:extLst xmlns:a="http://schemas.openxmlformats.org/drawingml/2006/main">
+              <a:ext uri="{FF2B5EF4-FFF2-40B4-BE49-F238E27FC236}">
+                <a16:creationId xmlns:a16="http://schemas.microsoft.com/office/drawing/2014/main" id="{B22BBC53-C619-4A2B-839F-7CBED54D09FA}"/>
               </a:ext>
             </a:extLst>
           </p:cNvPr>
@@ -2459,7 +2740,7 @@
         <p:spPr>
           <a:xfrm xmlns:a="http://schemas.openxmlformats.org/drawingml/2006/main">
             <a:off x="400050" y="361950"/>
-            <a:ext cx="3905250" cy="266700"/>
+            <a:ext cx="4000500" cy="266700"/>
           </a:xfrm>
           <a:prstGeom xmlns:a="http://schemas.openxmlformats.org/drawingml/2006/main" prst="rect">
             <a:avLst/>
@@ -2478,7 +2759,7 @@
               </a:defRPr>
             </a:pPr>
             <a:r>
-              <a:t>09  Доказательная лестница</a:t>
+              <a:t>09  GhostGraph result</a:t>
             </a:r>
           </a:p>
         </p:txBody>
@@ -2488,7 +2769,7 @@
           <p:cNvPr id="2" name="text-42-84">
             <a:extLst xmlns:a="http://schemas.openxmlformats.org/drawingml/2006/main">
               <a:ext uri="{FF2B5EF4-FFF2-40B4-BE49-F238E27FC236}">
-                <a16:creationId xmlns:a16="http://schemas.microsoft.com/office/drawing/2014/main" id="{19E14A2B-DF73-4819-96D1-9B256F982F6D}"/>
+                <a16:creationId xmlns:a16="http://schemas.microsoft.com/office/drawing/2014/main" id="{D185CEB2-B25C-43E7-8597-24C78B8E443E}"/>
               </a:ext>
             </a:extLst>
           </p:cNvPr>
@@ -2500,7 +2781,7 @@
         <p:spPr>
           <a:xfrm xmlns:a="http://schemas.openxmlformats.org/drawingml/2006/main">
             <a:off x="400050" y="800100"/>
-            <a:ext cx="10287000" cy="647700"/>
+            <a:ext cx="10668000" cy="647700"/>
           </a:xfrm>
           <a:prstGeom xmlns:a="http://schemas.openxmlformats.org/drawingml/2006/main" prst="rect">
             <a:avLst/>
@@ -2519,508 +2800,249 @@
               </a:defRPr>
             </a:pPr>
             <a:r>
-              <a:t>Readiness нельзя выдавать за independence</a:t>
-            </a:r>
-          </a:p>
-        </p:txBody>
-      </p:sp>
-      <p:sp>
-        <p:nvSpPr>
-          <p:cNvPr id="3" name="evidence-current">
-            <a:extLst xmlns:a="http://schemas.openxmlformats.org/drawingml/2006/main">
-              <a:ext uri="{FF2B5EF4-FFF2-40B4-BE49-F238E27FC236}">
-                <a16:creationId xmlns:a16="http://schemas.microsoft.com/office/drawing/2014/main" id="{4522758C-10EC-47AA-9A7F-E7FA866047BC}"/>
-              </a:ext>
-            </a:extLst>
-          </p:cNvPr>
-          <p:cNvSpPr>
-            <a:spLocks xmlns:a="http://schemas.openxmlformats.org/drawingml/2006/main" noGrp="1"/>
-          </p:cNvSpPr>
-          <p:nvPr/>
-        </p:nvSpPr>
-        <p:spPr>
-          <a:xfrm xmlns:a="http://schemas.openxmlformats.org/drawingml/2006/main">
-            <a:off x="400050" y="2114550"/>
-            <a:ext cx="3381375" cy="3257550"/>
+              <a:t>Активный запрос находит путь без ложной уверенности</a:t>
+            </a:r>
+          </a:p>
+        </p:txBody>
+      </p:sp>
+      <p:sp>
+        <p:nvSpPr>
+          <p:cNvPr id="3" name="systems-chart-frame">
+            <a:extLst xmlns:a="http://schemas.openxmlformats.org/drawingml/2006/main">
+              <a:ext uri="{FF2B5EF4-FFF2-40B4-BE49-F238E27FC236}">
+                <a16:creationId xmlns:a16="http://schemas.microsoft.com/office/drawing/2014/main" id="{7347690E-4A98-40BD-8A7C-733BB2E49D89}"/>
+              </a:ext>
+            </a:extLst>
+          </p:cNvPr>
+          <p:cNvSpPr>
+            <a:spLocks xmlns:a="http://schemas.openxmlformats.org/drawingml/2006/main" noGrp="1"/>
+          </p:cNvSpPr>
+          <p:nvPr/>
+        </p:nvSpPr>
+        <p:spPr>
+          <a:xfrm xmlns:a="http://schemas.openxmlformats.org/drawingml/2006/main">
+            <a:off x="400050" y="1752600"/>
+            <a:ext cx="6191250" cy="4095750"/>
           </a:xfrm>
           <a:prstGeom xmlns:a="http://schemas.openxmlformats.org/drawingml/2006/main" prst="rect">
             <a:avLst/>
           </a:prstGeom>
           <a:solidFill xmlns:a="http://schemas.openxmlformats.org/drawingml/2006/main">
-            <a:srgbClr val="EDEDED"/>
+            <a:srgbClr val="F4F5F6"/>
           </a:solidFill>
         </p:spPr>
       </p:sp>
       <p:sp>
         <p:nvSpPr>
-          <p:cNvPr id="4" name="evidence-next">
-            <a:extLst xmlns:a="http://schemas.openxmlformats.org/drawingml/2006/main">
-              <a:ext uri="{FF2B5EF4-FFF2-40B4-BE49-F238E27FC236}">
-                <a16:creationId xmlns:a16="http://schemas.microsoft.com/office/drawing/2014/main" id="{1A91BD7B-A987-424E-8056-4C3A1BC0A4E9}"/>
-              </a:ext>
-            </a:extLst>
-          </p:cNvPr>
-          <p:cNvSpPr>
-            <a:spLocks xmlns:a="http://schemas.openxmlformats.org/drawingml/2006/main" noGrp="1"/>
-          </p:cNvSpPr>
-          <p:nvPr/>
-        </p:nvSpPr>
-        <p:spPr>
-          <a:xfrm xmlns:a="http://schemas.openxmlformats.org/drawingml/2006/main">
-            <a:off x="4400550" y="1657350"/>
-            <a:ext cx="3381375" cy="3714750"/>
-          </a:xfrm>
-          <a:prstGeom xmlns:a="http://schemas.openxmlformats.org/drawingml/2006/main" prst="rect">
-            <a:avLst/>
-          </a:prstGeom>
-          <a:solidFill xmlns:a="http://schemas.openxmlformats.org/drawingml/2006/main">
-            <a:srgbClr val="F7E8E3"/>
-          </a:solidFill>
-        </p:spPr>
-      </p:sp>
-      <p:sp>
-        <p:nvSpPr>
-          <p:cNvPr id="5" name="evidence-org">
-            <a:extLst xmlns:a="http://schemas.openxmlformats.org/drawingml/2006/main">
-              <a:ext uri="{FF2B5EF4-FFF2-40B4-BE49-F238E27FC236}">
-                <a16:creationId xmlns:a16="http://schemas.microsoft.com/office/drawing/2014/main" id="{03EF12D5-9E7E-43A9-8496-B2924530B49B}"/>
-              </a:ext>
-            </a:extLst>
-          </p:cNvPr>
-          <p:cNvSpPr>
-            <a:spLocks xmlns:a="http://schemas.openxmlformats.org/drawingml/2006/main" noGrp="1"/>
-          </p:cNvSpPr>
-          <p:nvPr/>
-        </p:nvSpPr>
-        <p:spPr>
-          <a:xfrm xmlns:a="http://schemas.openxmlformats.org/drawingml/2006/main">
-            <a:off x="8401050" y="1200150"/>
-            <a:ext cx="3381375" cy="4171950"/>
-          </a:xfrm>
-          <a:prstGeom xmlns:a="http://schemas.openxmlformats.org/drawingml/2006/main" prst="rect">
-            <a:avLst/>
-          </a:prstGeom>
-          <a:solidFill xmlns:a="http://schemas.openxmlformats.org/drawingml/2006/main">
-            <a:srgbClr val="EDEDED"/>
-          </a:solidFill>
-        </p:spPr>
-      </p:sp>
-      <p:sp>
-        <p:nvSpPr>
-          <p:cNvPr id="6" name="text-69-254">
-            <a:extLst xmlns:a="http://schemas.openxmlformats.org/drawingml/2006/main">
-              <a:ext uri="{FF2B5EF4-FFF2-40B4-BE49-F238E27FC236}">
-                <a16:creationId xmlns:a16="http://schemas.microsoft.com/office/drawing/2014/main" id="{FEBA4D97-4910-4EC8-9008-1CC8E344CEC3}"/>
-              </a:ext>
-            </a:extLst>
-          </p:cNvPr>
-          <p:cNvSpPr>
-            <a:spLocks xmlns:a="http://schemas.openxmlformats.org/drawingml/2006/main" noGrp="1"/>
-          </p:cNvSpPr>
-          <p:nvPr/>
-        </p:nvSpPr>
-        <p:spPr>
-          <a:xfrm xmlns:a="http://schemas.openxmlformats.org/drawingml/2006/main">
-            <a:off x="657225" y="2419350"/>
-            <a:ext cx="2762250" cy="838200"/>
-          </a:xfrm>
-          <a:prstGeom xmlns:a="http://schemas.openxmlformats.org/drawingml/2006/main" prst="rect">
-            <a:avLst/>
-          </a:prstGeom>
-        </p:spPr>
-        <p:txBody>
-          <a:bodyPr xmlns:a="http://schemas.openxmlformats.org/drawingml/2006/main" lIns="0" tIns="0" rIns="0" bIns="0" anchor="t"/>
-          <a:lstStyle xmlns:a="http://schemas.openxmlformats.org/drawingml/2006/main"/>
-          <a:p xmlns:a="http://schemas.openxmlformats.org/drawingml/2006/main">
-            <a:pPr algn="l">
-              <a:buNone/>
-              <a:defRPr sz="4950" b="1">
+          <p:cNvPr id="4" name="text-760-205">
+            <a:extLst xmlns:a="http://schemas.openxmlformats.org/drawingml/2006/main">
+              <a:ext uri="{FF2B5EF4-FFF2-40B4-BE49-F238E27FC236}">
+                <a16:creationId xmlns:a16="http://schemas.microsoft.com/office/drawing/2014/main" id="{22CA30AA-F2F1-4978-BE4A-0059756DBF6D}"/>
+              </a:ext>
+            </a:extLst>
+          </p:cNvPr>
+          <p:cNvSpPr>
+            <a:spLocks xmlns:a="http://schemas.openxmlformats.org/drawingml/2006/main" noGrp="1"/>
+          </p:cNvSpPr>
+          <p:nvPr/>
+        </p:nvSpPr>
+        <p:spPr>
+          <a:xfrm xmlns:a="http://schemas.openxmlformats.org/drawingml/2006/main">
+            <a:off x="7239000" y="1952625"/>
+            <a:ext cx="3810000" cy="819150"/>
+          </a:xfrm>
+          <a:prstGeom xmlns:a="http://schemas.openxmlformats.org/drawingml/2006/main" prst="rect">
+            <a:avLst/>
+          </a:prstGeom>
+        </p:spPr>
+        <p:txBody>
+          <a:bodyPr xmlns:a="http://schemas.openxmlformats.org/drawingml/2006/main" lIns="0" tIns="0" rIns="0" bIns="0" anchor="t"/>
+          <a:lstStyle xmlns:a="http://schemas.openxmlformats.org/drawingml/2006/main"/>
+          <a:p xmlns:a="http://schemas.openxmlformats.org/drawingml/2006/main">
+            <a:pPr algn="l">
+              <a:buNone/>
+              <a:defRPr sz="4650" b="1">
+                <a:solidFill>
+                  <a:srgbClr val="FF6B35"/>
+                </a:solidFill>
+              </a:defRPr>
+            </a:pPr>
+            <a:r>
+              <a:t>49</a:t>
+            </a:r>
+          </a:p>
+        </p:txBody>
+      </p:sp>
+      <p:sp>
+        <p:nvSpPr>
+          <p:cNvPr id="5" name="text-760-292">
+            <a:extLst xmlns:a="http://schemas.openxmlformats.org/drawingml/2006/main">
+              <a:ext uri="{FF2B5EF4-FFF2-40B4-BE49-F238E27FC236}">
+                <a16:creationId xmlns:a16="http://schemas.microsoft.com/office/drawing/2014/main" id="{63B30A08-B935-402E-B700-B27A3AB9BD67}"/>
+              </a:ext>
+            </a:extLst>
+          </p:cNvPr>
+          <p:cNvSpPr>
+            <a:spLocks xmlns:a="http://schemas.openxmlformats.org/drawingml/2006/main" noGrp="1"/>
+          </p:cNvSpPr>
+          <p:nvPr/>
+        </p:nvSpPr>
+        <p:spPr>
+          <a:xfrm xmlns:a="http://schemas.openxmlformats.org/drawingml/2006/main">
+            <a:off x="7239000" y="2781300"/>
+            <a:ext cx="4095750" cy="381000"/>
+          </a:xfrm>
+          <a:prstGeom xmlns:a="http://schemas.openxmlformats.org/drawingml/2006/main" prst="rect">
+            <a:avLst/>
+          </a:prstGeom>
+        </p:spPr>
+        <p:txBody>
+          <a:bodyPr xmlns:a="http://schemas.openxmlformats.org/drawingml/2006/main" lIns="0" tIns="0" rIns="0" bIns="0" anchor="t"/>
+          <a:lstStyle xmlns:a="http://schemas.openxmlformats.org/drawingml/2006/main"/>
+          <a:p xmlns:a="http://schemas.openxmlformats.org/drawingml/2006/main">
+            <a:pPr algn="l">
+              <a:buNone/>
+              <a:defRPr sz="1575" b="0">
+                <a:solidFill>
+                  <a:srgbClr val="555B63"/>
+                </a:solidFill>
+              </a:defRPr>
+            </a:pPr>
+            <a:r>
+              <a:t>probes у nonadaptive exhaustive; active minimax — 7</a:t>
+            </a:r>
+          </a:p>
+        </p:txBody>
+      </p:sp>
+      <p:sp>
+        <p:nvSpPr>
+          <p:cNvPr id="6" name="text-760-375">
+            <a:extLst xmlns:a="http://schemas.openxmlformats.org/drawingml/2006/main">
+              <a:ext uri="{FF2B5EF4-FFF2-40B4-BE49-F238E27FC236}">
+                <a16:creationId xmlns:a16="http://schemas.microsoft.com/office/drawing/2014/main" id="{879904AD-32AD-4B94-94A3-AADB2C923A7D}"/>
+              </a:ext>
+            </a:extLst>
+          </p:cNvPr>
+          <p:cNvSpPr>
+            <a:spLocks xmlns:a="http://schemas.openxmlformats.org/drawingml/2006/main" noGrp="1"/>
+          </p:cNvSpPr>
+          <p:nvPr/>
+        </p:nvSpPr>
+        <p:spPr>
+          <a:xfrm xmlns:a="http://schemas.openxmlformats.org/drawingml/2006/main">
+            <a:off x="7239000" y="3571875"/>
+            <a:ext cx="3810000" cy="819150"/>
+          </a:xfrm>
+          <a:prstGeom xmlns:a="http://schemas.openxmlformats.org/drawingml/2006/main" prst="rect">
+            <a:avLst/>
+          </a:prstGeom>
+        </p:spPr>
+        <p:txBody>
+          <a:bodyPr xmlns:a="http://schemas.openxmlformats.org/drawingml/2006/main" lIns="0" tIns="0" rIns="0" bIns="0" anchor="t"/>
+          <a:lstStyle xmlns:a="http://schemas.openxmlformats.org/drawingml/2006/main"/>
+          <a:p xmlns:a="http://schemas.openxmlformats.org/drawingml/2006/main">
+            <a:pPr algn="l">
+              <a:buNone/>
+              <a:defRPr sz="4650" b="1">
                 <a:solidFill>
                   <a:srgbClr val="0B0D10"/>
                 </a:solidFill>
               </a:defRPr>
             </a:pPr>
             <a:r>
-              <a:t>7.8</a:t>
-            </a:r>
-          </a:p>
-        </p:txBody>
-      </p:sp>
-      <p:sp>
-        <p:nvSpPr>
-          <p:cNvPr id="7" name="text-69-354">
-            <a:extLst xmlns:a="http://schemas.openxmlformats.org/drawingml/2006/main">
-              <a:ext uri="{FF2B5EF4-FFF2-40B4-BE49-F238E27FC236}">
-                <a16:creationId xmlns:a16="http://schemas.microsoft.com/office/drawing/2014/main" id="{B2C5A188-5587-4A4A-927A-A54D89FD78C2}"/>
-              </a:ext>
-            </a:extLst>
-          </p:cNvPr>
-          <p:cNvSpPr>
-            <a:spLocks xmlns:a="http://schemas.openxmlformats.org/drawingml/2006/main" noGrp="1"/>
-          </p:cNvSpPr>
-          <p:nvPr/>
-        </p:nvSpPr>
-        <p:spPr>
-          <a:xfrm xmlns:a="http://schemas.openxmlformats.org/drawingml/2006/main">
-            <a:off x="657225" y="3371850"/>
-            <a:ext cx="2762250" cy="361950"/>
-          </a:xfrm>
-          <a:prstGeom xmlns:a="http://schemas.openxmlformats.org/drawingml/2006/main" prst="rect">
-            <a:avLst/>
-          </a:prstGeom>
-        </p:spPr>
-        <p:txBody>
-          <a:bodyPr xmlns:a="http://schemas.openxmlformats.org/drawingml/2006/main" lIns="0" tIns="0" rIns="0" bIns="0" anchor="t"/>
-          <a:lstStyle xmlns:a="http://schemas.openxmlformats.org/drawingml/2006/main"/>
-          <a:p xmlns:a="http://schemas.openxmlformats.org/drawingml/2006/main">
-            <a:pPr algn="l">
-              <a:buNone/>
-              <a:defRPr sz="1950" b="1">
+              <a:t>5 / 5</a:t>
+            </a:r>
+          </a:p>
+        </p:txBody>
+      </p:sp>
+      <p:sp>
+        <p:nvSpPr>
+          <p:cNvPr id="7" name="text-760-462">
+            <a:extLst xmlns:a="http://schemas.openxmlformats.org/drawingml/2006/main">
+              <a:ext uri="{FF2B5EF4-FFF2-40B4-BE49-F238E27FC236}">
+                <a16:creationId xmlns:a16="http://schemas.microsoft.com/office/drawing/2014/main" id="{714F099B-C0BF-46E0-AFF8-2B6160933A73}"/>
+              </a:ext>
+            </a:extLst>
+          </p:cNvPr>
+          <p:cNvSpPr>
+            <a:spLocks xmlns:a="http://schemas.openxmlformats.org/drawingml/2006/main" noGrp="1"/>
+          </p:cNvSpPr>
+          <p:nvPr/>
+        </p:nvSpPr>
+        <p:spPr>
+          <a:xfrm xmlns:a="http://schemas.openxmlformats.org/drawingml/2006/main">
+            <a:off x="7239000" y="4400550"/>
+            <a:ext cx="4095750" cy="609600"/>
+          </a:xfrm>
+          <a:prstGeom xmlns:a="http://schemas.openxmlformats.org/drawingml/2006/main" prst="rect">
+            <a:avLst/>
+          </a:prstGeom>
+        </p:spPr>
+        <p:txBody>
+          <a:bodyPr xmlns:a="http://schemas.openxmlformats.org/drawingml/2006/main" lIns="0" tIns="0" rIns="0" bIns="0" anchor="t"/>
+          <a:lstStyle xmlns:a="http://schemas.openxmlformats.org/drawingml/2006/main"/>
+          <a:p xmlns:a="http://schemas.openxmlformats.org/drawingml/2006/main">
+            <a:pPr algn="l">
+              <a:buNone/>
+              <a:defRPr sz="1575" b="0">
+                <a:solidFill>
+                  <a:srgbClr val="555B63"/>
+                </a:solidFill>
+              </a:defRPr>
+            </a:pPr>
+            <a:r>
+              <a:t>live cases: Redis · Keycloak · MLflow · Qdrant</a:t>
+            </a:r>
+          </a:p>
+        </p:txBody>
+      </p:sp>
+      <p:sp>
+        <p:nvSpPr>
+          <p:cNvPr id="8" name="text-760-566">
+            <a:extLst xmlns:a="http://schemas.openxmlformats.org/drawingml/2006/main">
+              <a:ext uri="{FF2B5EF4-FFF2-40B4-BE49-F238E27FC236}">
+                <a16:creationId xmlns:a16="http://schemas.microsoft.com/office/drawing/2014/main" id="{3DB3D267-0E06-4790-869A-7153182F02BE}"/>
+              </a:ext>
+            </a:extLst>
+          </p:cNvPr>
+          <p:cNvSpPr>
+            <a:spLocks xmlns:a="http://schemas.openxmlformats.org/drawingml/2006/main" noGrp="1"/>
+          </p:cNvSpPr>
+          <p:nvPr/>
+        </p:nvSpPr>
+        <p:spPr>
+          <a:xfrm xmlns:a="http://schemas.openxmlformats.org/drawingml/2006/main">
+            <a:off x="7239000" y="5391150"/>
+            <a:ext cx="4191000" cy="552450"/>
+          </a:xfrm>
+          <a:prstGeom xmlns:a="http://schemas.openxmlformats.org/drawingml/2006/main" prst="rect">
+            <a:avLst/>
+          </a:prstGeom>
+        </p:spPr>
+        <p:txBody>
+          <a:bodyPr xmlns:a="http://schemas.openxmlformats.org/drawingml/2006/main" lIns="0" tIns="0" rIns="0" bIns="0" anchor="t"/>
+          <a:lstStyle xmlns:a="http://schemas.openxmlformats.org/drawingml/2006/main"/>
+          <a:p xmlns:a="http://schemas.openxmlformats.org/drawingml/2006/main">
+            <a:pPr algn="l">
+              <a:buNone/>
+              <a:defRPr sz="1350" b="1">
                 <a:solidFill>
                   <a:srgbClr val="0B0D10"/>
                 </a:solidFill>
               </a:defRPr>
             </a:pPr>
             <a:r>
-              <a:t>Сейчас</a:t>
-            </a:r>
-          </a:p>
-        </p:txBody>
-      </p:sp>
-      <p:sp>
-        <p:nvSpPr>
-          <p:cNvPr id="8" name="text-69-418">
-            <a:extLst xmlns:a="http://schemas.openxmlformats.org/drawingml/2006/main">
-              <a:ext uri="{FF2B5EF4-FFF2-40B4-BE49-F238E27FC236}">
-                <a16:creationId xmlns:a16="http://schemas.microsoft.com/office/drawing/2014/main" id="{EAA35A75-54EE-4FE0-93D1-1DB9FDE2DDFD}"/>
-              </a:ext>
-            </a:extLst>
-          </p:cNvPr>
-          <p:cNvSpPr>
-            <a:spLocks xmlns:a="http://schemas.openxmlformats.org/drawingml/2006/main" noGrp="1"/>
-          </p:cNvSpPr>
-          <p:nvPr/>
-        </p:nvSpPr>
-        <p:spPr>
-          <a:xfrm xmlns:a="http://schemas.openxmlformats.org/drawingml/2006/main">
-            <a:off x="657225" y="3981450"/>
-            <a:ext cx="2714625" cy="1000125"/>
-          </a:xfrm>
-          <a:prstGeom xmlns:a="http://schemas.openxmlformats.org/drawingml/2006/main" prst="rect">
-            <a:avLst/>
-          </a:prstGeom>
-        </p:spPr>
-        <p:txBody>
-          <a:bodyPr xmlns:a="http://schemas.openxmlformats.org/drawingml/2006/main" lIns="0" tIns="0" rIns="0" bIns="0" anchor="t"/>
-          <a:lstStyle xmlns:a="http://schemas.openxmlformats.org/drawingml/2006/main"/>
-          <a:p xmlns:a="http://schemas.openxmlformats.org/drawingml/2006/main">
-            <a:pPr algn="l">
-              <a:buNone/>
-              <a:defRPr sz="1500" b="0">
-                <a:solidFill>
-                  <a:srgbClr val="0B0D10"/>
-                </a:solidFill>
-              </a:defRPr>
-            </a:pPr>
-            <a:r>
-              <a:t>Протокол, подпись, CI. Внешнего submission пока нет.</a:t>
-            </a:r>
-          </a:p>
-        </p:txBody>
-      </p:sp>
-      <p:sp>
-        <p:nvSpPr>
-          <p:cNvPr id="9" name="text-489-206">
-            <a:extLst xmlns:a="http://schemas.openxmlformats.org/drawingml/2006/main">
-              <a:ext uri="{FF2B5EF4-FFF2-40B4-BE49-F238E27FC236}">
-                <a16:creationId xmlns:a16="http://schemas.microsoft.com/office/drawing/2014/main" id="{B5431607-40D5-4ADF-8839-50FDE7F6F7A2}"/>
-              </a:ext>
-            </a:extLst>
-          </p:cNvPr>
-          <p:cNvSpPr>
-            <a:spLocks xmlns:a="http://schemas.openxmlformats.org/drawingml/2006/main" noGrp="1"/>
-          </p:cNvSpPr>
-          <p:nvPr/>
-        </p:nvSpPr>
-        <p:spPr>
-          <a:xfrm xmlns:a="http://schemas.openxmlformats.org/drawingml/2006/main">
-            <a:off x="4657725" y="1962150"/>
-            <a:ext cx="2762250" cy="838200"/>
-          </a:xfrm>
-          <a:prstGeom xmlns:a="http://schemas.openxmlformats.org/drawingml/2006/main" prst="rect">
-            <a:avLst/>
-          </a:prstGeom>
-        </p:spPr>
-        <p:txBody>
-          <a:bodyPr xmlns:a="http://schemas.openxmlformats.org/drawingml/2006/main" lIns="0" tIns="0" rIns="0" bIns="0" anchor="t"/>
-          <a:lstStyle xmlns:a="http://schemas.openxmlformats.org/drawingml/2006/main"/>
-          <a:p xmlns:a="http://schemas.openxmlformats.org/drawingml/2006/main">
-            <a:pPr algn="l">
-              <a:buNone/>
-              <a:defRPr sz="4950" b="1">
-                <a:solidFill>
-                  <a:srgbClr val="FF6B35"/>
-                </a:solidFill>
-              </a:defRPr>
-            </a:pPr>
-            <a:r>
-              <a:t>9.5</a:t>
-            </a:r>
-          </a:p>
-        </p:txBody>
-      </p:sp>
-      <p:sp>
-        <p:nvSpPr>
-          <p:cNvPr id="10" name="text-489-306">
-            <a:extLst xmlns:a="http://schemas.openxmlformats.org/drawingml/2006/main">
-              <a:ext uri="{FF2B5EF4-FFF2-40B4-BE49-F238E27FC236}">
-                <a16:creationId xmlns:a16="http://schemas.microsoft.com/office/drawing/2014/main" id="{0AAA1054-1482-4898-9013-7CEC14E283B4}"/>
-              </a:ext>
-            </a:extLst>
-          </p:cNvPr>
-          <p:cNvSpPr>
-            <a:spLocks xmlns:a="http://schemas.openxmlformats.org/drawingml/2006/main" noGrp="1"/>
-          </p:cNvSpPr>
-          <p:nvPr/>
-        </p:nvSpPr>
-        <p:spPr>
-          <a:xfrm xmlns:a="http://schemas.openxmlformats.org/drawingml/2006/main">
-            <a:off x="4657725" y="2914650"/>
-            <a:ext cx="2762250" cy="361950"/>
-          </a:xfrm>
-          <a:prstGeom xmlns:a="http://schemas.openxmlformats.org/drawingml/2006/main" prst="rect">
-            <a:avLst/>
-          </a:prstGeom>
-        </p:spPr>
-        <p:txBody>
-          <a:bodyPr xmlns:a="http://schemas.openxmlformats.org/drawingml/2006/main" lIns="0" tIns="0" rIns="0" bIns="0" anchor="t"/>
-          <a:lstStyle xmlns:a="http://schemas.openxmlformats.org/drawingml/2006/main"/>
-          <a:p xmlns:a="http://schemas.openxmlformats.org/drawingml/2006/main">
-            <a:pPr algn="l">
-              <a:buNone/>
-              <a:defRPr sz="1950" b="1">
-                <a:solidFill>
-                  <a:srgbClr val="0B0D10"/>
-                </a:solidFill>
-              </a:defRPr>
-            </a:pPr>
-            <a:r>
-              <a:t>Один external PASS</a:t>
-            </a:r>
-          </a:p>
-        </p:txBody>
-      </p:sp>
-      <p:sp>
-        <p:nvSpPr>
-          <p:cNvPr id="11" name="text-489-370">
-            <a:extLst xmlns:a="http://schemas.openxmlformats.org/drawingml/2006/main">
-              <a:ext uri="{FF2B5EF4-FFF2-40B4-BE49-F238E27FC236}">
-                <a16:creationId xmlns:a16="http://schemas.microsoft.com/office/drawing/2014/main" id="{6612D925-5A26-4E5F-AD81-B792370639FE}"/>
-              </a:ext>
-            </a:extLst>
-          </p:cNvPr>
-          <p:cNvSpPr>
-            <a:spLocks xmlns:a="http://schemas.openxmlformats.org/drawingml/2006/main" noGrp="1"/>
-          </p:cNvSpPr>
-          <p:nvPr/>
-        </p:nvSpPr>
-        <p:spPr>
-          <a:xfrm xmlns:a="http://schemas.openxmlformats.org/drawingml/2006/main">
-            <a:off x="4657725" y="3524250"/>
-            <a:ext cx="2714625" cy="1371600"/>
-          </a:xfrm>
-          <a:prstGeom xmlns:a="http://schemas.openxmlformats.org/drawingml/2006/main" prst="rect">
-            <a:avLst/>
-          </a:prstGeom>
-        </p:spPr>
-        <p:txBody>
-          <a:bodyPr xmlns:a="http://schemas.openxmlformats.org/drawingml/2006/main" lIns="0" tIns="0" rIns="0" bIns="0" anchor="t"/>
-          <a:lstStyle xmlns:a="http://schemas.openxmlformats.org/drawingml/2006/main"/>
-          <a:p xmlns:a="http://schemas.openxmlformats.org/drawingml/2006/main">
-            <a:pPr algn="l">
-              <a:buNone/>
-              <a:defRPr sz="1500" b="0">
-                <a:solidFill>
-                  <a:srgbClr val="0B0D10"/>
-                </a:solidFill>
-              </a:defRPr>
-            </a:pPr>
-            <a:r>
-              <a:t>≥4 independently authored families, ≥120 cases, one-shot freeze, reveal, provenance, signature.</a:t>
-            </a:r>
-          </a:p>
-        </p:txBody>
-      </p:sp>
-      <p:sp>
-        <p:nvSpPr>
-          <p:cNvPr id="12" name="text-909-158">
-            <a:extLst xmlns:a="http://schemas.openxmlformats.org/drawingml/2006/main">
-              <a:ext uri="{FF2B5EF4-FFF2-40B4-BE49-F238E27FC236}">
-                <a16:creationId xmlns:a16="http://schemas.microsoft.com/office/drawing/2014/main" id="{E6887C07-1C69-4285-8D09-01C9C9ED490B}"/>
-              </a:ext>
-            </a:extLst>
-          </p:cNvPr>
-          <p:cNvSpPr>
-            <a:spLocks xmlns:a="http://schemas.openxmlformats.org/drawingml/2006/main" noGrp="1"/>
-          </p:cNvSpPr>
-          <p:nvPr/>
-        </p:nvSpPr>
-        <p:spPr>
-          <a:xfrm xmlns:a="http://schemas.openxmlformats.org/drawingml/2006/main">
-            <a:off x="8658225" y="1504950"/>
-            <a:ext cx="2762250" cy="838200"/>
-          </a:xfrm>
-          <a:prstGeom xmlns:a="http://schemas.openxmlformats.org/drawingml/2006/main" prst="rect">
-            <a:avLst/>
-          </a:prstGeom>
-        </p:spPr>
-        <p:txBody>
-          <a:bodyPr xmlns:a="http://schemas.openxmlformats.org/drawingml/2006/main" lIns="0" tIns="0" rIns="0" bIns="0" anchor="t"/>
-          <a:lstStyle xmlns:a="http://schemas.openxmlformats.org/drawingml/2006/main"/>
-          <a:p xmlns:a="http://schemas.openxmlformats.org/drawingml/2006/main">
-            <a:pPr algn="l">
-              <a:buNone/>
-              <a:defRPr sz="4950" b="1">
-                <a:solidFill>
-                  <a:srgbClr val="0B0D10"/>
-                </a:solidFill>
-              </a:defRPr>
-            </a:pPr>
-            <a:r>
-              <a:t>9.8</a:t>
-            </a:r>
-          </a:p>
-        </p:txBody>
-      </p:sp>
-      <p:sp>
-        <p:nvSpPr>
-          <p:cNvPr id="13" name="text-909-258">
-            <a:extLst xmlns:a="http://schemas.openxmlformats.org/drawingml/2006/main">
-              <a:ext uri="{FF2B5EF4-FFF2-40B4-BE49-F238E27FC236}">
-                <a16:creationId xmlns:a16="http://schemas.microsoft.com/office/drawing/2014/main" id="{CC51D3AE-A8A3-47B0-93A7-F47E75AAC3D7}"/>
-              </a:ext>
-            </a:extLst>
-          </p:cNvPr>
-          <p:cNvSpPr>
-            <a:spLocks xmlns:a="http://schemas.openxmlformats.org/drawingml/2006/main" noGrp="1"/>
-          </p:cNvSpPr>
-          <p:nvPr/>
-        </p:nvSpPr>
-        <p:spPr>
-          <a:xfrm xmlns:a="http://schemas.openxmlformats.org/drawingml/2006/main">
-            <a:off x="8658225" y="2457450"/>
-            <a:ext cx="2762250" cy="361950"/>
-          </a:xfrm>
-          <a:prstGeom xmlns:a="http://schemas.openxmlformats.org/drawingml/2006/main" prst="rect">
-            <a:avLst/>
-          </a:prstGeom>
-        </p:spPr>
-        <p:txBody>
-          <a:bodyPr xmlns:a="http://schemas.openxmlformats.org/drawingml/2006/main" lIns="0" tIns="0" rIns="0" bIns="0" anchor="t"/>
-          <a:lstStyle xmlns:a="http://schemas.openxmlformats.org/drawingml/2006/main"/>
-          <a:p xmlns:a="http://schemas.openxmlformats.org/drawingml/2006/main">
-            <a:pPr algn="l">
-              <a:buNone/>
-              <a:defRPr sz="1950" b="1">
-                <a:solidFill>
-                  <a:srgbClr val="0B0D10"/>
-                </a:solidFill>
-              </a:defRPr>
-            </a:pPr>
-            <a:r>
-              <a:t>Репликация</a:t>
-            </a:r>
-          </a:p>
-        </p:txBody>
-      </p:sp>
-      <p:sp>
-        <p:nvSpPr>
-          <p:cNvPr id="14" name="text-909-322">
-            <a:extLst xmlns:a="http://schemas.openxmlformats.org/drawingml/2006/main">
-              <a:ext uri="{FF2B5EF4-FFF2-40B4-BE49-F238E27FC236}">
-                <a16:creationId xmlns:a16="http://schemas.microsoft.com/office/drawing/2014/main" id="{BD2231AD-8BC9-45FD-9C19-8F3F5902B986}"/>
-              </a:ext>
-            </a:extLst>
-          </p:cNvPr>
-          <p:cNvSpPr>
-            <a:spLocks xmlns:a="http://schemas.openxmlformats.org/drawingml/2006/main" noGrp="1"/>
-          </p:cNvSpPr>
-          <p:nvPr/>
-        </p:nvSpPr>
-        <p:spPr>
-          <a:xfrm xmlns:a="http://schemas.openxmlformats.org/drawingml/2006/main">
-            <a:off x="8658225" y="3067050"/>
-            <a:ext cx="2714625" cy="1371600"/>
-          </a:xfrm>
-          <a:prstGeom xmlns:a="http://schemas.openxmlformats.org/drawingml/2006/main" prst="rect">
-            <a:avLst/>
-          </a:prstGeom>
-        </p:spPr>
-        <p:txBody>
-          <a:bodyPr xmlns:a="http://schemas.openxmlformats.org/drawingml/2006/main" lIns="0" tIns="0" rIns="0" bIns="0" anchor="t"/>
-          <a:lstStyle xmlns:a="http://schemas.openxmlformats.org/drawingml/2006/main"/>
-          <a:p xmlns:a="http://schemas.openxmlformats.org/drawingml/2006/main">
-            <a:pPr algn="l">
-              <a:buNone/>
-              <a:defRPr sz="1500" b="0">
-                <a:solidFill>
-                  <a:srgbClr val="0B0D10"/>
-                </a:solidFill>
-              </a:defRPr>
-            </a:pPr>
-            <a:r>
-              <a:t>Два независимых evaluator или одна authorized organization на materially different systems.</a:t>
-            </a:r>
-          </a:p>
-        </p:txBody>
-      </p:sp>
-      <p:sp>
-        <p:nvSpPr>
-          <p:cNvPr id="15" name="text-42-625">
-            <a:extLst xmlns:a="http://schemas.openxmlformats.org/drawingml/2006/main">
-              <a:ext uri="{FF2B5EF4-FFF2-40B4-BE49-F238E27FC236}">
-                <a16:creationId xmlns:a16="http://schemas.microsoft.com/office/drawing/2014/main" id="{9E1F4E86-6ACB-42E1-A881-42F5336F2BB2}"/>
-              </a:ext>
-            </a:extLst>
-          </p:cNvPr>
-          <p:cNvSpPr>
-            <a:spLocks xmlns:a="http://schemas.openxmlformats.org/drawingml/2006/main" noGrp="1"/>
-          </p:cNvSpPr>
-          <p:nvPr/>
-        </p:nvSpPr>
-        <p:spPr>
-          <a:xfrm xmlns:a="http://schemas.openxmlformats.org/drawingml/2006/main">
-            <a:off x="400050" y="5953125"/>
-            <a:ext cx="8572500" cy="323850"/>
-          </a:xfrm>
-          <a:prstGeom xmlns:a="http://schemas.openxmlformats.org/drawingml/2006/main" prst="rect">
-            <a:avLst/>
-          </a:prstGeom>
-        </p:spPr>
-        <p:txBody>
-          <a:bodyPr xmlns:a="http://schemas.openxmlformats.org/drawingml/2006/main" lIns="0" tIns="0" rIns="0" bIns="0" anchor="t"/>
-          <a:lstStyle xmlns:a="http://schemas.openxmlformats.org/drawingml/2006/main"/>
-          <a:p xmlns:a="http://schemas.openxmlformats.org/drawingml/2006/main">
-            <a:pPr algn="l">
-              <a:buNone/>
-              <a:defRPr sz="1500" b="1">
-                <a:solidFill>
-                  <a:srgbClr val="FF6B35"/>
-                </a:solidFill>
-              </a:defRPr>
-            </a:pPr>
-            <a:r>
-              <a:t>Новые внутренние тесты не двигают 7.8.</a:t>
-            </a:r>
-          </a:p>
-        </p:txBody>
-      </p:sp>
-      <p:sp>
-        <p:nvSpPr>
-          <p:cNvPr id="16" name="slide-number-10">
-            <a:extLst xmlns:a="http://schemas.openxmlformats.org/drawingml/2006/main">
-              <a:ext uri="{FF2B5EF4-FFF2-40B4-BE49-F238E27FC236}">
-                <a16:creationId xmlns:a16="http://schemas.microsoft.com/office/drawing/2014/main" id="{1330B4F0-6E7D-4086-B860-39A5CC3E6515}"/>
+              <a:t>0 false confident · 0 oracle mismatch · external v2: NOT_COLLECTED</a:t>
+            </a:r>
+          </a:p>
+        </p:txBody>
+      </p:sp>
+      <p:sp>
+        <p:nvSpPr>
+          <p:cNvPr id="9" name="slide-number-7">
+            <a:extLst xmlns:a="http://schemas.openxmlformats.org/drawingml/2006/main">
+              <a:ext uri="{FF2B5EF4-FFF2-40B4-BE49-F238E27FC236}">
+                <a16:creationId xmlns:a16="http://schemas.microsoft.com/office/drawing/2014/main" id="{E9775F06-AC9F-482B-A8E6-439FBF8E6307}"/>
               </a:ext>
             </a:extLst>
           </p:cNvPr>
@@ -3056,10 +3078,26 @@
           </a:p>
         </p:txBody>
       </p:sp>
+      <p:graphicFrame>
+        <p:nvGraphicFramePr>
+          <p:cNvPr id="22" name="Chart"/>
+          <p:cNvGraphicFramePr/>
+          <p:nvPr/>
+        </p:nvGraphicFramePr>
+        <p:xfrm>
+          <a:off xmlns:a="http://schemas.openxmlformats.org/drawingml/2006/main" x="781050" y="2324100"/>
+          <a:ext xmlns:a="http://schemas.openxmlformats.org/drawingml/2006/main" cx="5334000" cy="2857500"/>
+        </p:xfrm>
+        <a:graphic xmlns:a="http://schemas.openxmlformats.org/drawingml/2006/main">
+          <a:graphicData uri="http://schemas.openxmlformats.org/drawingml/2006/chart">
+            <c:chart xmlns:r="http://schemas.openxmlformats.org/officeDocument/2006/relationships" xmlns:c="http://schemas.openxmlformats.org/drawingml/2006/chart" r:id="Rf233c2b77e104fc9"/>
+          </a:graphicData>
+        </a:graphic>
+      </p:graphicFrame>
     </p:spTree>
     <p:extLst>
       <p:ext uri="{BB962C8B-B14F-4D97-AF65-F5344CB8AC3E}">
-        <p14:creationId xmlns:p14="http://schemas.microsoft.com/office/powerpoint/2010/main" val="27292007"/>
+        <p14:creationId xmlns:p14="http://schemas.microsoft.com/office/powerpoint/2010/main" val="1077710387"/>
       </p:ext>
     </p:extLst>
   </p:cSld>
@@ -3090,6 +3128,1176 @@
           <p:cNvPr id="14" name="text-42-38">
             <a:extLst xmlns:a="http://schemas.openxmlformats.org/drawingml/2006/main">
               <a:ext uri="{FF2B5EF4-FFF2-40B4-BE49-F238E27FC236}">
+                <a16:creationId xmlns:a16="http://schemas.microsoft.com/office/drawing/2014/main" id="{88149F28-389D-4D06-9718-A82BEBB3178D}"/>
+              </a:ext>
+            </a:extLst>
+          </p:cNvPr>
+          <p:cNvSpPr>
+            <a:spLocks xmlns:a="http://schemas.openxmlformats.org/drawingml/2006/main" noGrp="1"/>
+          </p:cNvSpPr>
+          <p:nvPr/>
+        </p:nvSpPr>
+        <p:spPr>
+          <a:xfrm xmlns:a="http://schemas.openxmlformats.org/drawingml/2006/main">
+            <a:off x="400050" y="361950"/>
+            <a:ext cx="4572000" cy="266700"/>
+          </a:xfrm>
+          <a:prstGeom xmlns:a="http://schemas.openxmlformats.org/drawingml/2006/main" prst="rect">
+            <a:avLst/>
+          </a:prstGeom>
+        </p:spPr>
+        <p:txBody>
+          <a:bodyPr xmlns:a="http://schemas.openxmlformats.org/drawingml/2006/main" lIns="0" tIns="0" rIns="0" bIns="0" anchor="t"/>
+          <a:lstStyle xmlns:a="http://schemas.openxmlformats.org/drawingml/2006/main"/>
+          <a:p xmlns:a="http://schemas.openxmlformats.org/drawingml/2006/main">
+            <a:pPr algn="l">
+              <a:buNone/>
+              <a:defRPr sz="1200" b="1">
+                <a:solidFill>
+                  <a:srgbClr val="FF6B35"/>
+                </a:solidFill>
+              </a:defRPr>
+            </a:pPr>
+            <a:r>
+              <a:t>10  Новизна без преувеличения</a:t>
+            </a:r>
+          </a:p>
+        </p:txBody>
+      </p:sp>
+      <p:sp>
+        <p:nvSpPr>
+          <p:cNvPr id="2" name="text-42-84">
+            <a:extLst xmlns:a="http://schemas.openxmlformats.org/drawingml/2006/main">
+              <a:ext uri="{FF2B5EF4-FFF2-40B4-BE49-F238E27FC236}">
+                <a16:creationId xmlns:a16="http://schemas.microsoft.com/office/drawing/2014/main" id="{BE6D6434-59FB-440F-980D-9D9148C7FC53}"/>
+              </a:ext>
+            </a:extLst>
+          </p:cNvPr>
+          <p:cNvSpPr>
+            <a:spLocks xmlns:a="http://schemas.openxmlformats.org/drawingml/2006/main" noGrp="1"/>
+          </p:cNvSpPr>
+          <p:nvPr/>
+        </p:nvSpPr>
+        <p:spPr>
+          <a:xfrm xmlns:a="http://schemas.openxmlformats.org/drawingml/2006/main">
+            <a:off x="400050" y="800100"/>
+            <a:ext cx="10668000" cy="647700"/>
+          </a:xfrm>
+          <a:prstGeom xmlns:a="http://schemas.openxmlformats.org/drawingml/2006/main" prst="rect">
+            <a:avLst/>
+          </a:prstGeom>
+        </p:spPr>
+        <p:txBody>
+          <a:bodyPr xmlns:a="http://schemas.openxmlformats.org/drawingml/2006/main" lIns="0" tIns="0" rIns="0" bIns="0" anchor="t"/>
+          <a:lstStyle xmlns:a="http://schemas.openxmlformats.org/drawingml/2006/main"/>
+          <a:p xmlns:a="http://schemas.openxmlformats.org/drawingml/2006/main">
+            <a:pPr algn="l">
+              <a:buNone/>
+              <a:defRPr sz="3375" b="1">
+                <a:solidFill>
+                  <a:srgbClr val="0B0D10"/>
+                </a:solidFill>
+              </a:defRPr>
+            </a:pPr>
+            <a:r>
+              <a:t>Новый вклад — active discovery + fail-closed repair</a:t>
+            </a:r>
+          </a:p>
+        </p:txBody>
+      </p:sp>
+      <p:sp>
+        <p:nvSpPr>
+          <p:cNvPr id="3" name="novel-known">
+            <a:extLst xmlns:a="http://schemas.openxmlformats.org/drawingml/2006/main">
+              <a:ext uri="{FF2B5EF4-FFF2-40B4-BE49-F238E27FC236}">
+                <a16:creationId xmlns:a16="http://schemas.microsoft.com/office/drawing/2014/main" id="{6CB3F883-8645-4CCF-8509-0192D3BDBF13}"/>
+              </a:ext>
+            </a:extLst>
+          </p:cNvPr>
+          <p:cNvSpPr>
+            <a:spLocks xmlns:a="http://schemas.openxmlformats.org/drawingml/2006/main" noGrp="1"/>
+          </p:cNvSpPr>
+          <p:nvPr/>
+        </p:nvSpPr>
+        <p:spPr>
+          <a:xfrm xmlns:a="http://schemas.openxmlformats.org/drawingml/2006/main">
+            <a:off x="400050" y="1924050"/>
+            <a:ext cx="3381375" cy="3714750"/>
+          </a:xfrm>
+          <a:prstGeom xmlns:a="http://schemas.openxmlformats.org/drawingml/2006/main" prst="rect">
+            <a:avLst/>
+          </a:prstGeom>
+          <a:solidFill xmlns:a="http://schemas.openxmlformats.org/drawingml/2006/main">
+            <a:srgbClr val="EDEDED"/>
+          </a:solidFill>
+        </p:spPr>
+      </p:sp>
+      <p:sp>
+        <p:nvSpPr>
+          <p:cNvPr id="4" name="novel-contribution">
+            <a:extLst xmlns:a="http://schemas.openxmlformats.org/drawingml/2006/main">
+              <a:ext uri="{FF2B5EF4-FFF2-40B4-BE49-F238E27FC236}">
+                <a16:creationId xmlns:a16="http://schemas.microsoft.com/office/drawing/2014/main" id="{0F183184-76A7-4A8B-82E1-ADD6C4487F45}"/>
+              </a:ext>
+            </a:extLst>
+          </p:cNvPr>
+          <p:cNvSpPr>
+            <a:spLocks xmlns:a="http://schemas.openxmlformats.org/drawingml/2006/main" noGrp="1"/>
+          </p:cNvSpPr>
+          <p:nvPr/>
+        </p:nvSpPr>
+        <p:spPr>
+          <a:xfrm xmlns:a="http://schemas.openxmlformats.org/drawingml/2006/main">
+            <a:off x="4400550" y="1924050"/>
+            <a:ext cx="3381375" cy="3714750"/>
+          </a:xfrm>
+          <a:prstGeom xmlns:a="http://schemas.openxmlformats.org/drawingml/2006/main" prst="rect">
+            <a:avLst/>
+          </a:prstGeom>
+          <a:solidFill xmlns:a="http://schemas.openxmlformats.org/drawingml/2006/main">
+            <a:srgbClr val="F7E8E3"/>
+          </a:solidFill>
+        </p:spPr>
+      </p:sp>
+      <p:sp>
+        <p:nvSpPr>
+          <p:cNvPr id="5" name="novel-no-claim">
+            <a:extLst xmlns:a="http://schemas.openxmlformats.org/drawingml/2006/main">
+              <a:ext uri="{FF2B5EF4-FFF2-40B4-BE49-F238E27FC236}">
+                <a16:creationId xmlns:a16="http://schemas.microsoft.com/office/drawing/2014/main" id="{421AC173-16AB-4CD8-8662-E7865CC9EC05}"/>
+              </a:ext>
+            </a:extLst>
+          </p:cNvPr>
+          <p:cNvSpPr>
+            <a:spLocks xmlns:a="http://schemas.openxmlformats.org/drawingml/2006/main" noGrp="1"/>
+          </p:cNvSpPr>
+          <p:nvPr/>
+        </p:nvSpPr>
+        <p:spPr>
+          <a:xfrm xmlns:a="http://schemas.openxmlformats.org/drawingml/2006/main">
+            <a:off x="8401050" y="1924050"/>
+            <a:ext cx="3381375" cy="3714750"/>
+          </a:xfrm>
+          <a:prstGeom xmlns:a="http://schemas.openxmlformats.org/drawingml/2006/main" prst="rect">
+            <a:avLst/>
+          </a:prstGeom>
+          <a:solidFill xmlns:a="http://schemas.openxmlformats.org/drawingml/2006/main">
+            <a:srgbClr val="EDEDED"/>
+          </a:solidFill>
+        </p:spPr>
+      </p:sp>
+      <p:sp>
+        <p:nvSpPr>
+          <p:cNvPr id="6" name="text-69-234">
+            <a:extLst xmlns:a="http://schemas.openxmlformats.org/drawingml/2006/main">
+              <a:ext uri="{FF2B5EF4-FFF2-40B4-BE49-F238E27FC236}">
+                <a16:creationId xmlns:a16="http://schemas.microsoft.com/office/drawing/2014/main" id="{53B2EB09-807B-4592-850A-C8BD7C878981}"/>
+              </a:ext>
+            </a:extLst>
+          </p:cNvPr>
+          <p:cNvSpPr>
+            <a:spLocks xmlns:a="http://schemas.openxmlformats.org/drawingml/2006/main" noGrp="1"/>
+          </p:cNvSpPr>
+          <p:nvPr/>
+        </p:nvSpPr>
+        <p:spPr>
+          <a:xfrm xmlns:a="http://schemas.openxmlformats.org/drawingml/2006/main">
+            <a:off x="657225" y="2228850"/>
+            <a:ext cx="2762250" cy="361950"/>
+          </a:xfrm>
+          <a:prstGeom xmlns:a="http://schemas.openxmlformats.org/drawingml/2006/main" prst="rect">
+            <a:avLst/>
+          </a:prstGeom>
+        </p:spPr>
+        <p:txBody>
+          <a:bodyPr xmlns:a="http://schemas.openxmlformats.org/drawingml/2006/main" lIns="0" tIns="0" rIns="0" bIns="0" anchor="t"/>
+          <a:lstStyle xmlns:a="http://schemas.openxmlformats.org/drawingml/2006/main"/>
+          <a:p xmlns:a="http://schemas.openxmlformats.org/drawingml/2006/main">
+            <a:pPr algn="l">
+              <a:buNone/>
+              <a:defRPr sz="1950" b="1">
+                <a:solidFill>
+                  <a:srgbClr val="0B0D10"/>
+                </a:solidFill>
+              </a:defRPr>
+            </a:pPr>
+            <a:r>
+              <a:t>Уже существовало</a:t>
+            </a:r>
+          </a:p>
+        </p:txBody>
+      </p:sp>
+      <p:sp>
+        <p:nvSpPr>
+          <p:cNvPr id="7" name="text-69-306">
+            <a:extLst xmlns:a="http://schemas.openxmlformats.org/drawingml/2006/main">
+              <a:ext uri="{FF2B5EF4-FFF2-40B4-BE49-F238E27FC236}">
+                <a16:creationId xmlns:a16="http://schemas.microsoft.com/office/drawing/2014/main" id="{7E3BDE59-9D49-4288-AE30-F43FCFFA28FC}"/>
+              </a:ext>
+            </a:extLst>
+          </p:cNvPr>
+          <p:cNvSpPr>
+            <a:spLocks xmlns:a="http://schemas.openxmlformats.org/drawingml/2006/main" noGrp="1"/>
+          </p:cNvSpPr>
+          <p:nvPr/>
+        </p:nvSpPr>
+        <p:spPr>
+          <a:xfrm xmlns:a="http://schemas.openxmlformats.org/drawingml/2006/main">
+            <a:off x="657225" y="2914650"/>
+            <a:ext cx="2714625" cy="2095500"/>
+          </a:xfrm>
+          <a:prstGeom xmlns:a="http://schemas.openxmlformats.org/drawingml/2006/main" prst="rect">
+            <a:avLst/>
+          </a:prstGeom>
+        </p:spPr>
+        <p:txBody>
+          <a:bodyPr xmlns:a="http://schemas.openxmlformats.org/drawingml/2006/main" lIns="0" tIns="0" rIns="0" bIns="0" anchor="t"/>
+          <a:lstStyle xmlns:a="http://schemas.openxmlformats.org/drawingml/2006/main"/>
+          <a:p xmlns:a="http://schemas.openxmlformats.org/drawingml/2006/main">
+            <a:pPr algn="l">
+              <a:buNone/>
+              <a:defRPr sz="1650" b="0">
+                <a:solidFill>
+                  <a:srgbClr val="0B0D10"/>
+                </a:solidFill>
+              </a:defRPr>
+            </a:pPr>
+            <a:r>
+              <a:t>Network tomography
+Active diagnosis
+Data lineage
+Group testing
+Temporal erasure</a:t>
+            </a:r>
+          </a:p>
+        </p:txBody>
+      </p:sp>
+      <p:sp>
+        <p:nvSpPr>
+          <p:cNvPr id="8" name="text-489-234">
+            <a:extLst xmlns:a="http://schemas.openxmlformats.org/drawingml/2006/main">
+              <a:ext uri="{FF2B5EF4-FFF2-40B4-BE49-F238E27FC236}">
+                <a16:creationId xmlns:a16="http://schemas.microsoft.com/office/drawing/2014/main" id="{CF9CC74A-DC0A-4E7D-9EA5-5B88C37AEB47}"/>
+              </a:ext>
+            </a:extLst>
+          </p:cNvPr>
+          <p:cNvSpPr>
+            <a:spLocks xmlns:a="http://schemas.openxmlformats.org/drawingml/2006/main" noGrp="1"/>
+          </p:cNvSpPr>
+          <p:nvPr/>
+        </p:nvSpPr>
+        <p:spPr>
+          <a:xfrm xmlns:a="http://schemas.openxmlformats.org/drawingml/2006/main">
+            <a:off x="4657725" y="2228850"/>
+            <a:ext cx="2762250" cy="361950"/>
+          </a:xfrm>
+          <a:prstGeom xmlns:a="http://schemas.openxmlformats.org/drawingml/2006/main" prst="rect">
+            <a:avLst/>
+          </a:prstGeom>
+        </p:spPr>
+        <p:txBody>
+          <a:bodyPr xmlns:a="http://schemas.openxmlformats.org/drawingml/2006/main" lIns="0" tIns="0" rIns="0" bIns="0" anchor="t"/>
+          <a:lstStyle xmlns:a="http://schemas.openxmlformats.org/drawingml/2006/main"/>
+          <a:p xmlns:a="http://schemas.openxmlformats.org/drawingml/2006/main">
+            <a:pPr algn="l">
+              <a:buNone/>
+              <a:defRPr sz="1950" b="1">
+                <a:solidFill>
+                  <a:srgbClr val="FF6B35"/>
+                </a:solidFill>
+              </a:defRPr>
+            </a:pPr>
+            <a:r>
+              <a:t>Узкий вклад</a:t>
+            </a:r>
+          </a:p>
+        </p:txBody>
+      </p:sp>
+      <p:sp>
+        <p:nvSpPr>
+          <p:cNvPr id="9" name="text-489-306">
+            <a:extLst xmlns:a="http://schemas.openxmlformats.org/drawingml/2006/main">
+              <a:ext uri="{FF2B5EF4-FFF2-40B4-BE49-F238E27FC236}">
+                <a16:creationId xmlns:a16="http://schemas.microsoft.com/office/drawing/2014/main" id="{60FE33EA-F371-4DE4-963E-62261E17AB0C}"/>
+              </a:ext>
+            </a:extLst>
+          </p:cNvPr>
+          <p:cNvSpPr>
+            <a:spLocks xmlns:a="http://schemas.openxmlformats.org/drawingml/2006/main" noGrp="1"/>
+          </p:cNvSpPr>
+          <p:nvPr/>
+        </p:nvSpPr>
+        <p:spPr>
+          <a:xfrm xmlns:a="http://schemas.openxmlformats.org/drawingml/2006/main">
+            <a:off x="4657725" y="2914650"/>
+            <a:ext cx="2714625" cy="2305050"/>
+          </a:xfrm>
+          <a:prstGeom xmlns:a="http://schemas.openxmlformats.org/drawingml/2006/main" prst="rect">
+            <a:avLst/>
+          </a:prstGeom>
+        </p:spPr>
+        <p:txBody>
+          <a:bodyPr xmlns:a="http://schemas.openxmlformats.org/drawingml/2006/main" lIns="0" tIns="0" rIns="0" bIns="0" anchor="t"/>
+          <a:lstStyle xmlns:a="http://schemas.openxmlformats.org/drawingml/2006/main"/>
+          <a:p xmlns:a="http://schemas.openxmlformats.org/drawingml/2006/main">
+            <a:pPr algn="l">
+              <a:buNone/>
+              <a:defRPr sz="1575" b="1">
+                <a:solidFill>
+                  <a:srgbClr val="0B0D10"/>
+                </a:solidFill>
+              </a:defRPr>
+            </a:pPr>
+            <a:r>
+              <a:t>Subject interventions → exact version-space update → OUT / UNVERIFIED → path class → exact control + replay.</a:t>
+            </a:r>
+          </a:p>
+        </p:txBody>
+      </p:sp>
+      <p:sp>
+        <p:nvSpPr>
+          <p:cNvPr id="10" name="text-909-234">
+            <a:extLst xmlns:a="http://schemas.openxmlformats.org/drawingml/2006/main">
+              <a:ext uri="{FF2B5EF4-FFF2-40B4-BE49-F238E27FC236}">
+                <a16:creationId xmlns:a16="http://schemas.microsoft.com/office/drawing/2014/main" id="{6A719E17-299D-4604-A94A-7D1B99FC1CF6}"/>
+              </a:ext>
+            </a:extLst>
+          </p:cNvPr>
+          <p:cNvSpPr>
+            <a:spLocks xmlns:a="http://schemas.openxmlformats.org/drawingml/2006/main" noGrp="1"/>
+          </p:cNvSpPr>
+          <p:nvPr/>
+        </p:nvSpPr>
+        <p:spPr>
+          <a:xfrm xmlns:a="http://schemas.openxmlformats.org/drawingml/2006/main">
+            <a:off x="8658225" y="2228850"/>
+            <a:ext cx="2762250" cy="361950"/>
+          </a:xfrm>
+          <a:prstGeom xmlns:a="http://schemas.openxmlformats.org/drawingml/2006/main" prst="rect">
+            <a:avLst/>
+          </a:prstGeom>
+        </p:spPr>
+        <p:txBody>
+          <a:bodyPr xmlns:a="http://schemas.openxmlformats.org/drawingml/2006/main" lIns="0" tIns="0" rIns="0" bIns="0" anchor="t"/>
+          <a:lstStyle xmlns:a="http://schemas.openxmlformats.org/drawingml/2006/main"/>
+          <a:p xmlns:a="http://schemas.openxmlformats.org/drawingml/2006/main">
+            <a:pPr algn="l">
+              <a:buNone/>
+              <a:defRPr sz="1950" b="1">
+                <a:solidFill>
+                  <a:srgbClr val="0B0D10"/>
+                </a:solidFill>
+              </a:defRPr>
+            </a:pPr>
+            <a:r>
+              <a:t>Не заявляется</a:t>
+            </a:r>
+          </a:p>
+        </p:txBody>
+      </p:sp>
+      <p:sp>
+        <p:nvSpPr>
+          <p:cNvPr id="11" name="text-909-306">
+            <a:extLst xmlns:a="http://schemas.openxmlformats.org/drawingml/2006/main">
+              <a:ext uri="{FF2B5EF4-FFF2-40B4-BE49-F238E27FC236}">
+                <a16:creationId xmlns:a16="http://schemas.microsoft.com/office/drawing/2014/main" id="{2B397DEB-3D92-40C6-BD80-7A6966FF4101}"/>
+              </a:ext>
+            </a:extLst>
+          </p:cNvPr>
+          <p:cNvSpPr>
+            <a:spLocks xmlns:a="http://schemas.openxmlformats.org/drawingml/2006/main" noGrp="1"/>
+          </p:cNvSpPr>
+          <p:nvPr/>
+        </p:nvSpPr>
+        <p:spPr>
+          <a:xfrm xmlns:a="http://schemas.openxmlformats.org/drawingml/2006/main">
+            <a:off x="8658225" y="2914650"/>
+            <a:ext cx="2714625" cy="2190750"/>
+          </a:xfrm>
+          <a:prstGeom xmlns:a="http://schemas.openxmlformats.org/drawingml/2006/main" prst="rect">
+            <a:avLst/>
+          </a:prstGeom>
+        </p:spPr>
+        <p:txBody>
+          <a:bodyPr xmlns:a="http://schemas.openxmlformats.org/drawingml/2006/main" lIns="0" tIns="0" rIns="0" bIns="0" anchor="t"/>
+          <a:lstStyle xmlns:a="http://schemas.openxmlformats.org/drawingml/2006/main"/>
+          <a:p xmlns:a="http://schemas.openxmlformats.org/drawingml/2006/main">
+            <a:pPr algn="l">
+              <a:buNone/>
+              <a:defRPr sz="1650" b="0">
+                <a:solidFill>
+                  <a:srgbClr val="0B0D10"/>
+                </a:solidFill>
+              </a:defRPr>
+            </a:pPr>
+            <a:r>
+              <a:t>«Первый в мире»
+Arbitrary topology discovery
+Global optimal decision tree
+FaceID/eGov production</a:t>
+            </a:r>
+          </a:p>
+        </p:txBody>
+      </p:sp>
+      <p:sp>
+        <p:nvSpPr>
+          <p:cNvPr id="12" name="text-42-626">
+            <a:extLst xmlns:a="http://schemas.openxmlformats.org/drawingml/2006/main">
+              <a:ext uri="{FF2B5EF4-FFF2-40B4-BE49-F238E27FC236}">
+                <a16:creationId xmlns:a16="http://schemas.microsoft.com/office/drawing/2014/main" id="{08CD57D6-2C17-458D-B599-633D0A285537}"/>
+              </a:ext>
+            </a:extLst>
+          </p:cNvPr>
+          <p:cNvSpPr>
+            <a:spLocks xmlns:a="http://schemas.openxmlformats.org/drawingml/2006/main" noGrp="1"/>
+          </p:cNvSpPr>
+          <p:nvPr/>
+        </p:nvSpPr>
+        <p:spPr>
+          <a:xfrm xmlns:a="http://schemas.openxmlformats.org/drawingml/2006/main">
+            <a:off x="400050" y="5962650"/>
+            <a:ext cx="10858500" cy="361950"/>
+          </a:xfrm>
+          <a:prstGeom xmlns:a="http://schemas.openxmlformats.org/drawingml/2006/main" prst="rect">
+            <a:avLst/>
+          </a:prstGeom>
+        </p:spPr>
+        <p:txBody>
+          <a:bodyPr xmlns:a="http://schemas.openxmlformats.org/drawingml/2006/main" lIns="0" tIns="0" rIns="0" bIns="0" anchor="t"/>
+          <a:lstStyle xmlns:a="http://schemas.openxmlformats.org/drawingml/2006/main"/>
+          <a:p xmlns:a="http://schemas.openxmlformats.org/drawingml/2006/main">
+            <a:pPr algn="l">
+              <a:buNone/>
+              <a:defRPr sz="1350" b="0">
+                <a:solidFill>
+                  <a:srgbClr val="555B63"/>
+                </a:solidFill>
+              </a:defRPr>
+            </a:pPr>
+            <a:r>
+              <a:t>Greedy baseline tied at 7 probes: novelty is the auditable fail-closed composition, not universal query optimality.</a:t>
+            </a:r>
+          </a:p>
+        </p:txBody>
+      </p:sp>
+      <p:sp>
+        <p:nvSpPr>
+          <p:cNvPr id="13" name="slide-number-9">
+            <a:extLst xmlns:a="http://schemas.openxmlformats.org/drawingml/2006/main">
+              <a:ext uri="{FF2B5EF4-FFF2-40B4-BE49-F238E27FC236}">
+                <a16:creationId xmlns:a16="http://schemas.microsoft.com/office/drawing/2014/main" id="{B8861551-D27A-4601-8815-837B0ABF4B64}"/>
+              </a:ext>
+            </a:extLst>
+          </p:cNvPr>
+          <p:cNvSpPr>
+            <a:spLocks xmlns:a="http://schemas.openxmlformats.org/drawingml/2006/main" noGrp="1"/>
+          </p:cNvSpPr>
+          <p:nvPr/>
+        </p:nvSpPr>
+        <p:spPr>
+          <a:xfrm xmlns:a="http://schemas.openxmlformats.org/drawingml/2006/main">
+            <a:off x="11258550" y="6324600"/>
+            <a:ext cx="523875" cy="228600"/>
+          </a:xfrm>
+          <a:prstGeom xmlns:a="http://schemas.openxmlformats.org/drawingml/2006/main" prst="rect">
+            <a:avLst/>
+          </a:prstGeom>
+        </p:spPr>
+        <p:txBody>
+          <a:bodyPr xmlns:a="http://schemas.openxmlformats.org/drawingml/2006/main" lIns="0" tIns="0" rIns="0" bIns="0" anchor="t"/>
+          <a:lstStyle xmlns:a="http://schemas.openxmlformats.org/drawingml/2006/main"/>
+          <a:p xmlns:a="http://schemas.openxmlformats.org/drawingml/2006/main">
+            <a:pPr algn="r">
+              <a:buNone/>
+              <a:defRPr sz="1125" b="0">
+                <a:solidFill>
+                  <a:srgbClr val="555B63"/>
+                </a:solidFill>
+              </a:defRPr>
+            </a:pPr>
+            <a:r>
+              <a:t>11</a:t>
+            </a:r>
+          </a:p>
+        </p:txBody>
+      </p:sp>
+    </p:spTree>
+    <p:extLst>
+      <p:ext uri="{BB962C8B-B14F-4D97-AF65-F5344CB8AC3E}">
+        <p14:creationId xmlns:p14="http://schemas.microsoft.com/office/powerpoint/2010/main" val="2037705955"/>
+      </p:ext>
+    </p:extLst>
+  </p:cSld>
+</p:sld>
+</file>
+
+<file path=ppt/slides/slide12.xml><?xml version="1.0" encoding="utf-8"?>
+<p:sld xmlns:p="http://schemas.openxmlformats.org/presentationml/2006/main">
+  <p:cSld>
+    <p:bg>
+      <p:bgPr>
+        <a:solidFill xmlns:a="http://schemas.openxmlformats.org/drawingml/2006/main">
+          <a:srgbClr val="FFFFFF"/>
+        </a:solidFill>
+      </p:bgPr>
+    </p:bg>
+    <p:spTree>
+      <p:nvGrpSpPr>
+        <p:cNvPr id="1" name=""/>
+        <p:cNvGrpSpPr/>
+        <p:nvPr/>
+      </p:nvGrpSpPr>
+      <p:grpSpPr>
+        <a:xfrm xmlns:a="http://schemas.openxmlformats.org/drawingml/2006/main"/>
+      </p:grpSpPr>
+      <p:sp>
+        <p:nvSpPr>
+          <p:cNvPr id="17" name="text-42-38">
+            <a:extLst xmlns:a="http://schemas.openxmlformats.org/drawingml/2006/main">
+              <a:ext uri="{FF2B5EF4-FFF2-40B4-BE49-F238E27FC236}">
+                <a16:creationId xmlns:a16="http://schemas.microsoft.com/office/drawing/2014/main" id="{096D2445-227C-4447-8399-FA96923F8557}"/>
+              </a:ext>
+            </a:extLst>
+          </p:cNvPr>
+          <p:cNvSpPr>
+            <a:spLocks xmlns:a="http://schemas.openxmlformats.org/drawingml/2006/main" noGrp="1"/>
+          </p:cNvSpPr>
+          <p:nvPr/>
+        </p:nvSpPr>
+        <p:spPr>
+          <a:xfrm xmlns:a="http://schemas.openxmlformats.org/drawingml/2006/main">
+            <a:off x="400050" y="361950"/>
+            <a:ext cx="3905250" cy="266700"/>
+          </a:xfrm>
+          <a:prstGeom xmlns:a="http://schemas.openxmlformats.org/drawingml/2006/main" prst="rect">
+            <a:avLst/>
+          </a:prstGeom>
+        </p:spPr>
+        <p:txBody>
+          <a:bodyPr xmlns:a="http://schemas.openxmlformats.org/drawingml/2006/main" lIns="0" tIns="0" rIns="0" bIns="0" anchor="t"/>
+          <a:lstStyle xmlns:a="http://schemas.openxmlformats.org/drawingml/2006/main"/>
+          <a:p xmlns:a="http://schemas.openxmlformats.org/drawingml/2006/main">
+            <a:pPr algn="l">
+              <a:buNone/>
+              <a:defRPr sz="1200" b="1">
+                <a:solidFill>
+                  <a:srgbClr val="FF6B35"/>
+                </a:solidFill>
+              </a:defRPr>
+            </a:pPr>
+            <a:r>
+              <a:t>11  Доказательная лестница</a:t>
+            </a:r>
+          </a:p>
+        </p:txBody>
+      </p:sp>
+      <p:sp>
+        <p:nvSpPr>
+          <p:cNvPr id="2" name="text-42-84">
+            <a:extLst xmlns:a="http://schemas.openxmlformats.org/drawingml/2006/main">
+              <a:ext uri="{FF2B5EF4-FFF2-40B4-BE49-F238E27FC236}">
+                <a16:creationId xmlns:a16="http://schemas.microsoft.com/office/drawing/2014/main" id="{19E14A2B-DF73-4819-96D1-9B256F982F6D}"/>
+              </a:ext>
+            </a:extLst>
+          </p:cNvPr>
+          <p:cNvSpPr>
+            <a:spLocks xmlns:a="http://schemas.openxmlformats.org/drawingml/2006/main" noGrp="1"/>
+          </p:cNvSpPr>
+          <p:nvPr/>
+        </p:nvSpPr>
+        <p:spPr>
+          <a:xfrm xmlns:a="http://schemas.openxmlformats.org/drawingml/2006/main">
+            <a:off x="400050" y="800100"/>
+            <a:ext cx="10287000" cy="647700"/>
+          </a:xfrm>
+          <a:prstGeom xmlns:a="http://schemas.openxmlformats.org/drawingml/2006/main" prst="rect">
+            <a:avLst/>
+          </a:prstGeom>
+        </p:spPr>
+        <p:txBody>
+          <a:bodyPr xmlns:a="http://schemas.openxmlformats.org/drawingml/2006/main" lIns="0" tIns="0" rIns="0" bIns="0" anchor="t"/>
+          <a:lstStyle xmlns:a="http://schemas.openxmlformats.org/drawingml/2006/main"/>
+          <a:p xmlns:a="http://schemas.openxmlformats.org/drawingml/2006/main">
+            <a:pPr algn="l">
+              <a:buNone/>
+              <a:defRPr sz="3375" b="1">
+                <a:solidFill>
+                  <a:srgbClr val="0B0D10"/>
+                </a:solidFill>
+              </a:defRPr>
+            </a:pPr>
+            <a:r>
+              <a:t>Readiness нельзя выдавать за independence</a:t>
+            </a:r>
+          </a:p>
+        </p:txBody>
+      </p:sp>
+      <p:sp>
+        <p:nvSpPr>
+          <p:cNvPr id="3" name="evidence-current">
+            <a:extLst xmlns:a="http://schemas.openxmlformats.org/drawingml/2006/main">
+              <a:ext uri="{FF2B5EF4-FFF2-40B4-BE49-F238E27FC236}">
+                <a16:creationId xmlns:a16="http://schemas.microsoft.com/office/drawing/2014/main" id="{4522758C-10EC-47AA-9A7F-E7FA866047BC}"/>
+              </a:ext>
+            </a:extLst>
+          </p:cNvPr>
+          <p:cNvSpPr>
+            <a:spLocks xmlns:a="http://schemas.openxmlformats.org/drawingml/2006/main" noGrp="1"/>
+          </p:cNvSpPr>
+          <p:nvPr/>
+        </p:nvSpPr>
+        <p:spPr>
+          <a:xfrm xmlns:a="http://schemas.openxmlformats.org/drawingml/2006/main">
+            <a:off x="400050" y="2114550"/>
+            <a:ext cx="3381375" cy="3257550"/>
+          </a:xfrm>
+          <a:prstGeom xmlns:a="http://schemas.openxmlformats.org/drawingml/2006/main" prst="rect">
+            <a:avLst/>
+          </a:prstGeom>
+          <a:solidFill xmlns:a="http://schemas.openxmlformats.org/drawingml/2006/main">
+            <a:srgbClr val="EDEDED"/>
+          </a:solidFill>
+        </p:spPr>
+      </p:sp>
+      <p:sp>
+        <p:nvSpPr>
+          <p:cNvPr id="4" name="evidence-next">
+            <a:extLst xmlns:a="http://schemas.openxmlformats.org/drawingml/2006/main">
+              <a:ext uri="{FF2B5EF4-FFF2-40B4-BE49-F238E27FC236}">
+                <a16:creationId xmlns:a16="http://schemas.microsoft.com/office/drawing/2014/main" id="{1A91BD7B-A987-424E-8056-4C3A1BC0A4E9}"/>
+              </a:ext>
+            </a:extLst>
+          </p:cNvPr>
+          <p:cNvSpPr>
+            <a:spLocks xmlns:a="http://schemas.openxmlformats.org/drawingml/2006/main" noGrp="1"/>
+          </p:cNvSpPr>
+          <p:nvPr/>
+        </p:nvSpPr>
+        <p:spPr>
+          <a:xfrm xmlns:a="http://schemas.openxmlformats.org/drawingml/2006/main">
+            <a:off x="4400550" y="1657350"/>
+            <a:ext cx="3381375" cy="3714750"/>
+          </a:xfrm>
+          <a:prstGeom xmlns:a="http://schemas.openxmlformats.org/drawingml/2006/main" prst="rect">
+            <a:avLst/>
+          </a:prstGeom>
+          <a:solidFill xmlns:a="http://schemas.openxmlformats.org/drawingml/2006/main">
+            <a:srgbClr val="F7E8E3"/>
+          </a:solidFill>
+        </p:spPr>
+      </p:sp>
+      <p:sp>
+        <p:nvSpPr>
+          <p:cNvPr id="5" name="evidence-org">
+            <a:extLst xmlns:a="http://schemas.openxmlformats.org/drawingml/2006/main">
+              <a:ext uri="{FF2B5EF4-FFF2-40B4-BE49-F238E27FC236}">
+                <a16:creationId xmlns:a16="http://schemas.microsoft.com/office/drawing/2014/main" id="{03EF12D5-9E7E-43A9-8496-B2924530B49B}"/>
+              </a:ext>
+            </a:extLst>
+          </p:cNvPr>
+          <p:cNvSpPr>
+            <a:spLocks xmlns:a="http://schemas.openxmlformats.org/drawingml/2006/main" noGrp="1"/>
+          </p:cNvSpPr>
+          <p:nvPr/>
+        </p:nvSpPr>
+        <p:spPr>
+          <a:xfrm xmlns:a="http://schemas.openxmlformats.org/drawingml/2006/main">
+            <a:off x="8401050" y="1200150"/>
+            <a:ext cx="3381375" cy="4171950"/>
+          </a:xfrm>
+          <a:prstGeom xmlns:a="http://schemas.openxmlformats.org/drawingml/2006/main" prst="rect">
+            <a:avLst/>
+          </a:prstGeom>
+          <a:solidFill xmlns:a="http://schemas.openxmlformats.org/drawingml/2006/main">
+            <a:srgbClr val="EDEDED"/>
+          </a:solidFill>
+        </p:spPr>
+      </p:sp>
+      <p:sp>
+        <p:nvSpPr>
+          <p:cNvPr id="6" name="text-69-254">
+            <a:extLst xmlns:a="http://schemas.openxmlformats.org/drawingml/2006/main">
+              <a:ext uri="{FF2B5EF4-FFF2-40B4-BE49-F238E27FC236}">
+                <a16:creationId xmlns:a16="http://schemas.microsoft.com/office/drawing/2014/main" id="{FEBA4D97-4910-4EC8-9008-1CC8E344CEC3}"/>
+              </a:ext>
+            </a:extLst>
+          </p:cNvPr>
+          <p:cNvSpPr>
+            <a:spLocks xmlns:a="http://schemas.openxmlformats.org/drawingml/2006/main" noGrp="1"/>
+          </p:cNvSpPr>
+          <p:nvPr/>
+        </p:nvSpPr>
+        <p:spPr>
+          <a:xfrm xmlns:a="http://schemas.openxmlformats.org/drawingml/2006/main">
+            <a:off x="657225" y="2419350"/>
+            <a:ext cx="2762250" cy="838200"/>
+          </a:xfrm>
+          <a:prstGeom xmlns:a="http://schemas.openxmlformats.org/drawingml/2006/main" prst="rect">
+            <a:avLst/>
+          </a:prstGeom>
+        </p:spPr>
+        <p:txBody>
+          <a:bodyPr xmlns:a="http://schemas.openxmlformats.org/drawingml/2006/main" lIns="0" tIns="0" rIns="0" bIns="0" anchor="t"/>
+          <a:lstStyle xmlns:a="http://schemas.openxmlformats.org/drawingml/2006/main"/>
+          <a:p xmlns:a="http://schemas.openxmlformats.org/drawingml/2006/main">
+            <a:pPr algn="l">
+              <a:buNone/>
+              <a:defRPr sz="4950" b="1">
+                <a:solidFill>
+                  <a:srgbClr val="0B0D10"/>
+                </a:solidFill>
+              </a:defRPr>
+            </a:pPr>
+            <a:r>
+              <a:t>7.8</a:t>
+            </a:r>
+          </a:p>
+        </p:txBody>
+      </p:sp>
+      <p:sp>
+        <p:nvSpPr>
+          <p:cNvPr id="7" name="text-69-354">
+            <a:extLst xmlns:a="http://schemas.openxmlformats.org/drawingml/2006/main">
+              <a:ext uri="{FF2B5EF4-FFF2-40B4-BE49-F238E27FC236}">
+                <a16:creationId xmlns:a16="http://schemas.microsoft.com/office/drawing/2014/main" id="{B2C5A188-5587-4A4A-927A-A54D89FD78C2}"/>
+              </a:ext>
+            </a:extLst>
+          </p:cNvPr>
+          <p:cNvSpPr>
+            <a:spLocks xmlns:a="http://schemas.openxmlformats.org/drawingml/2006/main" noGrp="1"/>
+          </p:cNvSpPr>
+          <p:nvPr/>
+        </p:nvSpPr>
+        <p:spPr>
+          <a:xfrm xmlns:a="http://schemas.openxmlformats.org/drawingml/2006/main">
+            <a:off x="657225" y="3371850"/>
+            <a:ext cx="2762250" cy="361950"/>
+          </a:xfrm>
+          <a:prstGeom xmlns:a="http://schemas.openxmlformats.org/drawingml/2006/main" prst="rect">
+            <a:avLst/>
+          </a:prstGeom>
+        </p:spPr>
+        <p:txBody>
+          <a:bodyPr xmlns:a="http://schemas.openxmlformats.org/drawingml/2006/main" lIns="0" tIns="0" rIns="0" bIns="0" anchor="t"/>
+          <a:lstStyle xmlns:a="http://schemas.openxmlformats.org/drawingml/2006/main"/>
+          <a:p xmlns:a="http://schemas.openxmlformats.org/drawingml/2006/main">
+            <a:pPr algn="l">
+              <a:buNone/>
+              <a:defRPr sz="1950" b="1">
+                <a:solidFill>
+                  <a:srgbClr val="0B0D10"/>
+                </a:solidFill>
+              </a:defRPr>
+            </a:pPr>
+            <a:r>
+              <a:t>Сейчас</a:t>
+            </a:r>
+          </a:p>
+        </p:txBody>
+      </p:sp>
+      <p:sp>
+        <p:nvSpPr>
+          <p:cNvPr id="8" name="text-69-418">
+            <a:extLst xmlns:a="http://schemas.openxmlformats.org/drawingml/2006/main">
+              <a:ext uri="{FF2B5EF4-FFF2-40B4-BE49-F238E27FC236}">
+                <a16:creationId xmlns:a16="http://schemas.microsoft.com/office/drawing/2014/main" id="{EAA35A75-54EE-4FE0-93D1-1DB9FDE2DDFD}"/>
+              </a:ext>
+            </a:extLst>
+          </p:cNvPr>
+          <p:cNvSpPr>
+            <a:spLocks xmlns:a="http://schemas.openxmlformats.org/drawingml/2006/main" noGrp="1"/>
+          </p:cNvSpPr>
+          <p:nvPr/>
+        </p:nvSpPr>
+        <p:spPr>
+          <a:xfrm xmlns:a="http://schemas.openxmlformats.org/drawingml/2006/main">
+            <a:off x="657225" y="3981450"/>
+            <a:ext cx="2714625" cy="1000125"/>
+          </a:xfrm>
+          <a:prstGeom xmlns:a="http://schemas.openxmlformats.org/drawingml/2006/main" prst="rect">
+            <a:avLst/>
+          </a:prstGeom>
+        </p:spPr>
+        <p:txBody>
+          <a:bodyPr xmlns:a="http://schemas.openxmlformats.org/drawingml/2006/main" lIns="0" tIns="0" rIns="0" bIns="0" anchor="t"/>
+          <a:lstStyle xmlns:a="http://schemas.openxmlformats.org/drawingml/2006/main"/>
+          <a:p xmlns:a="http://schemas.openxmlformats.org/drawingml/2006/main">
+            <a:pPr algn="l">
+              <a:buNone/>
+              <a:defRPr sz="1500" b="0">
+                <a:solidFill>
+                  <a:srgbClr val="0B0D10"/>
+                </a:solidFill>
+              </a:defRPr>
+            </a:pPr>
+            <a:r>
+              <a:t>Frozen v2 + live four-service PASS. External submission: NOT_COLLECTED.</a:t>
+            </a:r>
+          </a:p>
+        </p:txBody>
+      </p:sp>
+      <p:sp>
+        <p:nvSpPr>
+          <p:cNvPr id="9" name="text-489-206">
+            <a:extLst xmlns:a="http://schemas.openxmlformats.org/drawingml/2006/main">
+              <a:ext uri="{FF2B5EF4-FFF2-40B4-BE49-F238E27FC236}">
+                <a16:creationId xmlns:a16="http://schemas.microsoft.com/office/drawing/2014/main" id="{B5431607-40D5-4ADF-8839-50FDE7F6F7A2}"/>
+              </a:ext>
+            </a:extLst>
+          </p:cNvPr>
+          <p:cNvSpPr>
+            <a:spLocks xmlns:a="http://schemas.openxmlformats.org/drawingml/2006/main" noGrp="1"/>
+          </p:cNvSpPr>
+          <p:nvPr/>
+        </p:nvSpPr>
+        <p:spPr>
+          <a:xfrm xmlns:a="http://schemas.openxmlformats.org/drawingml/2006/main">
+            <a:off x="4657725" y="1962150"/>
+            <a:ext cx="2762250" cy="838200"/>
+          </a:xfrm>
+          <a:prstGeom xmlns:a="http://schemas.openxmlformats.org/drawingml/2006/main" prst="rect">
+            <a:avLst/>
+          </a:prstGeom>
+        </p:spPr>
+        <p:txBody>
+          <a:bodyPr xmlns:a="http://schemas.openxmlformats.org/drawingml/2006/main" lIns="0" tIns="0" rIns="0" bIns="0" anchor="t"/>
+          <a:lstStyle xmlns:a="http://schemas.openxmlformats.org/drawingml/2006/main"/>
+          <a:p xmlns:a="http://schemas.openxmlformats.org/drawingml/2006/main">
+            <a:pPr algn="l">
+              <a:buNone/>
+              <a:defRPr sz="4950" b="1">
+                <a:solidFill>
+                  <a:srgbClr val="FF6B35"/>
+                </a:solidFill>
+              </a:defRPr>
+            </a:pPr>
+            <a:r>
+              <a:t>9.5</a:t>
+            </a:r>
+          </a:p>
+        </p:txBody>
+      </p:sp>
+      <p:sp>
+        <p:nvSpPr>
+          <p:cNvPr id="10" name="text-489-306">
+            <a:extLst xmlns:a="http://schemas.openxmlformats.org/drawingml/2006/main">
+              <a:ext uri="{FF2B5EF4-FFF2-40B4-BE49-F238E27FC236}">
+                <a16:creationId xmlns:a16="http://schemas.microsoft.com/office/drawing/2014/main" id="{0AAA1054-1482-4898-9013-7CEC14E283B4}"/>
+              </a:ext>
+            </a:extLst>
+          </p:cNvPr>
+          <p:cNvSpPr>
+            <a:spLocks xmlns:a="http://schemas.openxmlformats.org/drawingml/2006/main" noGrp="1"/>
+          </p:cNvSpPr>
+          <p:nvPr/>
+        </p:nvSpPr>
+        <p:spPr>
+          <a:xfrm xmlns:a="http://schemas.openxmlformats.org/drawingml/2006/main">
+            <a:off x="4657725" y="2914650"/>
+            <a:ext cx="2762250" cy="361950"/>
+          </a:xfrm>
+          <a:prstGeom xmlns:a="http://schemas.openxmlformats.org/drawingml/2006/main" prst="rect">
+            <a:avLst/>
+          </a:prstGeom>
+        </p:spPr>
+        <p:txBody>
+          <a:bodyPr xmlns:a="http://schemas.openxmlformats.org/drawingml/2006/main" lIns="0" tIns="0" rIns="0" bIns="0" anchor="t"/>
+          <a:lstStyle xmlns:a="http://schemas.openxmlformats.org/drawingml/2006/main"/>
+          <a:p xmlns:a="http://schemas.openxmlformats.org/drawingml/2006/main">
+            <a:pPr algn="l">
+              <a:buNone/>
+              <a:defRPr sz="1950" b="1">
+                <a:solidFill>
+                  <a:srgbClr val="0B0D10"/>
+                </a:solidFill>
+              </a:defRPr>
+            </a:pPr>
+            <a:r>
+              <a:t>External blind v2 PASS</a:t>
+            </a:r>
+          </a:p>
+        </p:txBody>
+      </p:sp>
+      <p:sp>
+        <p:nvSpPr>
+          <p:cNvPr id="11" name="text-489-370">
+            <a:extLst xmlns:a="http://schemas.openxmlformats.org/drawingml/2006/main">
+              <a:ext uri="{FF2B5EF4-FFF2-40B4-BE49-F238E27FC236}">
+                <a16:creationId xmlns:a16="http://schemas.microsoft.com/office/drawing/2014/main" id="{6612D925-5A26-4E5F-AD81-B792370639FE}"/>
+              </a:ext>
+            </a:extLst>
+          </p:cNvPr>
+          <p:cNvSpPr>
+            <a:spLocks xmlns:a="http://schemas.openxmlformats.org/drawingml/2006/main" noGrp="1"/>
+          </p:cNvSpPr>
+          <p:nvPr/>
+        </p:nvSpPr>
+        <p:spPr>
+          <a:xfrm xmlns:a="http://schemas.openxmlformats.org/drawingml/2006/main">
+            <a:off x="4657725" y="3524250"/>
+            <a:ext cx="2714625" cy="1371600"/>
+          </a:xfrm>
+          <a:prstGeom xmlns:a="http://schemas.openxmlformats.org/drawingml/2006/main" prst="rect">
+            <a:avLst/>
+          </a:prstGeom>
+        </p:spPr>
+        <p:txBody>
+          <a:bodyPr xmlns:a="http://schemas.openxmlformats.org/drawingml/2006/main" lIns="0" tIns="0" rIns="0" bIns="0" anchor="t"/>
+          <a:lstStyle xmlns:a="http://schemas.openxmlformats.org/drawingml/2006/main"/>
+          <a:p xmlns:a="http://schemas.openxmlformats.org/drawingml/2006/main">
+            <a:pPr algn="l">
+              <a:buNone/>
+              <a:defRPr sz="1500" b="0">
+                <a:solidFill>
+                  <a:srgbClr val="0B0D10"/>
+                </a:solidFill>
+              </a:defRPr>
+            </a:pPr>
+            <a:r>
+              <a:t>Outside author: hidden graphs, clean commit, source hashes, one-shot reveal, Ed25519 signature.</a:t>
+            </a:r>
+          </a:p>
+        </p:txBody>
+      </p:sp>
+      <p:sp>
+        <p:nvSpPr>
+          <p:cNvPr id="12" name="text-909-158">
+            <a:extLst xmlns:a="http://schemas.openxmlformats.org/drawingml/2006/main">
+              <a:ext uri="{FF2B5EF4-FFF2-40B4-BE49-F238E27FC236}">
+                <a16:creationId xmlns:a16="http://schemas.microsoft.com/office/drawing/2014/main" id="{E6887C07-1C69-4285-8D09-01C9C9ED490B}"/>
+              </a:ext>
+            </a:extLst>
+          </p:cNvPr>
+          <p:cNvSpPr>
+            <a:spLocks xmlns:a="http://schemas.openxmlformats.org/drawingml/2006/main" noGrp="1"/>
+          </p:cNvSpPr>
+          <p:nvPr/>
+        </p:nvSpPr>
+        <p:spPr>
+          <a:xfrm xmlns:a="http://schemas.openxmlformats.org/drawingml/2006/main">
+            <a:off x="8658225" y="1504950"/>
+            <a:ext cx="2762250" cy="838200"/>
+          </a:xfrm>
+          <a:prstGeom xmlns:a="http://schemas.openxmlformats.org/drawingml/2006/main" prst="rect">
+            <a:avLst/>
+          </a:prstGeom>
+        </p:spPr>
+        <p:txBody>
+          <a:bodyPr xmlns:a="http://schemas.openxmlformats.org/drawingml/2006/main" lIns="0" tIns="0" rIns="0" bIns="0" anchor="t"/>
+          <a:lstStyle xmlns:a="http://schemas.openxmlformats.org/drawingml/2006/main"/>
+          <a:p xmlns:a="http://schemas.openxmlformats.org/drawingml/2006/main">
+            <a:pPr algn="l">
+              <a:buNone/>
+              <a:defRPr sz="4950" b="1">
+                <a:solidFill>
+                  <a:srgbClr val="0B0D10"/>
+                </a:solidFill>
+              </a:defRPr>
+            </a:pPr>
+            <a:r>
+              <a:t>9.8</a:t>
+            </a:r>
+          </a:p>
+        </p:txBody>
+      </p:sp>
+      <p:sp>
+        <p:nvSpPr>
+          <p:cNvPr id="13" name="text-909-258">
+            <a:extLst xmlns:a="http://schemas.openxmlformats.org/drawingml/2006/main">
+              <a:ext uri="{FF2B5EF4-FFF2-40B4-BE49-F238E27FC236}">
+                <a16:creationId xmlns:a16="http://schemas.microsoft.com/office/drawing/2014/main" id="{CC51D3AE-A8A3-47B0-93A7-F47E75AAC3D7}"/>
+              </a:ext>
+            </a:extLst>
+          </p:cNvPr>
+          <p:cNvSpPr>
+            <a:spLocks xmlns:a="http://schemas.openxmlformats.org/drawingml/2006/main" noGrp="1"/>
+          </p:cNvSpPr>
+          <p:nvPr/>
+        </p:nvSpPr>
+        <p:spPr>
+          <a:xfrm xmlns:a="http://schemas.openxmlformats.org/drawingml/2006/main">
+            <a:off x="8658225" y="2457450"/>
+            <a:ext cx="2762250" cy="361950"/>
+          </a:xfrm>
+          <a:prstGeom xmlns:a="http://schemas.openxmlformats.org/drawingml/2006/main" prst="rect">
+            <a:avLst/>
+          </a:prstGeom>
+        </p:spPr>
+        <p:txBody>
+          <a:bodyPr xmlns:a="http://schemas.openxmlformats.org/drawingml/2006/main" lIns="0" tIns="0" rIns="0" bIns="0" anchor="t"/>
+          <a:lstStyle xmlns:a="http://schemas.openxmlformats.org/drawingml/2006/main"/>
+          <a:p xmlns:a="http://schemas.openxmlformats.org/drawingml/2006/main">
+            <a:pPr algn="l">
+              <a:buNone/>
+              <a:defRPr sz="1950" b="1">
+                <a:solidFill>
+                  <a:srgbClr val="0B0D10"/>
+                </a:solidFill>
+              </a:defRPr>
+            </a:pPr>
+            <a:r>
+              <a:t>Репликация</a:t>
+            </a:r>
+          </a:p>
+        </p:txBody>
+      </p:sp>
+      <p:sp>
+        <p:nvSpPr>
+          <p:cNvPr id="14" name="text-909-322">
+            <a:extLst xmlns:a="http://schemas.openxmlformats.org/drawingml/2006/main">
+              <a:ext uri="{FF2B5EF4-FFF2-40B4-BE49-F238E27FC236}">
+                <a16:creationId xmlns:a16="http://schemas.microsoft.com/office/drawing/2014/main" id="{BD2231AD-8BC9-45FD-9C19-8F3F5902B986}"/>
+              </a:ext>
+            </a:extLst>
+          </p:cNvPr>
+          <p:cNvSpPr>
+            <a:spLocks xmlns:a="http://schemas.openxmlformats.org/drawingml/2006/main" noGrp="1"/>
+          </p:cNvSpPr>
+          <p:nvPr/>
+        </p:nvSpPr>
+        <p:spPr>
+          <a:xfrm xmlns:a="http://schemas.openxmlformats.org/drawingml/2006/main">
+            <a:off x="8658225" y="3067050"/>
+            <a:ext cx="2714625" cy="1371600"/>
+          </a:xfrm>
+          <a:prstGeom xmlns:a="http://schemas.openxmlformats.org/drawingml/2006/main" prst="rect">
+            <a:avLst/>
+          </a:prstGeom>
+        </p:spPr>
+        <p:txBody>
+          <a:bodyPr xmlns:a="http://schemas.openxmlformats.org/drawingml/2006/main" lIns="0" tIns="0" rIns="0" bIns="0" anchor="t"/>
+          <a:lstStyle xmlns:a="http://schemas.openxmlformats.org/drawingml/2006/main"/>
+          <a:p xmlns:a="http://schemas.openxmlformats.org/drawingml/2006/main">
+            <a:pPr algn="l">
+              <a:buNone/>
+              <a:defRPr sz="1500" b="0">
+                <a:solidFill>
+                  <a:srgbClr val="0B0D10"/>
+                </a:solidFill>
+              </a:defRPr>
+            </a:pPr>
+            <a:r>
+              <a:t>Два независимых evaluator или одна authorized organization на materially different systems.</a:t>
+            </a:r>
+          </a:p>
+        </p:txBody>
+      </p:sp>
+      <p:sp>
+        <p:nvSpPr>
+          <p:cNvPr id="15" name="text-42-625">
+            <a:extLst xmlns:a="http://schemas.openxmlformats.org/drawingml/2006/main">
+              <a:ext uri="{FF2B5EF4-FFF2-40B4-BE49-F238E27FC236}">
+                <a16:creationId xmlns:a16="http://schemas.microsoft.com/office/drawing/2014/main" id="{9E1F4E86-6ACB-42E1-A881-42F5336F2BB2}"/>
+              </a:ext>
+            </a:extLst>
+          </p:cNvPr>
+          <p:cNvSpPr>
+            <a:spLocks xmlns:a="http://schemas.openxmlformats.org/drawingml/2006/main" noGrp="1"/>
+          </p:cNvSpPr>
+          <p:nvPr/>
+        </p:nvSpPr>
+        <p:spPr>
+          <a:xfrm xmlns:a="http://schemas.openxmlformats.org/drawingml/2006/main">
+            <a:off x="400050" y="5953125"/>
+            <a:ext cx="8572500" cy="323850"/>
+          </a:xfrm>
+          <a:prstGeom xmlns:a="http://schemas.openxmlformats.org/drawingml/2006/main" prst="rect">
+            <a:avLst/>
+          </a:prstGeom>
+        </p:spPr>
+        <p:txBody>
+          <a:bodyPr xmlns:a="http://schemas.openxmlformats.org/drawingml/2006/main" lIns="0" tIns="0" rIns="0" bIns="0" anchor="t"/>
+          <a:lstStyle xmlns:a="http://schemas.openxmlformats.org/drawingml/2006/main"/>
+          <a:p xmlns:a="http://schemas.openxmlformats.org/drawingml/2006/main">
+            <a:pPr algn="l">
+              <a:buNone/>
+              <a:defRPr sz="1500" b="1">
+                <a:solidFill>
+                  <a:srgbClr val="FF6B35"/>
+                </a:solidFill>
+              </a:defRPr>
+            </a:pPr>
+            <a:r>
+              <a:t>Только external authorship двигает independence; local work повышает readiness.</a:t>
+            </a:r>
+          </a:p>
+        </p:txBody>
+      </p:sp>
+      <p:sp>
+        <p:nvSpPr>
+          <p:cNvPr id="16" name="slide-number-10">
+            <a:extLst xmlns:a="http://schemas.openxmlformats.org/drawingml/2006/main">
+              <a:ext uri="{FF2B5EF4-FFF2-40B4-BE49-F238E27FC236}">
+                <a16:creationId xmlns:a16="http://schemas.microsoft.com/office/drawing/2014/main" id="{1330B4F0-6E7D-4086-B860-39A5CC3E6515}"/>
+              </a:ext>
+            </a:extLst>
+          </p:cNvPr>
+          <p:cNvSpPr>
+            <a:spLocks xmlns:a="http://schemas.openxmlformats.org/drawingml/2006/main" noGrp="1"/>
+          </p:cNvSpPr>
+          <p:nvPr/>
+        </p:nvSpPr>
+        <p:spPr>
+          <a:xfrm xmlns:a="http://schemas.openxmlformats.org/drawingml/2006/main">
+            <a:off x="11258550" y="6324600"/>
+            <a:ext cx="523875" cy="228600"/>
+          </a:xfrm>
+          <a:prstGeom xmlns:a="http://schemas.openxmlformats.org/drawingml/2006/main" prst="rect">
+            <a:avLst/>
+          </a:prstGeom>
+        </p:spPr>
+        <p:txBody>
+          <a:bodyPr xmlns:a="http://schemas.openxmlformats.org/drawingml/2006/main" lIns="0" tIns="0" rIns="0" bIns="0" anchor="t"/>
+          <a:lstStyle xmlns:a="http://schemas.openxmlformats.org/drawingml/2006/main"/>
+          <a:p xmlns:a="http://schemas.openxmlformats.org/drawingml/2006/main">
+            <a:pPr algn="r">
+              <a:buNone/>
+              <a:defRPr sz="1125" b="0">
+                <a:solidFill>
+                  <a:srgbClr val="555B63"/>
+                </a:solidFill>
+              </a:defRPr>
+            </a:pPr>
+            <a:r>
+              <a:t>12</a:t>
+            </a:r>
+          </a:p>
+        </p:txBody>
+      </p:sp>
+    </p:spTree>
+    <p:extLst>
+      <p:ext uri="{BB962C8B-B14F-4D97-AF65-F5344CB8AC3E}">
+        <p14:creationId xmlns:p14="http://schemas.microsoft.com/office/powerpoint/2010/main" val="27292007"/>
+      </p:ext>
+    </p:extLst>
+  </p:cSld>
+</p:sld>
+</file>
+
+<file path=ppt/slides/slide13.xml><?xml version="1.0" encoding="utf-8"?>
+<p:sld xmlns:p="http://schemas.openxmlformats.org/presentationml/2006/main">
+  <p:cSld>
+    <p:bg>
+      <p:bgPr>
+        <a:solidFill xmlns:a="http://schemas.openxmlformats.org/drawingml/2006/main">
+          <a:srgbClr val="FFFFFF"/>
+        </a:solidFill>
+      </p:bgPr>
+    </p:bg>
+    <p:spTree>
+      <p:nvGrpSpPr>
+        <p:cNvPr id="1" name=""/>
+        <p:cNvGrpSpPr/>
+        <p:nvPr/>
+      </p:nvGrpSpPr>
+      <p:grpSpPr>
+        <a:xfrm xmlns:a="http://schemas.openxmlformats.org/drawingml/2006/main"/>
+      </p:grpSpPr>
+      <p:sp>
+        <p:nvSpPr>
+          <p:cNvPr id="14" name="text-42-38">
+            <a:extLst xmlns:a="http://schemas.openxmlformats.org/drawingml/2006/main">
+              <a:ext uri="{FF2B5EF4-FFF2-40B4-BE49-F238E27FC236}">
                 <a16:creationId xmlns:a16="http://schemas.microsoft.com/office/drawing/2014/main" id="{41BD4B4C-46C1-4BDC-AFF3-8DEEE76E6031}"/>
               </a:ext>
             </a:extLst>
@@ -3353,7 +4561,7 @@
               </a:defRPr>
             </a:pPr>
             <a:r>
-              <a:t>Formal + measured systems + reproducible jury demo</a:t>
+              <a:t>Formal + measured systems + GhostGraph live + jury demo</a:t>
             </a:r>
           </a:p>
         </p:txBody>
@@ -3435,7 +4643,7 @@
               </a:defRPr>
             </a:pPr>
             <a:r>
-              <a:t>Независимый hidden challenge без изменения алгоритма</a:t>
+              <a:t>Blind v2 evaluator-authored challenge; algorithm frozen</a:t>
             </a:r>
           </a:p>
         </p:txBody>
@@ -3558,7 +4766,7 @@
               </a:defRPr>
             </a:pPr>
             <a:r>
-              <a:t>11</a:t>
+              <a:t>13</a:t>
             </a:r>
           </a:p>
         </p:txBody>
@@ -6176,7 +7384,7 @@
         </p:xfrm>
         <a:graphic xmlns:a="http://schemas.openxmlformats.org/drawingml/2006/main">
           <a:graphicData uri="http://schemas.openxmlformats.org/drawingml/2006/chart">
-            <c:chart xmlns:r="http://schemas.openxmlformats.org/officeDocument/2006/relationships" xmlns:c="http://schemas.openxmlformats.org/drawingml/2006/chart" r:id="R2fe7050674d8484c"/>
+            <c:chart xmlns:r="http://schemas.openxmlformats.org/officeDocument/2006/relationships" xmlns:c="http://schemas.openxmlformats.org/drawingml/2006/chart" r:id="R369af27eb41b4698"/>
           </a:graphicData>
         </a:graphic>
       </p:graphicFrame>
@@ -7137,7 +8345,7 @@
         </p:xfrm>
         <a:graphic xmlns:a="http://schemas.openxmlformats.org/drawingml/2006/main">
           <a:graphicData uri="http://schemas.openxmlformats.org/drawingml/2006/chart">
-            <c:chart xmlns:r="http://schemas.openxmlformats.org/officeDocument/2006/relationships" xmlns:c="http://schemas.openxmlformats.org/drawingml/2006/chart" r:id="R8a323f633dec4e35"/>
+            <c:chart xmlns:r="http://schemas.openxmlformats.org/officeDocument/2006/relationships" xmlns:c="http://schemas.openxmlformats.org/drawingml/2006/chart" r:id="Rbdf0e97d33d14435"/>
           </a:graphicData>
         </a:graphic>
       </p:graphicFrame>
@@ -7575,7 +8783,7 @@
           <p:nvPr/>
         </p:nvPicPr>
         <p:blipFill>
-          <a:blip xmlns:r="http://schemas.openxmlformats.org/officeDocument/2006/relationships" xmlns:a="http://schemas.openxmlformats.org/drawingml/2006/main" r:embed="Rb131826b7ce14bd2"/>
+          <a:blip xmlns:r="http://schemas.openxmlformats.org/officeDocument/2006/relationships" xmlns:a="http://schemas.openxmlformats.org/drawingml/2006/main" r:embed="R295d5bafa9af435c"/>
           <a:stretch xmlns:a="http://schemas.openxmlformats.org/drawingml/2006/main"/>
         </p:blipFill>
         <p:spPr>
@@ -7619,10 +8827,10 @@
       </p:grpSpPr>
       <p:sp>
         <p:nvSpPr>
-          <p:cNvPr id="14" name="text-42-38">
-            <a:extLst xmlns:a="http://schemas.openxmlformats.org/drawingml/2006/main">
-              <a:ext uri="{FF2B5EF4-FFF2-40B4-BE49-F238E27FC236}">
-                <a16:creationId xmlns:a16="http://schemas.microsoft.com/office/drawing/2014/main" id="{88149F28-389D-4D06-9718-A82BEBB3178D}"/>
+          <p:cNvPr id="17" name="text-42-38">
+            <a:extLst xmlns:a="http://schemas.openxmlformats.org/drawingml/2006/main">
+              <a:ext uri="{FF2B5EF4-FFF2-40B4-BE49-F238E27FC236}">
+                <a16:creationId xmlns:a16="http://schemas.microsoft.com/office/drawing/2014/main" id="{2ADB0BFD-EE7A-443A-83CD-513916D74904}"/>
               </a:ext>
             </a:extLst>
           </p:cNvPr>
@@ -7634,7 +8842,7 @@
         <p:spPr>
           <a:xfrm xmlns:a="http://schemas.openxmlformats.org/drawingml/2006/main">
             <a:off x="400050" y="361950"/>
-            <a:ext cx="4572000" cy="266700"/>
+            <a:ext cx="2381250" cy="266700"/>
           </a:xfrm>
           <a:prstGeom xmlns:a="http://schemas.openxmlformats.org/drawingml/2006/main" prst="rect">
             <a:avLst/>
@@ -7653,7 +8861,7 @@
               </a:defRPr>
             </a:pPr>
             <a:r>
-              <a:t>08  Новизна без преувеличения</a:t>
+              <a:t>08  GhostGraph</a:t>
             </a:r>
           </a:p>
         </p:txBody>
@@ -7663,7 +8871,7 @@
           <p:cNvPr id="2" name="text-42-84">
             <a:extLst xmlns:a="http://schemas.openxmlformats.org/drawingml/2006/main">
               <a:ext uri="{FF2B5EF4-FFF2-40B4-BE49-F238E27FC236}">
-                <a16:creationId xmlns:a16="http://schemas.microsoft.com/office/drawing/2014/main" id="{BE6D6434-59FB-440F-980D-9D9148C7FC53}"/>
+                <a16:creationId xmlns:a16="http://schemas.microsoft.com/office/drawing/2014/main" id="{2E76A229-3DE9-46C2-9053-9CE86CB43DB6}"/>
               </a:ext>
             </a:extLst>
           </p:cNvPr>
@@ -7675,48 +8883,48 @@
         <p:spPr>
           <a:xfrm xmlns:a="http://schemas.openxmlformats.org/drawingml/2006/main">
             <a:off x="400050" y="800100"/>
-            <a:ext cx="10668000" cy="647700"/>
-          </a:xfrm>
-          <a:prstGeom xmlns:a="http://schemas.openxmlformats.org/drawingml/2006/main" prst="rect">
-            <a:avLst/>
-          </a:prstGeom>
-        </p:spPr>
-        <p:txBody>
-          <a:bodyPr xmlns:a="http://schemas.openxmlformats.org/drawingml/2006/main" lIns="0" tIns="0" rIns="0" bIns="0" anchor="t"/>
-          <a:lstStyle xmlns:a="http://schemas.openxmlformats.org/drawingml/2006/main"/>
-          <a:p xmlns:a="http://schemas.openxmlformats.org/drawingml/2006/main">
-            <a:pPr algn="l">
-              <a:buNone/>
-              <a:defRPr sz="3375" b="1">
+            <a:ext cx="8001000" cy="666750"/>
+          </a:xfrm>
+          <a:prstGeom xmlns:a="http://schemas.openxmlformats.org/drawingml/2006/main" prst="rect">
+            <a:avLst/>
+          </a:prstGeom>
+        </p:spPr>
+        <p:txBody>
+          <a:bodyPr xmlns:a="http://schemas.openxmlformats.org/drawingml/2006/main" lIns="0" tIns="0" rIns="0" bIns="0" anchor="t"/>
+          <a:lstStyle xmlns:a="http://schemas.openxmlformats.org/drawingml/2006/main"/>
+          <a:p xmlns:a="http://schemas.openxmlformats.org/drawingml/2006/main">
+            <a:pPr algn="l">
+              <a:buNone/>
+              <a:defRPr sz="3600" b="1">
                 <a:solidFill>
                   <a:srgbClr val="0B0D10"/>
                 </a:solidFill>
               </a:defRPr>
             </a:pPr>
             <a:r>
-              <a:t>Композиция — вклад. Компоненты — prior art.</a:t>
-            </a:r>
-          </a:p>
-        </p:txBody>
-      </p:sp>
-      <p:sp>
-        <p:nvSpPr>
-          <p:cNvPr id="3" name="novel-known">
-            <a:extLst xmlns:a="http://schemas.openxmlformats.org/drawingml/2006/main">
-              <a:ext uri="{FF2B5EF4-FFF2-40B4-BE49-F238E27FC236}">
-                <a16:creationId xmlns:a16="http://schemas.microsoft.com/office/drawing/2014/main" id="{6CB3F883-8645-4CCF-8509-0192D3BDBF13}"/>
-              </a:ext>
-            </a:extLst>
-          </p:cNvPr>
-          <p:cNvSpPr>
-            <a:spLocks xmlns:a="http://schemas.openxmlformats.org/drawingml/2006/main" noGrp="1"/>
-          </p:cNvSpPr>
-          <p:nvPr/>
-        </p:nvSpPr>
-        <p:spPr>
-          <a:xfrm xmlns:a="http://schemas.openxmlformats.org/drawingml/2006/main">
-            <a:off x="400050" y="1924050"/>
-            <a:ext cx="3381375" cy="3714750"/>
+              <a:t>Ищем неизвестный путь — не верим карте</a:t>
+            </a:r>
+          </a:p>
+        </p:txBody>
+      </p:sp>
+      <p:sp>
+        <p:nvSpPr>
+          <p:cNvPr id="3" name="method-graph">
+            <a:extLst xmlns:a="http://schemas.openxmlformats.org/drawingml/2006/main">
+              <a:ext uri="{FF2B5EF4-FFF2-40B4-BE49-F238E27FC236}">
+                <a16:creationId xmlns:a16="http://schemas.microsoft.com/office/drawing/2014/main" id="{445AA98D-987E-4D2F-AC41-2E3600D04403}"/>
+              </a:ext>
+            </a:extLst>
+          </p:cNvPr>
+          <p:cNvSpPr>
+            <a:spLocks xmlns:a="http://schemas.openxmlformats.org/drawingml/2006/main" noGrp="1"/>
+          </p:cNvSpPr>
+          <p:nvPr/>
+        </p:nvSpPr>
+        <p:spPr>
+          <a:xfrm xmlns:a="http://schemas.openxmlformats.org/drawingml/2006/main">
+            <a:off x="400050" y="2028825"/>
+            <a:ext cx="3381375" cy="3476625"/>
           </a:xfrm>
           <a:prstGeom xmlns:a="http://schemas.openxmlformats.org/drawingml/2006/main" prst="rect">
             <a:avLst/>
@@ -7728,49 +8936,22 @@
       </p:sp>
       <p:sp>
         <p:nvSpPr>
-          <p:cNvPr id="4" name="novel-contribution">
-            <a:extLst xmlns:a="http://schemas.openxmlformats.org/drawingml/2006/main">
-              <a:ext uri="{FF2B5EF4-FFF2-40B4-BE49-F238E27FC236}">
-                <a16:creationId xmlns:a16="http://schemas.microsoft.com/office/drawing/2014/main" id="{0F183184-76A7-4A8B-82E1-ADD6C4487F45}"/>
-              </a:ext>
-            </a:extLst>
-          </p:cNvPr>
-          <p:cNvSpPr>
-            <a:spLocks xmlns:a="http://schemas.openxmlformats.org/drawingml/2006/main" noGrp="1"/>
-          </p:cNvSpPr>
-          <p:nvPr/>
-        </p:nvSpPr>
-        <p:spPr>
-          <a:xfrm xmlns:a="http://schemas.openxmlformats.org/drawingml/2006/main">
-            <a:off x="4400550" y="1924050"/>
-            <a:ext cx="3381375" cy="3714750"/>
-          </a:xfrm>
-          <a:prstGeom xmlns:a="http://schemas.openxmlformats.org/drawingml/2006/main" prst="rect">
-            <a:avLst/>
-          </a:prstGeom>
-          <a:solidFill xmlns:a="http://schemas.openxmlformats.org/drawingml/2006/main">
-            <a:srgbClr val="F7E8E3"/>
-          </a:solidFill>
-        </p:spPr>
-      </p:sp>
-      <p:sp>
-        <p:nvSpPr>
-          <p:cNvPr id="5" name="novel-no-claim">
-            <a:extLst xmlns:a="http://schemas.openxmlformats.org/drawingml/2006/main">
-              <a:ext uri="{FF2B5EF4-FFF2-40B4-BE49-F238E27FC236}">
-                <a16:creationId xmlns:a16="http://schemas.microsoft.com/office/drawing/2014/main" id="{421AC173-16AB-4CD8-8662-E7865CC9EC05}"/>
-              </a:ext>
-            </a:extLst>
-          </p:cNvPr>
-          <p:cNvSpPr>
-            <a:spLocks xmlns:a="http://schemas.openxmlformats.org/drawingml/2006/main" noGrp="1"/>
-          </p:cNvSpPr>
-          <p:nvPr/>
-        </p:nvSpPr>
-        <p:spPr>
-          <a:xfrm xmlns:a="http://schemas.openxmlformats.org/drawingml/2006/main">
-            <a:off x="8401050" y="1924050"/>
-            <a:ext cx="3381375" cy="3714750"/>
+          <p:cNvPr id="4" name="method-proof">
+            <a:extLst xmlns:a="http://schemas.openxmlformats.org/drawingml/2006/main">
+              <a:ext uri="{FF2B5EF4-FFF2-40B4-BE49-F238E27FC236}">
+                <a16:creationId xmlns:a16="http://schemas.microsoft.com/office/drawing/2014/main" id="{9C8CC1B5-F2AE-4AB0-A69F-0F64D2392AD8}"/>
+              </a:ext>
+            </a:extLst>
+          </p:cNvPr>
+          <p:cNvSpPr>
+            <a:spLocks xmlns:a="http://schemas.openxmlformats.org/drawingml/2006/main" noGrp="1"/>
+          </p:cNvSpPr>
+          <p:nvPr/>
+        </p:nvSpPr>
+        <p:spPr>
+          <a:xfrm xmlns:a="http://schemas.openxmlformats.org/drawingml/2006/main">
+            <a:off x="4400550" y="2028825"/>
+            <a:ext cx="3381375" cy="3476625"/>
           </a:xfrm>
           <a:prstGeom xmlns:a="http://schemas.openxmlformats.org/drawingml/2006/main" prst="rect">
             <a:avLst/>
@@ -7782,304 +8963,447 @@
       </p:sp>
       <p:sp>
         <p:nvSpPr>
-          <p:cNvPr id="6" name="text-69-234">
-            <a:extLst xmlns:a="http://schemas.openxmlformats.org/drawingml/2006/main">
-              <a:ext uri="{FF2B5EF4-FFF2-40B4-BE49-F238E27FC236}">
-                <a16:creationId xmlns:a16="http://schemas.microsoft.com/office/drawing/2014/main" id="{53B2EB09-807B-4592-850A-C8BD7C878981}"/>
-              </a:ext>
-            </a:extLst>
-          </p:cNvPr>
-          <p:cNvSpPr>
-            <a:spLocks xmlns:a="http://schemas.openxmlformats.org/drawingml/2006/main" noGrp="1"/>
-          </p:cNvSpPr>
-          <p:nvPr/>
-        </p:nvSpPr>
-        <p:spPr>
-          <a:xfrm xmlns:a="http://schemas.openxmlformats.org/drawingml/2006/main">
-            <a:off x="657225" y="2228850"/>
-            <a:ext cx="2762250" cy="361950"/>
-          </a:xfrm>
-          <a:prstGeom xmlns:a="http://schemas.openxmlformats.org/drawingml/2006/main" prst="rect">
-            <a:avLst/>
-          </a:prstGeom>
-        </p:spPr>
-        <p:txBody>
-          <a:bodyPr xmlns:a="http://schemas.openxmlformats.org/drawingml/2006/main" lIns="0" tIns="0" rIns="0" bIns="0" anchor="t"/>
-          <a:lstStyle xmlns:a="http://schemas.openxmlformats.org/drawingml/2006/main"/>
-          <a:p xmlns:a="http://schemas.openxmlformats.org/drawingml/2006/main">
-            <a:pPr algn="l">
-              <a:buNone/>
-              <a:defRPr sz="1950" b="1">
+          <p:cNvPr id="5" name="method-cut">
+            <a:extLst xmlns:a="http://schemas.openxmlformats.org/drawingml/2006/main">
+              <a:ext uri="{FF2B5EF4-FFF2-40B4-BE49-F238E27FC236}">
+                <a16:creationId xmlns:a16="http://schemas.microsoft.com/office/drawing/2014/main" id="{832FE88C-7A06-4689-B9FE-677AAF5BC175}"/>
+              </a:ext>
+            </a:extLst>
+          </p:cNvPr>
+          <p:cNvSpPr>
+            <a:spLocks xmlns:a="http://schemas.openxmlformats.org/drawingml/2006/main" noGrp="1"/>
+          </p:cNvSpPr>
+          <p:nvPr/>
+        </p:nvSpPr>
+        <p:spPr>
+          <a:xfrm xmlns:a="http://schemas.openxmlformats.org/drawingml/2006/main">
+            <a:off x="8401050" y="2028825"/>
+            <a:ext cx="3381375" cy="3476625"/>
+          </a:xfrm>
+          <a:prstGeom xmlns:a="http://schemas.openxmlformats.org/drawingml/2006/main" prst="rect">
+            <a:avLst/>
+          </a:prstGeom>
+          <a:solidFill xmlns:a="http://schemas.openxmlformats.org/drawingml/2006/main">
+            <a:srgbClr val="EDEDED"/>
+          </a:solidFill>
+        </p:spPr>
+      </p:sp>
+      <p:sp>
+        <p:nvSpPr>
+          <p:cNvPr id="6" name="text-69-238">
+            <a:extLst xmlns:a="http://schemas.openxmlformats.org/drawingml/2006/main">
+              <a:ext uri="{FF2B5EF4-FFF2-40B4-BE49-F238E27FC236}">
+                <a16:creationId xmlns:a16="http://schemas.microsoft.com/office/drawing/2014/main" id="{5214B5B4-F594-4E41-BF81-0744C2AABD8F}"/>
+              </a:ext>
+            </a:extLst>
+          </p:cNvPr>
+          <p:cNvSpPr>
+            <a:spLocks xmlns:a="http://schemas.openxmlformats.org/drawingml/2006/main" noGrp="1"/>
+          </p:cNvSpPr>
+          <p:nvPr/>
+        </p:nvSpPr>
+        <p:spPr>
+          <a:xfrm xmlns:a="http://schemas.openxmlformats.org/drawingml/2006/main">
+            <a:off x="657225" y="2266950"/>
+            <a:ext cx="476250" cy="552450"/>
+          </a:xfrm>
+          <a:prstGeom xmlns:a="http://schemas.openxmlformats.org/drawingml/2006/main" prst="rect">
+            <a:avLst/>
+          </a:prstGeom>
+        </p:spPr>
+        <p:txBody>
+          <a:bodyPr xmlns:a="http://schemas.openxmlformats.org/drawingml/2006/main" lIns="0" tIns="0" rIns="0" bIns="0" anchor="t"/>
+          <a:lstStyle xmlns:a="http://schemas.openxmlformats.org/drawingml/2006/main"/>
+          <a:p xmlns:a="http://schemas.openxmlformats.org/drawingml/2006/main">
+            <a:pPr algn="l">
+              <a:buNone/>
+              <a:defRPr sz="3300" b="1">
+                <a:solidFill>
+                  <a:srgbClr val="FF6B35"/>
+                </a:solidFill>
+              </a:defRPr>
+            </a:pPr>
+            <a:r>
+              <a:t>1</a:t>
+            </a:r>
+          </a:p>
+        </p:txBody>
+      </p:sp>
+      <p:sp>
+        <p:nvSpPr>
+          <p:cNvPr id="7" name="text-69-310">
+            <a:extLst xmlns:a="http://schemas.openxmlformats.org/drawingml/2006/main">
+              <a:ext uri="{FF2B5EF4-FFF2-40B4-BE49-F238E27FC236}">
+                <a16:creationId xmlns:a16="http://schemas.microsoft.com/office/drawing/2014/main" id="{AB868F2D-6282-4435-9814-F1DDB8122F2F}"/>
+              </a:ext>
+            </a:extLst>
+          </p:cNvPr>
+          <p:cNvSpPr>
+            <a:spLocks xmlns:a="http://schemas.openxmlformats.org/drawingml/2006/main" noGrp="1"/>
+          </p:cNvSpPr>
+          <p:nvPr/>
+        </p:nvSpPr>
+        <p:spPr>
+          <a:xfrm xmlns:a="http://schemas.openxmlformats.org/drawingml/2006/main">
+            <a:off x="657225" y="2952750"/>
+            <a:ext cx="2667000" cy="457200"/>
+          </a:xfrm>
+          <a:prstGeom xmlns:a="http://schemas.openxmlformats.org/drawingml/2006/main" prst="rect">
+            <a:avLst/>
+          </a:prstGeom>
+        </p:spPr>
+        <p:txBody>
+          <a:bodyPr xmlns:a="http://schemas.openxmlformats.org/drawingml/2006/main" lIns="0" tIns="0" rIns="0" bIns="0" anchor="t"/>
+          <a:lstStyle xmlns:a="http://schemas.openxmlformats.org/drawingml/2006/main"/>
+          <a:p xmlns:a="http://schemas.openxmlformats.org/drawingml/2006/main">
+            <a:pPr algn="l">
+              <a:buNone/>
+              <a:defRPr sz="2325" b="1">
                 <a:solidFill>
                   <a:srgbClr val="0B0D10"/>
                 </a:solidFill>
               </a:defRPr>
             </a:pPr>
             <a:r>
-              <a:t>Уже существовало</a:t>
-            </a:r>
-          </a:p>
-        </p:txBody>
-      </p:sp>
-      <p:sp>
-        <p:nvSpPr>
-          <p:cNvPr id="7" name="text-69-306">
-            <a:extLst xmlns:a="http://schemas.openxmlformats.org/drawingml/2006/main">
-              <a:ext uri="{FF2B5EF4-FFF2-40B4-BE49-F238E27FC236}">
-                <a16:creationId xmlns:a16="http://schemas.microsoft.com/office/drawing/2014/main" id="{7E3BDE59-9D49-4288-AE30-F43FCFFA28FC}"/>
-              </a:ext>
-            </a:extLst>
-          </p:cNvPr>
-          <p:cNvSpPr>
-            <a:spLocks xmlns:a="http://schemas.openxmlformats.org/drawingml/2006/main" noGrp="1"/>
-          </p:cNvSpPr>
-          <p:nvPr/>
-        </p:nvSpPr>
-        <p:spPr>
-          <a:xfrm xmlns:a="http://schemas.openxmlformats.org/drawingml/2006/main">
-            <a:off x="657225" y="2914650"/>
-            <a:ext cx="2714625" cy="2095500"/>
-          </a:xfrm>
-          <a:prstGeom xmlns:a="http://schemas.openxmlformats.org/drawingml/2006/main" prst="rect">
-            <a:avLst/>
-          </a:prstGeom>
-        </p:spPr>
-        <p:txBody>
-          <a:bodyPr xmlns:a="http://schemas.openxmlformats.org/drawingml/2006/main" lIns="0" tIns="0" rIns="0" bIns="0" anchor="t"/>
-          <a:lstStyle xmlns:a="http://schemas.openxmlformats.org/drawingml/2006/main"/>
-          <a:p xmlns:a="http://schemas.openxmlformats.org/drawingml/2006/main">
-            <a:pPr algn="l">
-              <a:buNone/>
-              <a:defRPr sz="1650" b="0">
+              <a:t>Version space</a:t>
+            </a:r>
+          </a:p>
+        </p:txBody>
+      </p:sp>
+      <p:sp>
+        <p:nvSpPr>
+          <p:cNvPr id="8" name="text-69-378">
+            <a:extLst xmlns:a="http://schemas.openxmlformats.org/drawingml/2006/main">
+              <a:ext uri="{FF2B5EF4-FFF2-40B4-BE49-F238E27FC236}">
+                <a16:creationId xmlns:a16="http://schemas.microsoft.com/office/drawing/2014/main" id="{06B49869-1D9C-4833-A072-0748F8987267}"/>
+              </a:ext>
+            </a:extLst>
+          </p:cNvPr>
+          <p:cNvSpPr>
+            <a:spLocks xmlns:a="http://schemas.openxmlformats.org/drawingml/2006/main" noGrp="1"/>
+          </p:cNvSpPr>
+          <p:nvPr/>
+        </p:nvSpPr>
+        <p:spPr>
+          <a:xfrm xmlns:a="http://schemas.openxmlformats.org/drawingml/2006/main">
+            <a:off x="657225" y="3600450"/>
+            <a:ext cx="2667000" cy="1238250"/>
+          </a:xfrm>
+          <a:prstGeom xmlns:a="http://schemas.openxmlformats.org/drawingml/2006/main" prst="rect">
+            <a:avLst/>
+          </a:prstGeom>
+        </p:spPr>
+        <p:txBody>
+          <a:bodyPr xmlns:a="http://schemas.openxmlformats.org/drawingml/2006/main" lIns="0" tIns="0" rIns="0" bIns="0" anchor="t"/>
+          <a:lstStyle xmlns:a="http://schemas.openxmlformats.org/drawingml/2006/main"/>
+          <a:p xmlns:a="http://schemas.openxmlformats.org/drawingml/2006/main">
+            <a:pPr algn="l">
+              <a:buNone/>
+              <a:defRPr sz="1575" b="0">
                 <a:solidFill>
                   <a:srgbClr val="0B0D10"/>
                 </a:solidFill>
               </a:defRPr>
             </a:pPr>
             <a:r>
-              <a:t>Data lineage
-Machine unlearning
-Proof of deletion
-Min-cut / set cover
-Signed provenance</a:t>
-            </a:r>
-          </a:p>
-        </p:txBody>
-      </p:sp>
-      <p:sp>
-        <p:nvSpPr>
-          <p:cNvPr id="8" name="text-489-234">
-            <a:extLst xmlns:a="http://schemas.openxmlformats.org/drawingml/2006/main">
-              <a:ext uri="{FF2B5EF4-FFF2-40B4-BE49-F238E27FC236}">
-                <a16:creationId xmlns:a16="http://schemas.microsoft.com/office/drawing/2014/main" id="{CF9CC74A-DC0A-4E7D-9EA5-5B88C37AEB47}"/>
-              </a:ext>
-            </a:extLst>
-          </p:cNvPr>
-          <p:cNvSpPr>
-            <a:spLocks xmlns:a="http://schemas.openxmlformats.org/drawingml/2006/main" noGrp="1"/>
-          </p:cNvSpPr>
-          <p:nvPr/>
-        </p:nvSpPr>
-        <p:spPr>
-          <a:xfrm xmlns:a="http://schemas.openxmlformats.org/drawingml/2006/main">
-            <a:off x="4657725" y="2228850"/>
-            <a:ext cx="2762250" cy="361950"/>
-          </a:xfrm>
-          <a:prstGeom xmlns:a="http://schemas.openxmlformats.org/drawingml/2006/main" prst="rect">
-            <a:avLst/>
-          </a:prstGeom>
-        </p:spPr>
-        <p:txBody>
-          <a:bodyPr xmlns:a="http://schemas.openxmlformats.org/drawingml/2006/main" lIns="0" tIns="0" rIns="0" bIns="0" anchor="t"/>
-          <a:lstStyle xmlns:a="http://schemas.openxmlformats.org/drawingml/2006/main"/>
-          <a:p xmlns:a="http://schemas.openxmlformats.org/drawingml/2006/main">
-            <a:pPr algn="l">
-              <a:buNone/>
-              <a:defRPr sz="1950" b="1">
+              <a:t>Frozen-каталог возможных deletion-regeneration графов и полный evidence contract.</a:t>
+            </a:r>
+          </a:p>
+        </p:txBody>
+      </p:sp>
+      <p:sp>
+        <p:nvSpPr>
+          <p:cNvPr id="9" name="text-489-238">
+            <a:extLst xmlns:a="http://schemas.openxmlformats.org/drawingml/2006/main">
+              <a:ext uri="{FF2B5EF4-FFF2-40B4-BE49-F238E27FC236}">
+                <a16:creationId xmlns:a16="http://schemas.microsoft.com/office/drawing/2014/main" id="{7FDB58C3-FD43-465F-992C-7E9D0599E277}"/>
+              </a:ext>
+            </a:extLst>
+          </p:cNvPr>
+          <p:cNvSpPr>
+            <a:spLocks xmlns:a="http://schemas.openxmlformats.org/drawingml/2006/main" noGrp="1"/>
+          </p:cNvSpPr>
+          <p:nvPr/>
+        </p:nvSpPr>
+        <p:spPr>
+          <a:xfrm xmlns:a="http://schemas.openxmlformats.org/drawingml/2006/main">
+            <a:off x="4657725" y="2266950"/>
+            <a:ext cx="476250" cy="552450"/>
+          </a:xfrm>
+          <a:prstGeom xmlns:a="http://schemas.openxmlformats.org/drawingml/2006/main" prst="rect">
+            <a:avLst/>
+          </a:prstGeom>
+        </p:spPr>
+        <p:txBody>
+          <a:bodyPr xmlns:a="http://schemas.openxmlformats.org/drawingml/2006/main" lIns="0" tIns="0" rIns="0" bIns="0" anchor="t"/>
+          <a:lstStyle xmlns:a="http://schemas.openxmlformats.org/drawingml/2006/main"/>
+          <a:p xmlns:a="http://schemas.openxmlformats.org/drawingml/2006/main">
+            <a:pPr algn="l">
+              <a:buNone/>
+              <a:defRPr sz="3300" b="1">
                 <a:solidFill>
                   <a:srgbClr val="FF6B35"/>
                 </a:solidFill>
               </a:defRPr>
             </a:pPr>
             <a:r>
-              <a:t>Узкий вклад</a:t>
-            </a:r>
-          </a:p>
-        </p:txBody>
-      </p:sp>
-      <p:sp>
-        <p:nvSpPr>
-          <p:cNvPr id="9" name="text-489-306">
-            <a:extLst xmlns:a="http://schemas.openxmlformats.org/drawingml/2006/main">
-              <a:ext uri="{FF2B5EF4-FFF2-40B4-BE49-F238E27FC236}">
-                <a16:creationId xmlns:a16="http://schemas.microsoft.com/office/drawing/2014/main" id="{60FE33EA-F371-4DE4-963E-62261E17AB0C}"/>
-              </a:ext>
-            </a:extLst>
-          </p:cNvPr>
-          <p:cNvSpPr>
-            <a:spLocks xmlns:a="http://schemas.openxmlformats.org/drawingml/2006/main" noGrp="1"/>
-          </p:cNvSpPr>
-          <p:nvPr/>
-        </p:nvSpPr>
-        <p:spPr>
-          <a:xfrm xmlns:a="http://schemas.openxmlformats.org/drawingml/2006/main">
-            <a:off x="4657725" y="2914650"/>
-            <a:ext cx="2714625" cy="2305050"/>
-          </a:xfrm>
-          <a:prstGeom xmlns:a="http://schemas.openxmlformats.org/drawingml/2006/main" prst="rect">
-            <a:avLst/>
-          </a:prstGeom>
-        </p:spPr>
-        <p:txBody>
-          <a:bodyPr xmlns:a="http://schemas.openxmlformats.org/drawingml/2006/main" lIns="0" tIns="0" rIns="0" bIns="0" anchor="t"/>
-          <a:lstStyle xmlns:a="http://schemas.openxmlformats.org/drawingml/2006/main"/>
-          <a:p xmlns:a="http://schemas.openxmlformats.org/drawingml/2006/main">
-            <a:pPr algn="l">
-              <a:buNone/>
-              <a:defRPr sz="1575" b="1">
+              <a:t>2</a:t>
+            </a:r>
+          </a:p>
+        </p:txBody>
+      </p:sp>
+      <p:sp>
+        <p:nvSpPr>
+          <p:cNvPr id="10" name="text-489-310">
+            <a:extLst xmlns:a="http://schemas.openxmlformats.org/drawingml/2006/main">
+              <a:ext uri="{FF2B5EF4-FFF2-40B4-BE49-F238E27FC236}">
+                <a16:creationId xmlns:a16="http://schemas.microsoft.com/office/drawing/2014/main" id="{854C5A1F-2426-49C8-8A9E-E7771FD66E49}"/>
+              </a:ext>
+            </a:extLst>
+          </p:cNvPr>
+          <p:cNvSpPr>
+            <a:spLocks xmlns:a="http://schemas.openxmlformats.org/drawingml/2006/main" noGrp="1"/>
+          </p:cNvSpPr>
+          <p:nvPr/>
+        </p:nvSpPr>
+        <p:spPr>
+          <a:xfrm xmlns:a="http://schemas.openxmlformats.org/drawingml/2006/main">
+            <a:off x="4657725" y="2952750"/>
+            <a:ext cx="2667000" cy="457200"/>
+          </a:xfrm>
+          <a:prstGeom xmlns:a="http://schemas.openxmlformats.org/drawingml/2006/main" prst="rect">
+            <a:avLst/>
+          </a:prstGeom>
+        </p:spPr>
+        <p:txBody>
+          <a:bodyPr xmlns:a="http://schemas.openxmlformats.org/drawingml/2006/main" lIns="0" tIns="0" rIns="0" bIns="0" anchor="t"/>
+          <a:lstStyle xmlns:a="http://schemas.openxmlformats.org/drawingml/2006/main"/>
+          <a:p xmlns:a="http://schemas.openxmlformats.org/drawingml/2006/main">
+            <a:pPr algn="l">
+              <a:buNone/>
+              <a:defRPr sz="2325" b="1">
                 <a:solidFill>
                   <a:srgbClr val="0B0D10"/>
                 </a:solidFill>
               </a:defRPr>
             </a:pPr>
             <a:r>
-              <a:t>Единый subject-scoped fail-closed residual-path contract: physical artifacts + model influence + mandatory channels + replay + counterexample + minimum CDC.</a:t>
-            </a:r>
-          </a:p>
-        </p:txBody>
-      </p:sp>
-      <p:sp>
-        <p:nvSpPr>
-          <p:cNvPr id="10" name="text-909-234">
-            <a:extLst xmlns:a="http://schemas.openxmlformats.org/drawingml/2006/main">
-              <a:ext uri="{FF2B5EF4-FFF2-40B4-BE49-F238E27FC236}">
-                <a16:creationId xmlns:a16="http://schemas.microsoft.com/office/drawing/2014/main" id="{6A719E17-299D-4604-A94A-7D1B99FC1CF6}"/>
-              </a:ext>
-            </a:extLst>
-          </p:cNvPr>
-          <p:cNvSpPr>
-            <a:spLocks xmlns:a="http://schemas.openxmlformats.org/drawingml/2006/main" noGrp="1"/>
-          </p:cNvSpPr>
-          <p:nvPr/>
-        </p:nvSpPr>
-        <p:spPr>
-          <a:xfrm xmlns:a="http://schemas.openxmlformats.org/drawingml/2006/main">
-            <a:off x="8658225" y="2228850"/>
-            <a:ext cx="2762250" cy="361950"/>
-          </a:xfrm>
-          <a:prstGeom xmlns:a="http://schemas.openxmlformats.org/drawingml/2006/main" prst="rect">
-            <a:avLst/>
-          </a:prstGeom>
-        </p:spPr>
-        <p:txBody>
-          <a:bodyPr xmlns:a="http://schemas.openxmlformats.org/drawingml/2006/main" lIns="0" tIns="0" rIns="0" bIns="0" anchor="t"/>
-          <a:lstStyle xmlns:a="http://schemas.openxmlformats.org/drawingml/2006/main"/>
-          <a:p xmlns:a="http://schemas.openxmlformats.org/drawingml/2006/main">
-            <a:pPr algn="l">
-              <a:buNone/>
-              <a:defRPr sz="1950" b="1">
+              <a:t>Active probe</a:t>
+            </a:r>
+          </a:p>
+        </p:txBody>
+      </p:sp>
+      <p:sp>
+        <p:nvSpPr>
+          <p:cNvPr id="11" name="text-489-378">
+            <a:extLst xmlns:a="http://schemas.openxmlformats.org/drawingml/2006/main">
+              <a:ext uri="{FF2B5EF4-FFF2-40B4-BE49-F238E27FC236}">
+                <a16:creationId xmlns:a16="http://schemas.microsoft.com/office/drawing/2014/main" id="{307855CD-6F77-4C88-A190-DEE5456448DC}"/>
+              </a:ext>
+            </a:extLst>
+          </p:cNvPr>
+          <p:cNvSpPr>
+            <a:spLocks xmlns:a="http://schemas.openxmlformats.org/drawingml/2006/main" noGrp="1"/>
+          </p:cNvSpPr>
+          <p:nvPr/>
+        </p:nvSpPr>
+        <p:spPr>
+          <a:xfrm xmlns:a="http://schemas.openxmlformats.org/drawingml/2006/main">
+            <a:off x="4657725" y="3600450"/>
+            <a:ext cx="2667000" cy="1238250"/>
+          </a:xfrm>
+          <a:prstGeom xmlns:a="http://schemas.openxmlformats.org/drawingml/2006/main" prst="rect">
+            <a:avLst/>
+          </a:prstGeom>
+        </p:spPr>
+        <p:txBody>
+          <a:bodyPr xmlns:a="http://schemas.openxmlformats.org/drawingml/2006/main" lIns="0" tIns="0" rIns="0" bIns="0" anchor="t"/>
+          <a:lstStyle xmlns:a="http://schemas.openxmlformats.org/drawingml/2006/main"/>
+          <a:p xmlns:a="http://schemas.openxmlformats.org/drawingml/2006/main">
+            <a:pPr algn="l">
+              <a:buNone/>
+              <a:defRPr sz="1575" b="0">
                 <a:solidFill>
                   <a:srgbClr val="0B0D10"/>
                 </a:solidFill>
               </a:defRPr>
             </a:pPr>
             <a:r>
-              <a:t>Не заявляется</a:t>
-            </a:r>
-          </a:p>
-        </p:txBody>
-      </p:sp>
-      <p:sp>
-        <p:nvSpPr>
-          <p:cNvPr id="11" name="text-909-306">
-            <a:extLst xmlns:a="http://schemas.openxmlformats.org/drawingml/2006/main">
-              <a:ext uri="{FF2B5EF4-FFF2-40B4-BE49-F238E27FC236}">
-                <a16:creationId xmlns:a16="http://schemas.microsoft.com/office/drawing/2014/main" id="{2B397DEB-3D92-40C6-BD80-7A6966FF4101}"/>
-              </a:ext>
-            </a:extLst>
-          </p:cNvPr>
-          <p:cNvSpPr>
-            <a:spLocks xmlns:a="http://schemas.openxmlformats.org/drawingml/2006/main" noGrp="1"/>
-          </p:cNvSpPr>
-          <p:nvPr/>
-        </p:nvSpPr>
-        <p:spPr>
-          <a:xfrm xmlns:a="http://schemas.openxmlformats.org/drawingml/2006/main">
-            <a:off x="8658225" y="2914650"/>
-            <a:ext cx="2714625" cy="2190750"/>
-          </a:xfrm>
-          <a:prstGeom xmlns:a="http://schemas.openxmlformats.org/drawingml/2006/main" prst="rect">
-            <a:avLst/>
-          </a:prstGeom>
-        </p:spPr>
-        <p:txBody>
-          <a:bodyPr xmlns:a="http://schemas.openxmlformats.org/drawingml/2006/main" lIns="0" tIns="0" rIns="0" bIns="0" anchor="t"/>
-          <a:lstStyle xmlns:a="http://schemas.openxmlformats.org/drawingml/2006/main"/>
-          <a:p xmlns:a="http://schemas.openxmlformats.org/drawingml/2006/main">
-            <a:pPr algn="l">
-              <a:buNone/>
-              <a:defRPr sz="1650" b="0">
+              <a:t>Minimax выбирает intervention, сильнее всего сужающий оставшиеся графы.</a:t>
+            </a:r>
+          </a:p>
+        </p:txBody>
+      </p:sp>
+      <p:sp>
+        <p:nvSpPr>
+          <p:cNvPr id="12" name="text-909-238">
+            <a:extLst xmlns:a="http://schemas.openxmlformats.org/drawingml/2006/main">
+              <a:ext uri="{FF2B5EF4-FFF2-40B4-BE49-F238E27FC236}">
+                <a16:creationId xmlns:a16="http://schemas.microsoft.com/office/drawing/2014/main" id="{BD7FBEF4-0818-4155-8DF9-9EE04181DDB6}"/>
+              </a:ext>
+            </a:extLst>
+          </p:cNvPr>
+          <p:cNvSpPr>
+            <a:spLocks xmlns:a="http://schemas.openxmlformats.org/drawingml/2006/main" noGrp="1"/>
+          </p:cNvSpPr>
+          <p:nvPr/>
+        </p:nvSpPr>
+        <p:spPr>
+          <a:xfrm xmlns:a="http://schemas.openxmlformats.org/drawingml/2006/main">
+            <a:off x="8658225" y="2266950"/>
+            <a:ext cx="476250" cy="552450"/>
+          </a:xfrm>
+          <a:prstGeom xmlns:a="http://schemas.openxmlformats.org/drawingml/2006/main" prst="rect">
+            <a:avLst/>
+          </a:prstGeom>
+        </p:spPr>
+        <p:txBody>
+          <a:bodyPr xmlns:a="http://schemas.openxmlformats.org/drawingml/2006/main" lIns="0" tIns="0" rIns="0" bIns="0" anchor="t"/>
+          <a:lstStyle xmlns:a="http://schemas.openxmlformats.org/drawingml/2006/main"/>
+          <a:p xmlns:a="http://schemas.openxmlformats.org/drawingml/2006/main">
+            <a:pPr algn="l">
+              <a:buNone/>
+              <a:defRPr sz="3300" b="1">
+                <a:solidFill>
+                  <a:srgbClr val="FF6B35"/>
+                </a:solidFill>
+              </a:defRPr>
+            </a:pPr>
+            <a:r>
+              <a:t>3</a:t>
+            </a:r>
+          </a:p>
+        </p:txBody>
+      </p:sp>
+      <p:sp>
+        <p:nvSpPr>
+          <p:cNvPr id="13" name="text-909-310">
+            <a:extLst xmlns:a="http://schemas.openxmlformats.org/drawingml/2006/main">
+              <a:ext uri="{FF2B5EF4-FFF2-40B4-BE49-F238E27FC236}">
+                <a16:creationId xmlns:a16="http://schemas.microsoft.com/office/drawing/2014/main" id="{06E704E8-3D11-409E-825F-EAD96B166036}"/>
+              </a:ext>
+            </a:extLst>
+          </p:cNvPr>
+          <p:cNvSpPr>
+            <a:spLocks xmlns:a="http://schemas.openxmlformats.org/drawingml/2006/main" noGrp="1"/>
+          </p:cNvSpPr>
+          <p:nvPr/>
+        </p:nvSpPr>
+        <p:spPr>
+          <a:xfrm xmlns:a="http://schemas.openxmlformats.org/drawingml/2006/main">
+            <a:off x="8658225" y="2952750"/>
+            <a:ext cx="2667000" cy="457200"/>
+          </a:xfrm>
+          <a:prstGeom xmlns:a="http://schemas.openxmlformats.org/drawingml/2006/main" prst="rect">
+            <a:avLst/>
+          </a:prstGeom>
+        </p:spPr>
+        <p:txBody>
+          <a:bodyPr xmlns:a="http://schemas.openxmlformats.org/drawingml/2006/main" lIns="0" tIns="0" rIns="0" bIns="0" anchor="t"/>
+          <a:lstStyle xmlns:a="http://schemas.openxmlformats.org/drawingml/2006/main"/>
+          <a:p xmlns:a="http://schemas.openxmlformats.org/drawingml/2006/main">
+            <a:pPr algn="l">
+              <a:buNone/>
+              <a:defRPr sz="2325" b="1">
                 <a:solidFill>
                   <a:srgbClr val="0B0D10"/>
                 </a:solidFill>
               </a:defRPr>
             </a:pPr>
             <a:r>
-              <a:t>«Первый proof of unlearning»
-Глобальное физическое стирание
-Внедрение FaceID/eGov
-Юридическая compliance guarantee</a:t>
-            </a:r>
-          </a:p>
-        </p:txBody>
-      </p:sp>
-      <p:sp>
-        <p:nvSpPr>
-          <p:cNvPr id="12" name="text-42-626">
-            <a:extLst xmlns:a="http://schemas.openxmlformats.org/drawingml/2006/main">
-              <a:ext uri="{FF2B5EF4-FFF2-40B4-BE49-F238E27FC236}">
-                <a16:creationId xmlns:a16="http://schemas.microsoft.com/office/drawing/2014/main" id="{08CD57D6-2C17-458D-B599-633D0A285537}"/>
-              </a:ext>
-            </a:extLst>
-          </p:cNvPr>
-          <p:cNvSpPr>
-            <a:spLocks xmlns:a="http://schemas.openxmlformats.org/drawingml/2006/main" noGrp="1"/>
-          </p:cNvSpPr>
-          <p:nvPr/>
-        </p:nvSpPr>
-        <p:spPr>
-          <a:xfrm xmlns:a="http://schemas.openxmlformats.org/drawingml/2006/main">
-            <a:off x="400050" y="5962650"/>
-            <a:ext cx="10858500" cy="361950"/>
-          </a:xfrm>
-          <a:prstGeom xmlns:a="http://schemas.openxmlformats.org/drawingml/2006/main" prst="rect">
-            <a:avLst/>
-          </a:prstGeom>
-        </p:spPr>
-        <p:txBody>
-          <a:bodyPr xmlns:a="http://schemas.openxmlformats.org/drawingml/2006/main" lIns="0" tIns="0" rIns="0" bIns="0" anchor="t"/>
-          <a:lstStyle xmlns:a="http://schemas.openxmlformats.org/drawingml/2006/main"/>
-          <a:p xmlns:a="http://schemas.openxmlformats.org/drawingml/2006/main">
-            <a:pPr algn="l">
-              <a:buNone/>
-              <a:defRPr sz="1350" b="0">
+              <a:t>Fail-closed repair</a:t>
+            </a:r>
+          </a:p>
+        </p:txBody>
+      </p:sp>
+      <p:sp>
+        <p:nvSpPr>
+          <p:cNvPr id="14" name="text-909-378">
+            <a:extLst xmlns:a="http://schemas.openxmlformats.org/drawingml/2006/main">
+              <a:ext uri="{FF2B5EF4-FFF2-40B4-BE49-F238E27FC236}">
+                <a16:creationId xmlns:a16="http://schemas.microsoft.com/office/drawing/2014/main" id="{2A23EF1D-1816-41A0-A1C7-EE7E7D884236}"/>
+              </a:ext>
+            </a:extLst>
+          </p:cNvPr>
+          <p:cNvSpPr>
+            <a:spLocks xmlns:a="http://schemas.openxmlformats.org/drawingml/2006/main" noGrp="1"/>
+          </p:cNvSpPr>
+          <p:nvPr/>
+        </p:nvSpPr>
+        <p:spPr>
+          <a:xfrm xmlns:a="http://schemas.openxmlformats.org/drawingml/2006/main">
+            <a:off x="8658225" y="3600450"/>
+            <a:ext cx="2667000" cy="1238250"/>
+          </a:xfrm>
+          <a:prstGeom xmlns:a="http://schemas.openxmlformats.org/drawingml/2006/main" prst="rect">
+            <a:avLst/>
+          </a:prstGeom>
+        </p:spPr>
+        <p:txBody>
+          <a:bodyPr xmlns:a="http://schemas.openxmlformats.org/drawingml/2006/main" lIns="0" tIns="0" rIns="0" bIns="0" anchor="t"/>
+          <a:lstStyle xmlns:a="http://schemas.openxmlformats.org/drawingml/2006/main"/>
+          <a:p xmlns:a="http://schemas.openxmlformats.org/drawingml/2006/main">
+            <a:pPr algn="l">
+              <a:buNone/>
+              <a:defRPr sz="1575" b="0">
+                <a:solidFill>
+                  <a:srgbClr val="0B0D10"/>
+                </a:solidFill>
+              </a:defRPr>
+            </a:pPr>
+            <a:r>
+              <a:t>Exact graph / path class, либо OUT / UNVERIFIED; затем exact control и replay.</a:t>
+            </a:r>
+          </a:p>
+        </p:txBody>
+      </p:sp>
+      <p:sp>
+        <p:nvSpPr>
+          <p:cNvPr id="15" name="text-42-624">
+            <a:extLst xmlns:a="http://schemas.openxmlformats.org/drawingml/2006/main">
+              <a:ext uri="{FF2B5EF4-FFF2-40B4-BE49-F238E27FC236}">
+                <a16:creationId xmlns:a16="http://schemas.microsoft.com/office/drawing/2014/main" id="{8FE06295-BB67-4999-B18D-927AED086CAF}"/>
+              </a:ext>
+            </a:extLst>
+          </p:cNvPr>
+          <p:cNvSpPr>
+            <a:spLocks xmlns:a="http://schemas.openxmlformats.org/drawingml/2006/main" noGrp="1"/>
+          </p:cNvSpPr>
+          <p:nvPr/>
+        </p:nvSpPr>
+        <p:spPr>
+          <a:xfrm xmlns:a="http://schemas.openxmlformats.org/drawingml/2006/main">
+            <a:off x="400050" y="5943600"/>
+            <a:ext cx="10477500" cy="342900"/>
+          </a:xfrm>
+          <a:prstGeom xmlns:a="http://schemas.openxmlformats.org/drawingml/2006/main" prst="rect">
+            <a:avLst/>
+          </a:prstGeom>
+        </p:spPr>
+        <p:txBody>
+          <a:bodyPr xmlns:a="http://schemas.openxmlformats.org/drawingml/2006/main" lIns="0" tIns="0" rIns="0" bIns="0" anchor="t"/>
+          <a:lstStyle xmlns:a="http://schemas.openxmlformats.org/drawingml/2006/main"/>
+          <a:p xmlns:a="http://schemas.openxmlformats.org/drawingml/2006/main">
+            <a:pPr algn="l">
+              <a:buNone/>
+              <a:defRPr sz="1500" b="0">
                 <a:solidFill>
                   <a:srgbClr val="555B63"/>
                 </a:solidFill>
               </a:defRPr>
             </a:pPr>
             <a:r>
-              <a:t>Добавлен близкий патент US12456052B2: staged unlearning DAG + cryptographic verification + deployment checks.</a:t>
-            </a:r>
-          </a:p>
-        </p:txBody>
-      </p:sp>
-      <p:sp>
-        <p:nvSpPr>
-          <p:cNvPr id="13" name="slide-number-9">
-            <a:extLst xmlns:a="http://schemas.openxmlformats.org/drawingml/2006/main">
-              <a:ext uri="{FF2B5EF4-FFF2-40B4-BE49-F238E27FC236}">
-                <a16:creationId xmlns:a16="http://schemas.microsoft.com/office/drawing/2014/main" id="{B8861551-D27A-4601-8815-837B0ABF4B64}"/>
+              <a:t>Finite catalogue · synthetic subjects · без claim об arbitrary hidden infrastructure.</a:t>
+            </a:r>
+          </a:p>
+        </p:txBody>
+      </p:sp>
+      <p:sp>
+        <p:nvSpPr>
+          <p:cNvPr id="16" name="slide-number-4">
+            <a:extLst xmlns:a="http://schemas.openxmlformats.org/drawingml/2006/main">
+              <a:ext uri="{FF2B5EF4-FFF2-40B4-BE49-F238E27FC236}">
+                <a16:creationId xmlns:a16="http://schemas.microsoft.com/office/drawing/2014/main" id="{F5CF1F1B-88CD-4B85-9F7F-372DF89823CE}"/>
               </a:ext>
             </a:extLst>
           </p:cNvPr>
@@ -8118,7 +9442,7 @@
     </p:spTree>
     <p:extLst>
       <p:ext uri="{BB962C8B-B14F-4D97-AF65-F5344CB8AC3E}">
-        <p14:creationId xmlns:p14="http://schemas.microsoft.com/office/powerpoint/2010/main" val="2037705955"/>
+        <p14:creationId xmlns:p14="http://schemas.microsoft.com/office/powerpoint/2010/main" val="787107868"/>
       </p:ext>
     </p:extLst>
   </p:cSld>

</xml_diff>

<commit_message>
docs: integrate GhostGraph-T into competition materials
</commit_message>
<xml_diff>
--- a/competition/EraSeMap_RKNP_ISEF_RU.pptx
+++ b/competition/EraSeMap_RKNP_ISEF_RU.pptx
@@ -2,25 +2,25 @@
 <file path=ppt/presentation.xml><?xml version="1.0" encoding="utf-8"?>
 <p:presentation xmlns:p="http://schemas.openxmlformats.org/presentationml/2006/main">
   <p:sldMasterIdLst>
-    <p:sldMasterId xmlns:r="http://schemas.openxmlformats.org/officeDocument/2006/relationships" id="2147483648" r:id="Re4baf87b8571477d"/>
+    <p:sldMasterId xmlns:r="http://schemas.openxmlformats.org/officeDocument/2006/relationships" id="2147483648" r:id="Rd65aafc08eb54ecd"/>
   </p:sldMasterIdLst>
   <p:notesMasterIdLst>
-    <p:notesMasterId xmlns:r="http://schemas.openxmlformats.org/officeDocument/2006/relationships" r:id="R0ca15390281a4c1e"/>
+    <p:notesMasterId xmlns:r="http://schemas.openxmlformats.org/officeDocument/2006/relationships" r:id="Rbddc8c9aefc341f4"/>
   </p:notesMasterIdLst>
   <p:sldIdLst>
-    <p:sldId xmlns:r="http://schemas.openxmlformats.org/officeDocument/2006/relationships" id="256" r:id="R85d989a87b994158"/>
-    <p:sldId xmlns:r="http://schemas.openxmlformats.org/officeDocument/2006/relationships" id="257" r:id="R37e86a87c7114b5c"/>
-    <p:sldId xmlns:r="http://schemas.openxmlformats.org/officeDocument/2006/relationships" id="258" r:id="Rc63d747e38524c43"/>
-    <p:sldId xmlns:r="http://schemas.openxmlformats.org/officeDocument/2006/relationships" id="259" r:id="R904b86407f1942af"/>
-    <p:sldId xmlns:r="http://schemas.openxmlformats.org/officeDocument/2006/relationships" id="260" r:id="R3cfe274f290c40af"/>
-    <p:sldId xmlns:r="http://schemas.openxmlformats.org/officeDocument/2006/relationships" id="261" r:id="R445a4b43df8543b5"/>
-    <p:sldId xmlns:r="http://schemas.openxmlformats.org/officeDocument/2006/relationships" id="262" r:id="R13656b7bcc4343bb"/>
-    <p:sldId xmlns:r="http://schemas.openxmlformats.org/officeDocument/2006/relationships" id="263" r:id="R30e90c30a56242d6"/>
-    <p:sldId xmlns:r="http://schemas.openxmlformats.org/officeDocument/2006/relationships" id="264" r:id="Rc7f396e9ebc14929"/>
-    <p:sldId xmlns:r="http://schemas.openxmlformats.org/officeDocument/2006/relationships" id="265" r:id="Rdc2c0cfa1ada492f"/>
-    <p:sldId xmlns:r="http://schemas.openxmlformats.org/officeDocument/2006/relationships" id="266" r:id="R08503a3d744749cc"/>
-    <p:sldId xmlns:r="http://schemas.openxmlformats.org/officeDocument/2006/relationships" id="267" r:id="Ra291ee1d47a14354"/>
-    <p:sldId xmlns:r="http://schemas.openxmlformats.org/officeDocument/2006/relationships" id="268" r:id="R406713be4e504493"/>
+    <p:sldId xmlns:r="http://schemas.openxmlformats.org/officeDocument/2006/relationships" id="256" r:id="R6db87433dce84f2a"/>
+    <p:sldId xmlns:r="http://schemas.openxmlformats.org/officeDocument/2006/relationships" id="257" r:id="Rb20862da28a44838"/>
+    <p:sldId xmlns:r="http://schemas.openxmlformats.org/officeDocument/2006/relationships" id="258" r:id="R9f6034a3a18a4d20"/>
+    <p:sldId xmlns:r="http://schemas.openxmlformats.org/officeDocument/2006/relationships" id="259" r:id="R26456f2a549c4748"/>
+    <p:sldId xmlns:r="http://schemas.openxmlformats.org/officeDocument/2006/relationships" id="260" r:id="R73bf6ac8441946ad"/>
+    <p:sldId xmlns:r="http://schemas.openxmlformats.org/officeDocument/2006/relationships" id="261" r:id="R53351380afa744ac"/>
+    <p:sldId xmlns:r="http://schemas.openxmlformats.org/officeDocument/2006/relationships" id="262" r:id="R52787efed6e24a93"/>
+    <p:sldId xmlns:r="http://schemas.openxmlformats.org/officeDocument/2006/relationships" id="263" r:id="Rbcde396cd01447a3"/>
+    <p:sldId xmlns:r="http://schemas.openxmlformats.org/officeDocument/2006/relationships" id="264" r:id="Rc7d19d9c675f44b1"/>
+    <p:sldId xmlns:r="http://schemas.openxmlformats.org/officeDocument/2006/relationships" id="265" r:id="Re789a5c2476a43ea"/>
+    <p:sldId xmlns:r="http://schemas.openxmlformats.org/officeDocument/2006/relationships" id="266" r:id="R7d38e0bd71c84364"/>
+    <p:sldId xmlns:r="http://schemas.openxmlformats.org/officeDocument/2006/relationships" id="267" r:id="R9ab2aa2cc5164490"/>
+    <p:sldId xmlns:r="http://schemas.openxmlformats.org/officeDocument/2006/relationships" id="268" r:id="Re6f873d7a6f245af"/>
   </p:sldIdLst>
   <p:sldSz cx="12192000" cy="6858000"/>
   <p:notesSz cx="6858000" cy="9144000"/>
@@ -524,7 +524,7 @@
           <a:lstStyle xmlns:a="http://schemas.openxmlformats.org/drawingml/2006/main"/>
           <a:p xmlns:a="http://schemas.openxmlformats.org/drawingml/2006/main">
             <a:r>
-              <a:t>Реальны процессы PostgreSQL, Redis и Qdrant. Данные synthetic; это не production latency FaceID/eGov.</a:t>
+              <a:t>Frozen GhostGraph-T v1: 300/300 action-or-OOD, 50/50 family-held-out OOD, 0 false-confident, 1.28 mean probes versus 8.0 exhaustive. Global, one-step minimax и greedy tied; не заявлять превосходство между ними. Benchmark project-authored; external validation NOT_COLLECTED.</a:t>
             </a:r>
           </a:p>
         </p:txBody>
@@ -1362,7 +1362,7 @@
   </p:cSld>
   <p:clrMap bg1="lt1" tx1="dk1" bg2="lt2" tx2="dk2" accent1="accent1" accent2="accent2" accent3="accent3" accent4="accent4" accent5="accent5" accent6="accent6" hlink="hlink" folHlink="folHlink"/>
   <p:sldLayoutIdLst>
-    <p:sldLayoutId xmlns:r="http://schemas.openxmlformats.org/officeDocument/2006/relationships" id="2147483649" r:id="R44154ae30a114e4c"/>
+    <p:sldLayoutId xmlns:r="http://schemas.openxmlformats.org/officeDocument/2006/relationships" id="2147483649" r:id="R436a411d5a3547e8"/>
   </p:sldLayoutIdLst>
   <p:txStyles>
     <p:titleStyle>
@@ -2190,10 +2190,10 @@
             <c:strLit>
               <c:ptCount val="2"/>
               <c:pt idx="0">
-                <c:v>Active minimax</c:v>
+                <c:v>Global action</c:v>
               </c:pt>
               <c:pt idx="1">
-                <c:v>Frozen random</c:v>
+                <c:v>Exhaustive</c:v>
               </c:pt>
             </c:strLit>
           </c:cat>
@@ -2202,10 +2202,10 @@
               <c:formatCode>General</c:formatCode>
               <c:ptCount val="2"/>
               <c:pt idx="0">
-                <c:v>7</c:v>
+                <c:v>1.28</c:v>
               </c:pt>
               <c:pt idx="1">
-                <c:v>13</c:v>
+                <c:v>8</c:v>
               </c:pt>
             </c:numLit>
           </c:val>
@@ -2759,7 +2759,7 @@
               </a:defRPr>
             </a:pPr>
             <a:r>
-              <a:t>09  GhostGraph result</a:t>
+              <a:t>09  GhostGraph-T result</a:t>
             </a:r>
           </a:p>
         </p:txBody>
@@ -2800,7 +2800,7 @@
               </a:defRPr>
             </a:pPr>
             <a:r>
-              <a:t>Активный запрос находит путь без ложной уверенности</a:t>
+              <a:t>Достаточное действие — даже когда точный граф неразличим</a:t>
             </a:r>
           </a:p>
         </p:txBody>
@@ -2868,7 +2868,7 @@
               </a:defRPr>
             </a:pPr>
             <a:r>
-              <a:t>49</a:t>
+              <a:t>300 / 300</a:t>
             </a:r>
           </a:p>
         </p:txBody>
@@ -2909,7 +2909,7 @@
               </a:defRPr>
             </a:pPr>
             <a:r>
-              <a:t>probes у nonadaptive exhaustive; active minimax — 7</a:t>
+              <a:t>correct action или OOD · 0 false confident</a:t>
             </a:r>
           </a:p>
         </p:txBody>
@@ -2950,7 +2950,7 @@
               </a:defRPr>
             </a:pPr>
             <a:r>
-              <a:t>5 / 5</a:t>
+              <a:t>50 / 50</a:t>
             </a:r>
           </a:p>
         </p:txBody>
@@ -2991,7 +2991,7 @@
               </a:defRPr>
             </a:pPr>
             <a:r>
-              <a:t>live cases: Redis · Keycloak · MLflow · Qdrant</a:t>
+              <a:t>family-held-out retry-replay распознан как OOD</a:t>
             </a:r>
           </a:p>
         </p:txBody>
@@ -3032,7 +3032,7 @@
               </a:defRPr>
             </a:pPr>
             <a:r>
-              <a:t>0 false confident · 0 oracle mismatch · external v2: NOT_COLLECTED</a:t>
+              <a:t>1.28 probes vs 8.0 exhaustive · policies tie · external: NOT_COLLECTED</a:t>
             </a:r>
           </a:p>
         </p:txBody>
@@ -3090,7 +3090,7 @@
         </p:xfrm>
         <a:graphic xmlns:a="http://schemas.openxmlformats.org/drawingml/2006/main">
           <a:graphicData uri="http://schemas.openxmlformats.org/drawingml/2006/chart">
-            <c:chart xmlns:r="http://schemas.openxmlformats.org/officeDocument/2006/relationships" xmlns:c="http://schemas.openxmlformats.org/drawingml/2006/chart" r:id="Rf233c2b77e104fc9"/>
+            <c:chart xmlns:r="http://schemas.openxmlformats.org/officeDocument/2006/relationships" xmlns:c="http://schemas.openxmlformats.org/drawingml/2006/chart" r:id="Rdabf555e6d4247ba"/>
           </a:graphicData>
         </a:graphic>
       </p:graphicFrame>
@@ -7384,7 +7384,7 @@
         </p:xfrm>
         <a:graphic xmlns:a="http://schemas.openxmlformats.org/drawingml/2006/main">
           <a:graphicData uri="http://schemas.openxmlformats.org/drawingml/2006/chart">
-            <c:chart xmlns:r="http://schemas.openxmlformats.org/officeDocument/2006/relationships" xmlns:c="http://schemas.openxmlformats.org/drawingml/2006/chart" r:id="R369af27eb41b4698"/>
+            <c:chart xmlns:r="http://schemas.openxmlformats.org/officeDocument/2006/relationships" xmlns:c="http://schemas.openxmlformats.org/drawingml/2006/chart" r:id="Refc5340788304a13"/>
           </a:graphicData>
         </a:graphic>
       </p:graphicFrame>
@@ -8345,7 +8345,7 @@
         </p:xfrm>
         <a:graphic xmlns:a="http://schemas.openxmlformats.org/drawingml/2006/main">
           <a:graphicData uri="http://schemas.openxmlformats.org/drawingml/2006/chart">
-            <c:chart xmlns:r="http://schemas.openxmlformats.org/officeDocument/2006/relationships" xmlns:c="http://schemas.openxmlformats.org/drawingml/2006/chart" r:id="Rbdf0e97d33d14435"/>
+            <c:chart xmlns:r="http://schemas.openxmlformats.org/officeDocument/2006/relationships" xmlns:c="http://schemas.openxmlformats.org/drawingml/2006/chart" r:id="Rd9218f53908b4c80"/>
           </a:graphicData>
         </a:graphic>
       </p:graphicFrame>
@@ -8783,7 +8783,7 @@
           <p:nvPr/>
         </p:nvPicPr>
         <p:blipFill>
-          <a:blip xmlns:r="http://schemas.openxmlformats.org/officeDocument/2006/relationships" xmlns:a="http://schemas.openxmlformats.org/drawingml/2006/main" r:embed="R295d5bafa9af435c"/>
+          <a:blip xmlns:r="http://schemas.openxmlformats.org/officeDocument/2006/relationships" xmlns:a="http://schemas.openxmlformats.org/drawingml/2006/main" r:embed="R3ba847c6e3ef42a4"/>
           <a:stretch xmlns:a="http://schemas.openxmlformats.org/drawingml/2006/main"/>
         </p:blipFill>
         <p:spPr>

</xml_diff>

<commit_message>
feat: unify EraSeMap presentation and comparisons
</commit_message>
<xml_diff>
--- a/competition/EraSeMap_RKNP_ISEF_RU.pptx
+++ b/competition/EraSeMap_RKNP_ISEF_RU.pptx
@@ -2,25 +2,25 @@
 <file path=ppt/presentation.xml><?xml version="1.0" encoding="utf-8"?>
 <p:presentation xmlns:p="http://schemas.openxmlformats.org/presentationml/2006/main">
   <p:sldMasterIdLst>
-    <p:sldMasterId xmlns:r="http://schemas.openxmlformats.org/officeDocument/2006/relationships" id="2147483648" r:id="Rd65aafc08eb54ecd"/>
+    <p:sldMasterId xmlns:r="http://schemas.openxmlformats.org/officeDocument/2006/relationships" id="2147483648" r:id="Ra5d98cea84434aeb"/>
   </p:sldMasterIdLst>
   <p:notesMasterIdLst>
-    <p:notesMasterId xmlns:r="http://schemas.openxmlformats.org/officeDocument/2006/relationships" r:id="Rbddc8c9aefc341f4"/>
+    <p:notesMasterId xmlns:r="http://schemas.openxmlformats.org/officeDocument/2006/relationships" r:id="R3796e6ec929446ee"/>
   </p:notesMasterIdLst>
   <p:sldIdLst>
-    <p:sldId xmlns:r="http://schemas.openxmlformats.org/officeDocument/2006/relationships" id="256" r:id="R6db87433dce84f2a"/>
-    <p:sldId xmlns:r="http://schemas.openxmlformats.org/officeDocument/2006/relationships" id="257" r:id="Rb20862da28a44838"/>
-    <p:sldId xmlns:r="http://schemas.openxmlformats.org/officeDocument/2006/relationships" id="258" r:id="R9f6034a3a18a4d20"/>
-    <p:sldId xmlns:r="http://schemas.openxmlformats.org/officeDocument/2006/relationships" id="259" r:id="R26456f2a549c4748"/>
-    <p:sldId xmlns:r="http://schemas.openxmlformats.org/officeDocument/2006/relationships" id="260" r:id="R73bf6ac8441946ad"/>
-    <p:sldId xmlns:r="http://schemas.openxmlformats.org/officeDocument/2006/relationships" id="261" r:id="R53351380afa744ac"/>
-    <p:sldId xmlns:r="http://schemas.openxmlformats.org/officeDocument/2006/relationships" id="262" r:id="R52787efed6e24a93"/>
-    <p:sldId xmlns:r="http://schemas.openxmlformats.org/officeDocument/2006/relationships" id="263" r:id="Rbcde396cd01447a3"/>
-    <p:sldId xmlns:r="http://schemas.openxmlformats.org/officeDocument/2006/relationships" id="264" r:id="Rc7d19d9c675f44b1"/>
-    <p:sldId xmlns:r="http://schemas.openxmlformats.org/officeDocument/2006/relationships" id="265" r:id="Re789a5c2476a43ea"/>
-    <p:sldId xmlns:r="http://schemas.openxmlformats.org/officeDocument/2006/relationships" id="266" r:id="R7d38e0bd71c84364"/>
-    <p:sldId xmlns:r="http://schemas.openxmlformats.org/officeDocument/2006/relationships" id="267" r:id="R9ab2aa2cc5164490"/>
-    <p:sldId xmlns:r="http://schemas.openxmlformats.org/officeDocument/2006/relationships" id="268" r:id="Re6f873d7a6f245af"/>
+    <p:sldId xmlns:r="http://schemas.openxmlformats.org/officeDocument/2006/relationships" id="256" r:id="R3601467929c94d1e"/>
+    <p:sldId xmlns:r="http://schemas.openxmlformats.org/officeDocument/2006/relationships" id="257" r:id="Rb36e626a29194ac4"/>
+    <p:sldId xmlns:r="http://schemas.openxmlformats.org/officeDocument/2006/relationships" id="258" r:id="R05a1330f8e874a10"/>
+    <p:sldId xmlns:r="http://schemas.openxmlformats.org/officeDocument/2006/relationships" id="259" r:id="R821ec87babfa4bf2"/>
+    <p:sldId xmlns:r="http://schemas.openxmlformats.org/officeDocument/2006/relationships" id="260" r:id="R51ac048698224d13"/>
+    <p:sldId xmlns:r="http://schemas.openxmlformats.org/officeDocument/2006/relationships" id="261" r:id="Ree3ae2ba0a154f00"/>
+    <p:sldId xmlns:r="http://schemas.openxmlformats.org/officeDocument/2006/relationships" id="262" r:id="R3a352070ff224fc4"/>
+    <p:sldId xmlns:r="http://schemas.openxmlformats.org/officeDocument/2006/relationships" id="263" r:id="R66f5c440caae4566"/>
+    <p:sldId xmlns:r="http://schemas.openxmlformats.org/officeDocument/2006/relationships" id="264" r:id="R71543541ec974d21"/>
+    <p:sldId xmlns:r="http://schemas.openxmlformats.org/officeDocument/2006/relationships" id="265" r:id="R65bb691f00814286"/>
+    <p:sldId xmlns:r="http://schemas.openxmlformats.org/officeDocument/2006/relationships" id="266" r:id="R48e37c715ab9407d"/>
+    <p:sldId xmlns:r="http://schemas.openxmlformats.org/officeDocument/2006/relationships" id="267" r:id="R79e87304aa29442a"/>
+    <p:sldId xmlns:r="http://schemas.openxmlformats.org/officeDocument/2006/relationships" id="268" r:id="R2eaf8f6c022a4a41"/>
   </p:sldIdLst>
   <p:sldSz cx="12192000" cy="6858000"/>
   <p:notesSz cx="6858000" cy="9144000"/>
@@ -1362,7 +1362,7 @@
   </p:cSld>
   <p:clrMap bg1="lt1" tx1="dk1" bg2="lt2" tx2="dk2" accent1="accent1" accent2="accent2" accent3="accent3" accent4="accent4" accent5="accent5" accent6="accent6" hlink="hlink" folHlink="folHlink"/>
   <p:sldLayoutIdLst>
-    <p:sldLayoutId xmlns:r="http://schemas.openxmlformats.org/officeDocument/2006/relationships" id="2147483649" r:id="R436a411d5a3547e8"/>
+    <p:sldLayoutId xmlns:r="http://schemas.openxmlformats.org/officeDocument/2006/relationships" id="2147483649" r:id="R8c6720164ff341f5"/>
   </p:sldLayoutIdLst>
   <p:txStyles>
     <p:titleStyle>
@@ -1912,10 +1912,10 @@
             <c:strLit>
               <c:ptCount val="2"/>
               <c:pt idx="0">
-                <c:v>PCUG</c:v>
+                <c:v>EraSeMap</c:v>
               </c:pt>
               <c:pt idx="1">
-                <c:v>Typed node</c:v>
+                <c:v>Typed-node audit</c:v>
               </c:pt>
             </c:strLit>
           </c:cat>
@@ -2051,10 +2051,10 @@
             <c:strLit>
               <c:ptCount val="2"/>
               <c:pt idx="0">
-                <c:v>Targeted CDC</c:v>
+                <c:v>EraSeMap</c:v>
               </c:pt>
               <c:pt idx="1">
-                <c:v>Rebuild all</c:v>
+                <c:v>Rebuild-all</c:v>
               </c:pt>
             </c:strLit>
           </c:cat>
@@ -2471,7 +2471,7 @@
               </a:defRPr>
             </a:pPr>
             <a:r>
-              <a:t>Proof-Carrying Unlearning Graph</a:t>
+              <a:t>Один алгоритм • пять этапов</a:t>
             </a:r>
           </a:p>
         </p:txBody>
@@ -2512,7 +2512,7 @@
               </a:defRPr>
             </a:pPr>
             <a:r>
-              <a:t>Проверяем остаточные копии, влияние на модель и минимальный путь к безопасному удалению.</a:t>
+              <a:t>Карта → скрытые пути → минимальные действия → проверка во времени → сертификат.</a:t>
             </a:r>
           </a:p>
         </p:txBody>
@@ -2759,7 +2759,7 @@
               </a:defRPr>
             </a:pPr>
             <a:r>
-              <a:t>09  GhostGraph-T result</a:t>
+              <a:t>09  Этап 2: результат</a:t>
             </a:r>
           </a:p>
         </p:txBody>
@@ -2800,7 +2800,7 @@
               </a:defRPr>
             </a:pPr>
             <a:r>
-              <a:t>Достаточное действие — даже когда точный граф неразличим</a:t>
+              <a:t>EraSeMap находит действие без знания точного графа</a:t>
             </a:r>
           </a:p>
         </p:txBody>
@@ -3032,7 +3032,7 @@
               </a:defRPr>
             </a:pPr>
             <a:r>
-              <a:t>1.28 probes vs 8.0 exhaustive · policies tie · external: NOT_COLLECTED</a:t>
+              <a:t>EraSeMap: 1.28 probes vs 8.0 exhaustive · adaptive tie · external: NOT_COLLECTED</a:t>
             </a:r>
           </a:p>
         </p:txBody>
@@ -3090,7 +3090,7 @@
         </p:xfrm>
         <a:graphic xmlns:a="http://schemas.openxmlformats.org/drawingml/2006/main">
           <a:graphicData uri="http://schemas.openxmlformats.org/drawingml/2006/chart">
-            <c:chart xmlns:r="http://schemas.openxmlformats.org/officeDocument/2006/relationships" xmlns:c="http://schemas.openxmlformats.org/drawingml/2006/chart" r:id="Rdabf555e6d4247ba"/>
+            <c:chart xmlns:r="http://schemas.openxmlformats.org/officeDocument/2006/relationships" xmlns:c="http://schemas.openxmlformats.org/drawingml/2006/chart" r:id="R867d4a418f084340"/>
           </a:graphicData>
         </a:graphic>
       </p:graphicFrame>
@@ -3159,7 +3159,7 @@
               </a:defRPr>
             </a:pPr>
             <a:r>
-              <a:t>10  Новизна без преувеличения</a:t>
+              <a:t>10  Новизна одного алгоритма</a:t>
             </a:r>
           </a:p>
         </p:txBody>
@@ -3200,7 +3200,7 @@
               </a:defRPr>
             </a:pPr>
             <a:r>
-              <a:t>Новый вклад — active discovery + fail-closed repair</a:t>
+              <a:t>Новый вклад — полный fail-closed путь от discovery до сертификата</a:t>
             </a:r>
           </a:p>
         </p:txBody>
@@ -3408,7 +3408,7 @@
               </a:defRPr>
             </a:pPr>
             <a:r>
-              <a:t>Узкий вклад</a:t>
+              <a:t>Вклад EraSeMap</a:t>
             </a:r>
           </a:p>
         </p:txBody>
@@ -3449,7 +3449,7 @@
               </a:defRPr>
             </a:pPr>
             <a:r>
-              <a:t>Subject interventions → exact version-space update → OUT / UNVERIFIED → path class → exact control + replay.</a:t>
+              <a:t>Карта → безопасные subject-пробы → минимальный план → temporal replay → сертификат или честный отказ.</a:t>
             </a:r>
           </a:p>
         </p:txBody>
@@ -3575,7 +3575,7 @@
               </a:defRPr>
             </a:pPr>
             <a:r>
-              <a:t>Greedy baseline tied at 7 probes: novelty is the auditable fail-closed composition, not universal query optimality.</a:t>
+              <a:t>Сильный adaptive baseline разделил первое место: новизна в проверяемой композиции, не в универсальной query optimality.</a:t>
             </a:r>
           </a:p>
         </p:txBody>
@@ -4561,7 +4561,7 @@
               </a:defRPr>
             </a:pPr>
             <a:r>
-              <a:t>Formal + measured systems + GhostGraph live + jury demo</a:t>
+              <a:t>Formal + measured systems + active discovery + jury demo</a:t>
             </a:r>
           </a:p>
         </p:txBody>
@@ -4643,7 +4643,7 @@
               </a:defRPr>
             </a:pPr>
             <a:r>
-              <a:t>Blind v2 evaluator-authored challenge; algorithm frozen</a:t>
+              <a:t>Независимый hidden challenge; EraSeMap frozen</a:t>
             </a:r>
           </a:p>
         </p:txBody>
@@ -4725,7 +4725,7 @@
               </a:defRPr>
             </a:pPr>
             <a:r>
-              <a:t>Доказать COMPLETE на чужих скрытых системах — или честно показать failure.</a:t>
+              <a:t>Доказать COMPLETE на чужих системах — или честно показать failure.</a:t>
             </a:r>
           </a:p>
         </p:txBody>
@@ -6451,7 +6451,7 @@
               </a:defRPr>
             </a:pPr>
             <a:r>
-              <a:t>Один fail-closed контракт</a:t>
+              <a:t>Один алгоритм EraSeMap</a:t>
             </a:r>
           </a:p>
         </p:txBody>
@@ -6554,7 +6554,7 @@
         <p:spPr>
           <a:xfrm xmlns:a="http://schemas.openxmlformats.org/drawingml/2006/main">
             <a:off x="657225" y="2266950"/>
-            <a:ext cx="476250" cy="552450"/>
+            <a:ext cx="857250" cy="552450"/>
           </a:xfrm>
           <a:prstGeom xmlns:a="http://schemas.openxmlformats.org/drawingml/2006/main" prst="rect">
             <a:avLst/>
@@ -6573,7 +6573,7 @@
               </a:defRPr>
             </a:pPr>
             <a:r>
-              <a:t>1</a:t>
+              <a:t>1–2</a:t>
             </a:r>
           </a:p>
         </p:txBody>
@@ -6614,7 +6614,7 @@
               </a:defRPr>
             </a:pPr>
             <a:r>
-              <a:t>PCUG</a:t>
+              <a:t>Карта + обнаружение</a:t>
             </a:r>
           </a:p>
         </p:txBody>
@@ -6655,7 +6655,7 @@
               </a:defRPr>
             </a:pPr>
             <a:r>
-              <a:t>Физические копии + request-scoped model influence + обязательные verifier-каналы.</a:t>
+              <a:t>Копии, производные, model influence и безопасные пробы скрытых recovery paths.</a:t>
             </a:r>
           </a:p>
         </p:txBody>
@@ -6696,7 +6696,7 @@
               </a:defRPr>
             </a:pPr>
             <a:r>
-              <a:t>2</a:t>
+              <a:t>3</a:t>
             </a:r>
           </a:p>
         </p:txBody>
@@ -6737,7 +6737,7 @@
               </a:defRPr>
             </a:pPr>
             <a:r>
-              <a:t>Proof bundle</a:t>
+              <a:t>Минимизация + replay</a:t>
             </a:r>
           </a:p>
         </p:txBody>
@@ -6778,7 +6778,7 @@
               </a:defRPr>
             </a:pPr>
             <a:r>
-              <a:t>Commitments, raw evidence, replay, signature и independently recomputed verdict.</a:t>
+              <a:t>Точный least-cost план закрывает представленные пути и повторно проверяется.</a:t>
             </a:r>
           </a:p>
         </p:txBody>
@@ -6800,7 +6800,7 @@
         <p:spPr>
           <a:xfrm xmlns:a="http://schemas.openxmlformats.org/drawingml/2006/main">
             <a:off x="8658225" y="2266950"/>
-            <a:ext cx="476250" cy="552450"/>
+            <a:ext cx="857250" cy="552450"/>
           </a:xfrm>
           <a:prstGeom xmlns:a="http://schemas.openxmlformats.org/drawingml/2006/main" prst="rect">
             <a:avLst/>
@@ -6819,7 +6819,7 @@
               </a:defRPr>
             </a:pPr>
             <a:r>
-              <a:t>3</a:t>
+              <a:t>4–5</a:t>
             </a:r>
           </a:p>
         </p:txBody>
@@ -6860,7 +6860,7 @@
               </a:defRPr>
             </a:pPr>
             <a:r>
-              <a:t>Exact CDC</a:t>
+              <a:t>Проверка + сертификат</a:t>
             </a:r>
           </a:p>
         </p:txBody>
@@ -6901,7 +6901,7 @@
               </a:defRPr>
             </a:pPr>
             <a:r>
-              <a:t>Минимальная по стоимости разрешённая remediation, закрывающая представленные пути.</a:t>
+              <a:t>Будущие сценарии не возвращают данные; иначе INCOMPLETE или UNVERIFIED.</a:t>
             </a:r>
           </a:p>
         </p:txBody>
@@ -6942,7 +6942,7 @@
               </a:defRPr>
             </a:pPr>
             <a:r>
-              <a:t>Не отдельный unlearning algorithm — системный слой принятия и проверки решения.</a:t>
+              <a:t>Пять этапов • один вход • один fail-closed вердикт • внутренние названия только для науки.</a:t>
             </a:r>
           </a:p>
         </p:txBody>
@@ -7053,7 +7053,7 @@
               </a:defRPr>
             </a:pPr>
             <a:r>
-              <a:t>04  Зачем PCUG</a:t>
+              <a:t>04  Сравнение безопасности</a:t>
             </a:r>
           </a:p>
         </p:txBody>
@@ -7094,7 +7094,7 @@
               </a:defRPr>
             </a:pPr>
             <a:r>
-              <a:t>Node-state audit пропускает взаимодействия</a:t>
+              <a:t>EraSeMap против обычного typed audit</a:t>
             </a:r>
           </a:p>
         </p:txBody>
@@ -7203,7 +7203,7 @@
               </a:defRPr>
             </a:pPr>
             <a:r>
-              <a:t>ложных COMPLETE у PCUG</a:t>
+              <a:t>ложных COMPLETE у EraSeMap</a:t>
             </a:r>
           </a:p>
         </p:txBody>
@@ -7384,7 +7384,7 @@
         </p:xfrm>
         <a:graphic xmlns:a="http://schemas.openxmlformats.org/drawingml/2006/main">
           <a:graphicData uri="http://schemas.openxmlformats.org/drawingml/2006/chart">
-            <c:chart xmlns:r="http://schemas.openxmlformats.org/officeDocument/2006/relationships" xmlns:c="http://schemas.openxmlformats.org/drawingml/2006/chart" r:id="Refc5340788304a13"/>
+            <c:chart xmlns:r="http://schemas.openxmlformats.org/officeDocument/2006/relationships" xmlns:c="http://schemas.openxmlformats.org/drawingml/2006/chart" r:id="R834571a3e6ff46fa"/>
           </a:graphicData>
         </a:graphic>
       </p:graphicFrame>
@@ -7535,7 +7535,7 @@
               </a:defRPr>
             </a:pPr>
             <a:r>
-              <a:t>production exact CDC = exhaustive oracle</a:t>
+              <a:t>EraSeMap minimum-action stage = exhaustive oracle</a:t>
             </a:r>
           </a:p>
         </p:txBody>
@@ -8014,7 +8014,7 @@
               </a:defRPr>
             </a:pPr>
             <a:r>
-              <a:t>06  Real-process experiment</a:t>
+              <a:t>06  Сравнение эффективности</a:t>
             </a:r>
           </a:p>
         </p:txBody>
@@ -8055,7 +8055,7 @@
               </a:defRPr>
             </a:pPr>
             <a:r>
-              <a:t>Меньше работы — тот же verified COMPLETE</a:t>
+              <a:t>EraSeMap vs rebuild-all: тот же verified COMPLETE</a:t>
             </a:r>
           </a:p>
         </p:txBody>
@@ -8345,7 +8345,7 @@
         </p:xfrm>
         <a:graphic xmlns:a="http://schemas.openxmlformats.org/drawingml/2006/main">
           <a:graphicData uri="http://schemas.openxmlformats.org/drawingml/2006/chart">
-            <c:chart xmlns:r="http://schemas.openxmlformats.org/officeDocument/2006/relationships" xmlns:c="http://schemas.openxmlformats.org/drawingml/2006/chart" r:id="Rd9218f53908b4c80"/>
+            <c:chart xmlns:r="http://schemas.openxmlformats.org/officeDocument/2006/relationships" xmlns:c="http://schemas.openxmlformats.org/drawingml/2006/chart" r:id="Rf9e31c1edeaa4ee8"/>
           </a:graphicData>
         </a:graphic>
       </p:graphicFrame>
@@ -8414,7 +8414,7 @@
               </a:defRPr>
             </a:pPr>
             <a:r>
-              <a:t>07  Model layer</a:t>
+              <a:t>07  Внутренний model-канал</a:t>
             </a:r>
           </a:p>
         </p:txBody>
@@ -8455,7 +8455,7 @@
               </a:defRPr>
             </a:pPr>
             <a:r>
-              <a:t>MUFAC FAIL → sequential PASS</a:t>
+              <a:t>Model unlearning — только один канал EraSeMap</a:t>
             </a:r>
           </a:p>
         </p:txBody>
@@ -8523,7 +8523,7 @@
               </a:defRPr>
             </a:pPr>
             <a:r>
-              <a:t>MUFAC v3</a:t>
+              <a:t>Approximate candidate</a:t>
             </a:r>
           </a:p>
         </p:txBody>
@@ -8646,7 +8646,7 @@
               </a:defRPr>
             </a:pPr>
             <a:r>
-              <a:t>Sequential v1</a:t>
+              <a:t>Sequential branch</a:t>
             </a:r>
           </a:p>
         </p:txBody>
@@ -8783,7 +8783,7 @@
           <p:nvPr/>
         </p:nvPicPr>
         <p:blipFill>
-          <a:blip xmlns:r="http://schemas.openxmlformats.org/officeDocument/2006/relationships" xmlns:a="http://schemas.openxmlformats.org/drawingml/2006/main" r:embed="R3ba847c6e3ef42a4"/>
+          <a:blip xmlns:r="http://schemas.openxmlformats.org/officeDocument/2006/relationships" xmlns:a="http://schemas.openxmlformats.org/drawingml/2006/main" r:embed="R9f615e93df004353"/>
           <a:stretch xmlns:a="http://schemas.openxmlformats.org/drawingml/2006/main"/>
         </p:blipFill>
         <p:spPr>
@@ -8861,7 +8861,7 @@
               </a:defRPr>
             </a:pPr>
             <a:r>
-              <a:t>08  GhostGraph</a:t>
+              <a:t>08  Этап 2: обнаружение</a:t>
             </a:r>
           </a:p>
         </p:txBody>
@@ -8902,7 +8902,7 @@
               </a:defRPr>
             </a:pPr>
             <a:r>
-              <a:t>Ищем неизвестный путь — не верим карте</a:t>
+              <a:t>Активно ищем скрытый путь — не верим карте</a:t>
             </a:r>
           </a:p>
         </p:txBody>
@@ -9065,7 +9065,7 @@
               </a:defRPr>
             </a:pPr>
             <a:r>
-              <a:t>Version space</a:t>
+              <a:t>Гипотезы</a:t>
             </a:r>
           </a:p>
         </p:txBody>
@@ -9106,7 +9106,7 @@
               </a:defRPr>
             </a:pPr>
             <a:r>
-              <a:t>Frozen-каталог возможных deletion-regeneration графов и полный evidence contract.</a:t>
+              <a:t>Зафиксированный каталог возможных recovery paths и полный evidence contract.</a:t>
             </a:r>
           </a:p>
         </p:txBody>
@@ -9188,7 +9188,7 @@
               </a:defRPr>
             </a:pPr>
             <a:r>
-              <a:t>Active probe</a:t>
+              <a:t>Безопасная проба</a:t>
             </a:r>
           </a:p>
         </p:txBody>
@@ -9229,7 +9229,7 @@
               </a:defRPr>
             </a:pPr>
             <a:r>
-              <a:t>Minimax выбирает intervention, сильнее всего сужающий оставшиеся графы.</a:t>
+              <a:t>Minimax выбирает синтетическую проверку, сильнее всего сужающую гипотезы.</a:t>
             </a:r>
           </a:p>
         </p:txBody>
@@ -9311,7 +9311,7 @@
               </a:defRPr>
             </a:pPr>
             <a:r>
-              <a:t>Fail-closed repair</a:t>
+              <a:t>Fail-closed решение</a:t>
             </a:r>
           </a:p>
         </p:txBody>
@@ -9352,7 +9352,7 @@
               </a:defRPr>
             </a:pPr>
             <a:r>
-              <a:t>Exact graph / path class, либо OUT / UNVERIFIED; затем exact control и replay.</a:t>
+              <a:t>Путь или класс действий; иначе OUT / UNVERIFIED. Затем control и replay.</a:t>
             </a:r>
           </a:p>
         </p:txBody>
@@ -9393,7 +9393,7 @@
               </a:defRPr>
             </a:pPr>
             <a:r>
-              <a:t>Finite catalogue · synthetic subjects · без claim об arbitrary hidden infrastructure.</a:t>
+              <a:t>Ограниченный каталог · synthetic subjects · не arbitrary hidden infrastructure.</a:t>
             </a:r>
           </a:p>
         </p:txBody>

</xml_diff>